<commit_message>
style(intro): update introduction paragraph with proper academic formatting
</commit_message>
<xml_diff>
--- a/paper/SafeAdapt_Google_Slides.pptx
+++ b/paper/SafeAdapt_Google_Slides.pptx
@@ -4,27 +4,30 @@
   <p:sldMasterIdLst>
     <p:sldMasterId id="2147483648" r:id="rId1"/>
   </p:sldMasterIdLst>
+  <p:notesMasterIdLst>
+    <p:notesMasterId r:id="rId20"/>
+  </p:notesMasterIdLst>
   <p:sldIdLst>
-    <p:sldId id="256" r:id="rId7"/>
-    <p:sldId id="257" r:id="rId9"/>
-    <p:sldId id="258" r:id="rId10"/>
-    <p:sldId id="259" r:id="rId11"/>
-    <p:sldId id="260" r:id="rId12"/>
-    <p:sldId id="261" r:id="rId13"/>
-    <p:sldId id="262" r:id="rId14"/>
-    <p:sldId id="263" r:id="rId15"/>
-    <p:sldId id="264" r:id="rId16"/>
-    <p:sldId id="265" r:id="rId17"/>
-    <p:sldId id="266" r:id="rId18"/>
-    <p:sldId id="267" r:id="rId19"/>
-    <p:sldId id="268" r:id="rId20"/>
-    <p:sldId id="269" r:id="rId21"/>
-    <p:sldId id="270" r:id="rId22"/>
-    <p:sldId id="271" r:id="rId23"/>
-    <p:sldId id="272" r:id="rId24"/>
-    <p:sldId id="273" r:id="rId25"/>
+    <p:sldId id="256" r:id="rId2"/>
+    <p:sldId id="257" r:id="rId3"/>
+    <p:sldId id="258" r:id="rId4"/>
+    <p:sldId id="259" r:id="rId5"/>
+    <p:sldId id="260" r:id="rId6"/>
+    <p:sldId id="261" r:id="rId7"/>
+    <p:sldId id="262" r:id="rId8"/>
+    <p:sldId id="263" r:id="rId9"/>
+    <p:sldId id="264" r:id="rId10"/>
+    <p:sldId id="265" r:id="rId11"/>
+    <p:sldId id="266" r:id="rId12"/>
+    <p:sldId id="267" r:id="rId13"/>
+    <p:sldId id="268" r:id="rId14"/>
+    <p:sldId id="269" r:id="rId15"/>
+    <p:sldId id="270" r:id="rId16"/>
+    <p:sldId id="271" r:id="rId17"/>
+    <p:sldId id="272" r:id="rId18"/>
+    <p:sldId id="273" r:id="rId19"/>
   </p:sldIdLst>
-  <p:sldSz cx="12191695" cy="6858000" type="screen4x3"/>
+  <p:sldSz cx="12192000" cy="6858000"/>
   <p:notesSz cx="6858000" cy="9144000"/>
   <p:defaultTextStyle>
     <a:defPPr>
@@ -121,11 +124,132 @@
       </a:defRPr>
     </a:lvl9pPr>
   </p:defaultTextStyle>
+  <p:extLst>
+    <p:ext uri="{EFAFB233-063F-42B5-8137-9DF3F51BA10A}">
+      <p15:sldGuideLst xmlns:p15="http://schemas.microsoft.com/office/powerpoint/2012/main">
+        <p15:guide id="1" orient="horz" pos="2160">
+          <p15:clr>
+            <a:srgbClr val="A4A3A4"/>
+          </p15:clr>
+        </p15:guide>
+        <p15:guide id="2" pos="2880">
+          <p15:clr>
+            <a:srgbClr val="A4A3A4"/>
+          </p15:clr>
+        </p15:guide>
+      </p15:sldGuideLst>
+    </p:ext>
+  </p:extLst>
 </p:presentation>
 </file>
 
+<file path=ppt/changesInfos/changesInfo1.xml><?xml version="1.0" encoding="utf-8"?>
+<pc:chgInfo xmlns:a="http://schemas.openxmlformats.org/drawingml/2006/main" xmlns:r="http://schemas.openxmlformats.org/officeDocument/2006/relationships" xmlns:ac="http://schemas.microsoft.com/office/drawing/2013/main/command" xmlns:pc="http://schemas.microsoft.com/office/powerpoint/2013/main/command">
+  <pc:docChgLst>
+    <pc:chgData name="AVINASH REDDY" userId="3713b3410679553c" providerId="LiveId" clId="{F2F15F19-5B48-4202-9555-3CF439342418}"/>
+    <pc:docChg chg="undo custSel modSld">
+      <pc:chgData name="AVINASH REDDY" userId="3713b3410679553c" providerId="LiveId" clId="{F2F15F19-5B48-4202-9555-3CF439342418}" dt="2026-10-27T06:50:44.021" v="14" actId="20577"/>
+      <pc:docMkLst>
+        <pc:docMk/>
+      </pc:docMkLst>
+      <pc:sldChg chg="modSp mod modNotesTx">
+        <pc:chgData name="AVINASH REDDY" userId="3713b3410679553c" providerId="LiveId" clId="{F2F15F19-5B48-4202-9555-3CF439342418}" dt="2026-10-27T06:50:44.021" v="14" actId="20577"/>
+        <pc:sldMkLst>
+          <pc:docMk/>
+          <pc:sldMk cId="0" sldId="257"/>
+        </pc:sldMkLst>
+        <pc:spChg chg="mod">
+          <ac:chgData name="AVINASH REDDY" userId="3713b3410679553c" providerId="LiveId" clId="{F2F15F19-5B48-4202-9555-3CF439342418}" dt="2026-10-27T06:50:44.021" v="14" actId="20577"/>
+          <ac:spMkLst>
+            <pc:docMk/>
+            <pc:sldMk cId="0" sldId="257"/>
+            <ac:spMk id="7" creationId="{00000000-0000-0000-0000-000000000000}"/>
+          </ac:spMkLst>
+        </pc:spChg>
+      </pc:sldChg>
+      <pc:sldChg chg="modSp mod">
+        <pc:chgData name="AVINASH REDDY" userId="3713b3410679553c" providerId="LiveId" clId="{F2F15F19-5B48-4202-9555-3CF439342418}" dt="2026-10-27T06:50:29.933" v="12" actId="1076"/>
+        <pc:sldMkLst>
+          <pc:docMk/>
+          <pc:sldMk cId="0" sldId="258"/>
+        </pc:sldMkLst>
+        <pc:spChg chg="mod">
+          <ac:chgData name="AVINASH REDDY" userId="3713b3410679553c" providerId="LiveId" clId="{F2F15F19-5B48-4202-9555-3CF439342418}" dt="2026-10-27T06:50:21.343" v="9" actId="1076"/>
+          <ac:spMkLst>
+            <pc:docMk/>
+            <pc:sldMk cId="0" sldId="258"/>
+            <ac:spMk id="5" creationId="{00000000-0000-0000-0000-000000000000}"/>
+          </ac:spMkLst>
+        </pc:spChg>
+        <pc:picChg chg="mod">
+          <ac:chgData name="AVINASH REDDY" userId="3713b3410679553c" providerId="LiveId" clId="{F2F15F19-5B48-4202-9555-3CF439342418}" dt="2026-10-27T06:50:29.933" v="12" actId="1076"/>
+          <ac:picMkLst>
+            <pc:docMk/>
+            <pc:sldMk cId="0" sldId="258"/>
+            <ac:picMk id="6" creationId="{00000000-0000-0000-0000-000000000000}"/>
+          </ac:picMkLst>
+        </pc:picChg>
+      </pc:sldChg>
+      <pc:sldChg chg="modSp mod">
+        <pc:chgData name="AVINASH REDDY" userId="3713b3410679553c" providerId="LiveId" clId="{F2F15F19-5B48-4202-9555-3CF439342418}" dt="2026-10-27T06:50:07.294" v="8" actId="1076"/>
+        <pc:sldMkLst>
+          <pc:docMk/>
+          <pc:sldMk cId="0" sldId="261"/>
+        </pc:sldMkLst>
+        <pc:picChg chg="mod">
+          <ac:chgData name="AVINASH REDDY" userId="3713b3410679553c" providerId="LiveId" clId="{F2F15F19-5B48-4202-9555-3CF439342418}" dt="2026-10-27T06:50:07.294" v="8" actId="1076"/>
+          <ac:picMkLst>
+            <pc:docMk/>
+            <pc:sldMk cId="0" sldId="261"/>
+            <ac:picMk id="5" creationId="{00000000-0000-0000-0000-000000000000}"/>
+          </ac:picMkLst>
+        </pc:picChg>
+      </pc:sldChg>
+      <pc:sldChg chg="modSp mod">
+        <pc:chgData name="AVINASH REDDY" userId="3713b3410679553c" providerId="LiveId" clId="{F2F15F19-5B48-4202-9555-3CF439342418}" dt="2026-10-27T06:49:39.235" v="5" actId="14100"/>
+        <pc:sldMkLst>
+          <pc:docMk/>
+          <pc:sldMk cId="0" sldId="262"/>
+        </pc:sldMkLst>
+        <pc:spChg chg="mod">
+          <ac:chgData name="AVINASH REDDY" userId="3713b3410679553c" providerId="LiveId" clId="{F2F15F19-5B48-4202-9555-3CF439342418}" dt="2026-10-27T06:49:34.178" v="3" actId="1076"/>
+          <ac:spMkLst>
+            <pc:docMk/>
+            <pc:sldMk cId="0" sldId="262"/>
+            <ac:spMk id="5" creationId="{00000000-0000-0000-0000-000000000000}"/>
+          </ac:spMkLst>
+        </pc:spChg>
+        <pc:picChg chg="mod">
+          <ac:chgData name="AVINASH REDDY" userId="3713b3410679553c" providerId="LiveId" clId="{F2F15F19-5B48-4202-9555-3CF439342418}" dt="2026-10-27T06:49:39.235" v="5" actId="14100"/>
+          <ac:picMkLst>
+            <pc:docMk/>
+            <pc:sldMk cId="0" sldId="262"/>
+            <ac:picMk id="6" creationId="{00000000-0000-0000-0000-000000000000}"/>
+          </ac:picMkLst>
+        </pc:picChg>
+      </pc:sldChg>
+      <pc:sldChg chg="modSp mod">
+        <pc:chgData name="AVINASH REDDY" userId="3713b3410679553c" providerId="LiveId" clId="{F2F15F19-5B48-4202-9555-3CF439342418}" dt="2026-10-27T06:49:49.020" v="6" actId="1076"/>
+        <pc:sldMkLst>
+          <pc:docMk/>
+          <pc:sldMk cId="0" sldId="263"/>
+        </pc:sldMkLst>
+        <pc:spChg chg="mod">
+          <ac:chgData name="AVINASH REDDY" userId="3713b3410679553c" providerId="LiveId" clId="{F2F15F19-5B48-4202-9555-3CF439342418}" dt="2026-10-27T06:49:49.020" v="6" actId="1076"/>
+          <ac:spMkLst>
+            <pc:docMk/>
+            <pc:sldMk cId="0" sldId="263"/>
+            <ac:spMk id="6" creationId="{00000000-0000-0000-0000-000000000000}"/>
+          </ac:spMkLst>
+        </pc:spChg>
+      </pc:sldChg>
+    </pc:docChg>
+  </pc:docChgLst>
+</pc:chgInfo>
+</file>
+
 <file path=ppt/notesMasters/notesMaster1.xml><?xml version="1.0" encoding="utf-8"?>
-<p:notesMaster xmlns:a="http://schemas.openxmlformats.org/drawingml/2006/main" xmlns:p="http://schemas.openxmlformats.org/presentationml/2006/main" xmlns:r="http://schemas.openxmlformats.org/officeDocument/2006/relationships">
+<p:notesMaster xmlns:a="http://schemas.openxmlformats.org/drawingml/2006/main" xmlns:r="http://schemas.openxmlformats.org/officeDocument/2006/relationships" xmlns:p="http://schemas.openxmlformats.org/presentationml/2006/main">
   <p:cSld>
     <p:bg>
       <p:bgRef idx="1001">
@@ -146,241 +270,16 @@
           <a:chExt cx="0" cy="0"/>
         </a:xfrm>
       </p:grpSpPr>
-      <p:sp>
-        <p:nvSpPr>
-          <p:cNvPr id="2" name="Header Placeholder 1"/>
-          <p:cNvSpPr>
-            <a:spLocks noGrp="1"/>
-          </p:cNvSpPr>
-          <p:nvPr>
-            <p:ph type="hdr" sz="quarter"/>
-          </p:nvPr>
-        </p:nvSpPr>
-        <p:spPr>
-          <a:xfrm>
-            <a:off x="0" y="0"/>
-            <a:ext cx="2971800" cy="457200"/>
-          </a:xfrm>
-          <a:prstGeom prst="rect">
-            <a:avLst/>
-          </a:prstGeom>
-        </p:spPr>
-        <p:txBody>
-          <a:bodyPr vert="horz" lIns="91440" tIns="45720" rIns="91440" bIns="45720" rtlCol="0"/>
-          <a:lstStyle>
-            <a:lvl1pPr algn="l">
-              <a:defRPr sz="1200"/>
-            </a:lvl1pPr>
-          </a:lstStyle>
-          <a:p>
-            <a:endParaRPr lang="en-US"/>
-          </a:p>
-        </p:txBody>
-      </p:sp>
-      <p:sp>
-        <p:nvSpPr>
-          <p:cNvPr id="3" name="Date Placeholder 2"/>
-          <p:cNvSpPr>
-            <a:spLocks noGrp="1"/>
-          </p:cNvSpPr>
-          <p:nvPr>
-            <p:ph type="dt" idx="1"/>
-          </p:nvPr>
-        </p:nvSpPr>
-        <p:spPr>
-          <a:xfrm>
-            <a:off x="3884613" y="0"/>
-            <a:ext cx="2971800" cy="457200"/>
-          </a:xfrm>
-          <a:prstGeom prst="rect">
-            <a:avLst/>
-          </a:prstGeom>
-        </p:spPr>
-        <p:txBody>
-          <a:bodyPr vert="horz" lIns="91440" tIns="45720" rIns="91440" bIns="45720" rtlCol="0"/>
-          <a:lstStyle>
-            <a:lvl1pPr algn="r">
-              <a:defRPr sz="1200"/>
-            </a:lvl1pPr>
-          </a:lstStyle>
-          <a:p>
-            <a:fld id="{0F89C1C7-3DCD-1040-A9CF-14679D8B5DDD}" type="datetimeFigureOut">
-              <a:rPr lang="en-US" smtClean="0"/>
-              <a:t>10/17/16</a:t>
-            </a:fld>
-            <a:endParaRPr lang="en-US"/>
-          </a:p>
-        </p:txBody>
-      </p:sp>
-      <p:sp>
-        <p:nvSpPr>
-          <p:cNvPr id="4" name="Slide Image Placeholder 3"/>
-          <p:cNvSpPr>
-            <a:spLocks noGrp="1" noRot="1" noChangeAspect="1"/>
-          </p:cNvSpPr>
-          <p:nvPr>
-            <p:ph type="sldImg" idx="2"/>
-          </p:nvPr>
-        </p:nvSpPr>
-        <p:spPr>
-          <a:xfrm>
-            <a:off x="1143000" y="685800"/>
-            <a:ext cx="4572000" cy="3429000"/>
-          </a:xfrm>
-          <a:prstGeom prst="rect">
-            <a:avLst/>
-          </a:prstGeom>
-          <a:noFill/>
-          <a:ln w="12700">
-            <a:solidFill>
-              <a:prstClr val="black"/>
-            </a:solidFill>
-          </a:ln>
-        </p:spPr>
-        <p:txBody>
-          <a:bodyPr vert="horz" lIns="91440" tIns="45720" rIns="91440" bIns="45720" rtlCol="0" anchor="ctr"/>
-          <a:lstStyle/>
-          <a:p>
-            <a:endParaRPr lang="en-US"/>
-          </a:p>
-        </p:txBody>
-      </p:sp>
-      <p:sp>
-        <p:nvSpPr>
-          <p:cNvPr id="5" name="Notes Placeholder 4"/>
-          <p:cNvSpPr>
-            <a:spLocks noGrp="1"/>
-          </p:cNvSpPr>
-          <p:nvPr>
-            <p:ph type="body" sz="quarter" idx="3"/>
-          </p:nvPr>
-        </p:nvSpPr>
-        <p:spPr>
-          <a:xfrm>
-            <a:off x="685800" y="4343400"/>
-            <a:ext cx="5486400" cy="4114800"/>
-          </a:xfrm>
-          <a:prstGeom prst="rect">
-            <a:avLst/>
-          </a:prstGeom>
-        </p:spPr>
-        <p:txBody>
-          <a:bodyPr vert="horz" lIns="91440" tIns="45720" rIns="91440" bIns="45720" rtlCol="0"/>
-          <a:lstStyle/>
-          <a:p>
-            <a:pPr lvl="0"/>
-            <a:r>
-              <a:rPr lang="en-US" smtClean="0"/>
-              <a:t>Click to edit Master text styles</a:t>
-            </a:r>
-          </a:p>
-          <a:p>
-            <a:pPr lvl="1"/>
-            <a:r>
-              <a:rPr lang="en-US" smtClean="0"/>
-              <a:t>Second level</a:t>
-            </a:r>
-          </a:p>
-          <a:p>
-            <a:pPr lvl="2"/>
-            <a:r>
-              <a:rPr lang="en-US" smtClean="0"/>
-              <a:t>Third level</a:t>
-            </a:r>
-          </a:p>
-          <a:p>
-            <a:pPr lvl="3"/>
-            <a:r>
-              <a:rPr lang="en-US" smtClean="0"/>
-              <a:t>Fourth level</a:t>
-            </a:r>
-          </a:p>
-          <a:p>
-            <a:pPr lvl="4"/>
-            <a:r>
-              <a:rPr lang="en-US" smtClean="0"/>
-              <a:t>Fifth level</a:t>
-            </a:r>
-            <a:endParaRPr lang="en-US"/>
-          </a:p>
-        </p:txBody>
-      </p:sp>
-      <p:sp>
-        <p:nvSpPr>
-          <p:cNvPr id="6" name="Footer Placeholder 5"/>
-          <p:cNvSpPr>
-            <a:spLocks noGrp="1"/>
-          </p:cNvSpPr>
-          <p:nvPr>
-            <p:ph type="ftr" sz="quarter" idx="4"/>
-          </p:nvPr>
-        </p:nvSpPr>
-        <p:spPr>
-          <a:xfrm>
-            <a:off x="0" y="8685213"/>
-            <a:ext cx="2971800" cy="457200"/>
-          </a:xfrm>
-          <a:prstGeom prst="rect">
-            <a:avLst/>
-          </a:prstGeom>
-        </p:spPr>
-        <p:txBody>
-          <a:bodyPr vert="horz" lIns="91440" tIns="45720" rIns="91440" bIns="45720" rtlCol="0" anchor="b"/>
-          <a:lstStyle>
-            <a:lvl1pPr algn="l">
-              <a:defRPr sz="1200"/>
-            </a:lvl1pPr>
-          </a:lstStyle>
-          <a:p>
-            <a:endParaRPr lang="en-US"/>
-          </a:p>
-        </p:txBody>
-      </p:sp>
-      <p:sp>
-        <p:nvSpPr>
-          <p:cNvPr id="7" name="Slide Number Placeholder 6"/>
-          <p:cNvSpPr>
-            <a:spLocks noGrp="1"/>
-          </p:cNvSpPr>
-          <p:nvPr>
-            <p:ph type="sldNum" sz="quarter" idx="5"/>
-          </p:nvPr>
-        </p:nvSpPr>
-        <p:spPr>
-          <a:xfrm>
-            <a:off x="3884613" y="8685213"/>
-            <a:ext cx="2971800" cy="457200"/>
-          </a:xfrm>
-          <a:prstGeom prst="rect">
-            <a:avLst/>
-          </a:prstGeom>
-        </p:spPr>
-        <p:txBody>
-          <a:bodyPr vert="horz" lIns="91440" tIns="45720" rIns="91440" bIns="45720" rtlCol="0" anchor="b"/>
-          <a:lstStyle>
-            <a:lvl1pPr algn="r">
-              <a:defRPr sz="1200"/>
-            </a:lvl1pPr>
-          </a:lstStyle>
-          <a:p>
-            <a:fld id="{BB5E49A5-4136-284D-997B-48E1D791AD67}" type="slidenum">
-              <a:rPr lang="en-US" smtClean="0"/>
-              <a:t>‹#›</a:t>
-            </a:fld>
-            <a:endParaRPr lang="en-US"/>
-          </a:p>
-        </p:txBody>
-      </p:sp>
     </p:spTree>
     <p:extLst>
       <p:ext uri="{BB962C8B-B14F-4D97-AF65-F5344CB8AC3E}">
-        <p14:creationId xmlns:p14="http://schemas.microsoft.com/office/powerpoint/2010/main" val="2623252185"/>
+        <p14:creationId xmlns:p14="http://schemas.microsoft.com/office/powerpoint/2010/main" val="2352067798"/>
       </p:ext>
     </p:extLst>
   </p:cSld>
   <p:clrMap bg1="lt1" tx1="dk1" bg2="lt2" tx2="dk2" accent1="accent1" accent2="accent2" accent3="accent3" accent4="accent4" accent5="accent5" accent6="accent6" hlink="hlink" folHlink="folHlink"/>
   <p:notesStyle>
-    <a:lvl1pPr marL="0" algn="l" defTabSz="457200" rtl="0" eaLnBrk="1" latinLnBrk="0" hangingPunct="1">
+    <a:lvl1pPr marL="0" algn="l" defTabSz="914400" rtl="0" eaLnBrk="1" latinLnBrk="0" hangingPunct="1">
       <a:defRPr sz="1200" kern="1200">
         <a:solidFill>
           <a:schemeClr val="tx1"/>
@@ -390,7 +289,7 @@
         <a:cs typeface="+mn-cs"/>
       </a:defRPr>
     </a:lvl1pPr>
-    <a:lvl2pPr marL="457200" algn="l" defTabSz="457200" rtl="0" eaLnBrk="1" latinLnBrk="0" hangingPunct="1">
+    <a:lvl2pPr marL="457200" algn="l" defTabSz="914400" rtl="0" eaLnBrk="1" latinLnBrk="0" hangingPunct="1">
       <a:defRPr sz="1200" kern="1200">
         <a:solidFill>
           <a:schemeClr val="tx1"/>
@@ -400,7 +299,7 @@
         <a:cs typeface="+mn-cs"/>
       </a:defRPr>
     </a:lvl2pPr>
-    <a:lvl3pPr marL="914400" algn="l" defTabSz="457200" rtl="0" eaLnBrk="1" latinLnBrk="0" hangingPunct="1">
+    <a:lvl3pPr marL="914400" algn="l" defTabSz="914400" rtl="0" eaLnBrk="1" latinLnBrk="0" hangingPunct="1">
       <a:defRPr sz="1200" kern="1200">
         <a:solidFill>
           <a:schemeClr val="tx1"/>
@@ -410,7 +309,7 @@
         <a:cs typeface="+mn-cs"/>
       </a:defRPr>
     </a:lvl3pPr>
-    <a:lvl4pPr marL="1371600" algn="l" defTabSz="457200" rtl="0" eaLnBrk="1" latinLnBrk="0" hangingPunct="1">
+    <a:lvl4pPr marL="1371600" algn="l" defTabSz="914400" rtl="0" eaLnBrk="1" latinLnBrk="0" hangingPunct="1">
       <a:defRPr sz="1200" kern="1200">
         <a:solidFill>
           <a:schemeClr val="tx1"/>
@@ -420,7 +319,7 @@
         <a:cs typeface="+mn-cs"/>
       </a:defRPr>
     </a:lvl4pPr>
-    <a:lvl5pPr marL="1828800" algn="l" defTabSz="457200" rtl="0" eaLnBrk="1" latinLnBrk="0" hangingPunct="1">
+    <a:lvl5pPr marL="1828800" algn="l" defTabSz="914400" rtl="0" eaLnBrk="1" latinLnBrk="0" hangingPunct="1">
       <a:defRPr sz="1200" kern="1200">
         <a:solidFill>
           <a:schemeClr val="tx1"/>
@@ -430,7 +329,7 @@
         <a:cs typeface="+mn-cs"/>
       </a:defRPr>
     </a:lvl5pPr>
-    <a:lvl6pPr marL="2286000" algn="l" defTabSz="457200" rtl="0" eaLnBrk="1" latinLnBrk="0" hangingPunct="1">
+    <a:lvl6pPr marL="2286000" algn="l" defTabSz="914400" rtl="0" eaLnBrk="1" latinLnBrk="0" hangingPunct="1">
       <a:defRPr sz="1200" kern="1200">
         <a:solidFill>
           <a:schemeClr val="tx1"/>
@@ -440,7 +339,7 @@
         <a:cs typeface="+mn-cs"/>
       </a:defRPr>
     </a:lvl6pPr>
-    <a:lvl7pPr marL="2743200" algn="l" defTabSz="457200" rtl="0" eaLnBrk="1" latinLnBrk="0" hangingPunct="1">
+    <a:lvl7pPr marL="2743200" algn="l" defTabSz="914400" rtl="0" eaLnBrk="1" latinLnBrk="0" hangingPunct="1">
       <a:defRPr sz="1200" kern="1200">
         <a:solidFill>
           <a:schemeClr val="tx1"/>
@@ -450,7 +349,7 @@
         <a:cs typeface="+mn-cs"/>
       </a:defRPr>
     </a:lvl7pPr>
-    <a:lvl8pPr marL="3200400" algn="l" defTabSz="457200" rtl="0" eaLnBrk="1" latinLnBrk="0" hangingPunct="1">
+    <a:lvl8pPr marL="3200400" algn="l" defTabSz="914400" rtl="0" eaLnBrk="1" latinLnBrk="0" hangingPunct="1">
       <a:defRPr sz="1200" kern="1200">
         <a:solidFill>
           <a:schemeClr val="tx1"/>
@@ -460,7 +359,7 @@
         <a:cs typeface="+mn-cs"/>
       </a:defRPr>
     </a:lvl8pPr>
-    <a:lvl9pPr marL="3657600" algn="l" defTabSz="457200" rtl="0" eaLnBrk="1" latinLnBrk="0" hangingPunct="1">
+    <a:lvl9pPr marL="3657600" algn="l" defTabSz="914400" rtl="0" eaLnBrk="1" latinLnBrk="0" hangingPunct="1">
       <a:defRPr sz="1200" kern="1200">
         <a:solidFill>
           <a:schemeClr val="tx1"/>
@@ -475,7 +374,7 @@
 </file>
 
 <file path=ppt/notesSlides/notesSlide1.xml><?xml version="1.0" encoding="utf-8"?>
-<p:notes xmlns:a="http://schemas.openxmlformats.org/drawingml/2006/main" xmlns:p="http://schemas.openxmlformats.org/presentationml/2006/main" xmlns:r="http://schemas.openxmlformats.org/officeDocument/2006/relationships">
+<p:notes xmlns:a="http://schemas.openxmlformats.org/drawingml/2006/main" xmlns:r="http://schemas.openxmlformats.org/officeDocument/2006/relationships" xmlns:p="http://schemas.openxmlformats.org/presentationml/2006/main">
   <p:cSld>
     <p:spTree>
       <p:nvGrpSpPr>
@@ -495,7 +394,7 @@
         <p:nvSpPr>
           <p:cNvPr id="2" name="Slide Image Placeholder 1"/>
           <p:cNvSpPr>
-            <a:spLocks noGrp="1"/>
+            <a:spLocks noGrp="1" noRot="1" noChangeAspect="1"/>
           </p:cNvSpPr>
           <p:nvPr>
             <p:ph type="sldImg" idx="2"/>
@@ -510,7 +409,7 @@
             <a:spLocks noGrp="1"/>
           </p:cNvSpPr>
           <p:nvPr>
-            <p:ph type="body" idx="3" sz="quarter"/>
+            <p:ph type="body" sz="quarter" idx="3"/>
           </p:nvPr>
         </p:nvSpPr>
         <p:spPr/>
@@ -531,7 +430,7 @@
             <a:spLocks noGrp="1"/>
           </p:cNvSpPr>
           <p:nvPr>
-            <p:ph type="sldNum" idx="5" sz="quarter"/>
+            <p:ph type="sldNum" sz="quarter" idx="5"/>
           </p:nvPr>
         </p:nvSpPr>
         <p:spPr/>
@@ -545,7 +444,7 @@
 </file>
 
 <file path=ppt/notesSlides/notesSlide10.xml><?xml version="1.0" encoding="utf-8"?>
-<p:notes xmlns:a="http://schemas.openxmlformats.org/drawingml/2006/main" xmlns:p="http://schemas.openxmlformats.org/presentationml/2006/main" xmlns:r="http://schemas.openxmlformats.org/officeDocument/2006/relationships">
+<p:notes xmlns:a="http://schemas.openxmlformats.org/drawingml/2006/main" xmlns:r="http://schemas.openxmlformats.org/officeDocument/2006/relationships" xmlns:p="http://schemas.openxmlformats.org/presentationml/2006/main">
   <p:cSld>
     <p:spTree>
       <p:nvGrpSpPr>
@@ -565,7 +464,7 @@
         <p:nvSpPr>
           <p:cNvPr id="2" name="Slide Image Placeholder 1"/>
           <p:cNvSpPr>
-            <a:spLocks noGrp="1"/>
+            <a:spLocks noGrp="1" noRot="1" noChangeAspect="1"/>
           </p:cNvSpPr>
           <p:nvPr>
             <p:ph type="sldImg" idx="2"/>
@@ -580,7 +479,7 @@
             <a:spLocks noGrp="1"/>
           </p:cNvSpPr>
           <p:nvPr>
-            <p:ph type="body" idx="3" sz="quarter"/>
+            <p:ph type="body" sz="quarter" idx="3"/>
           </p:nvPr>
         </p:nvSpPr>
         <p:spPr/>
@@ -601,7 +500,7 @@
             <a:spLocks noGrp="1"/>
           </p:cNvSpPr>
           <p:nvPr>
-            <p:ph type="sldNum" idx="5" sz="quarter"/>
+            <p:ph type="sldNum" sz="quarter" idx="5"/>
           </p:nvPr>
         </p:nvSpPr>
         <p:spPr/>
@@ -615,7 +514,7 @@
 </file>
 
 <file path=ppt/notesSlides/notesSlide11.xml><?xml version="1.0" encoding="utf-8"?>
-<p:notes xmlns:a="http://schemas.openxmlformats.org/drawingml/2006/main" xmlns:p="http://schemas.openxmlformats.org/presentationml/2006/main" xmlns:r="http://schemas.openxmlformats.org/officeDocument/2006/relationships">
+<p:notes xmlns:a="http://schemas.openxmlformats.org/drawingml/2006/main" xmlns:r="http://schemas.openxmlformats.org/officeDocument/2006/relationships" xmlns:p="http://schemas.openxmlformats.org/presentationml/2006/main">
   <p:cSld>
     <p:spTree>
       <p:nvGrpSpPr>
@@ -635,7 +534,7 @@
         <p:nvSpPr>
           <p:cNvPr id="2" name="Slide Image Placeholder 1"/>
           <p:cNvSpPr>
-            <a:spLocks noGrp="1"/>
+            <a:spLocks noGrp="1" noRot="1" noChangeAspect="1"/>
           </p:cNvSpPr>
           <p:nvPr>
             <p:ph type="sldImg" idx="2"/>
@@ -650,7 +549,7 @@
             <a:spLocks noGrp="1"/>
           </p:cNvSpPr>
           <p:nvPr>
-            <p:ph type="body" idx="3" sz="quarter"/>
+            <p:ph type="body" sz="quarter" idx="3"/>
           </p:nvPr>
         </p:nvSpPr>
         <p:spPr/>
@@ -671,7 +570,7 @@
             <a:spLocks noGrp="1"/>
           </p:cNvSpPr>
           <p:nvPr>
-            <p:ph type="sldNum" idx="5" sz="quarter"/>
+            <p:ph type="sldNum" sz="quarter" idx="5"/>
           </p:nvPr>
         </p:nvSpPr>
         <p:spPr/>
@@ -685,7 +584,7 @@
 </file>
 
 <file path=ppt/notesSlides/notesSlide12.xml><?xml version="1.0" encoding="utf-8"?>
-<p:notes xmlns:a="http://schemas.openxmlformats.org/drawingml/2006/main" xmlns:p="http://schemas.openxmlformats.org/presentationml/2006/main" xmlns:r="http://schemas.openxmlformats.org/officeDocument/2006/relationships">
+<p:notes xmlns:a="http://schemas.openxmlformats.org/drawingml/2006/main" xmlns:r="http://schemas.openxmlformats.org/officeDocument/2006/relationships" xmlns:p="http://schemas.openxmlformats.org/presentationml/2006/main">
   <p:cSld>
     <p:spTree>
       <p:nvGrpSpPr>
@@ -705,7 +604,7 @@
         <p:nvSpPr>
           <p:cNvPr id="2" name="Slide Image Placeholder 1"/>
           <p:cNvSpPr>
-            <a:spLocks noGrp="1"/>
+            <a:spLocks noGrp="1" noRot="1" noChangeAspect="1"/>
           </p:cNvSpPr>
           <p:nvPr>
             <p:ph type="sldImg" idx="2"/>
@@ -720,7 +619,7 @@
             <a:spLocks noGrp="1"/>
           </p:cNvSpPr>
           <p:nvPr>
-            <p:ph type="body" idx="3" sz="quarter"/>
+            <p:ph type="body" sz="quarter" idx="3"/>
           </p:nvPr>
         </p:nvSpPr>
         <p:spPr/>
@@ -741,7 +640,7 @@
             <a:spLocks noGrp="1"/>
           </p:cNvSpPr>
           <p:nvPr>
-            <p:ph type="sldNum" idx="5" sz="quarter"/>
+            <p:ph type="sldNum" sz="quarter" idx="5"/>
           </p:nvPr>
         </p:nvSpPr>
         <p:spPr/>
@@ -755,7 +654,7 @@
 </file>
 
 <file path=ppt/notesSlides/notesSlide13.xml><?xml version="1.0" encoding="utf-8"?>
-<p:notes xmlns:a="http://schemas.openxmlformats.org/drawingml/2006/main" xmlns:p="http://schemas.openxmlformats.org/presentationml/2006/main" xmlns:r="http://schemas.openxmlformats.org/officeDocument/2006/relationships">
+<p:notes xmlns:a="http://schemas.openxmlformats.org/drawingml/2006/main" xmlns:r="http://schemas.openxmlformats.org/officeDocument/2006/relationships" xmlns:p="http://schemas.openxmlformats.org/presentationml/2006/main">
   <p:cSld>
     <p:spTree>
       <p:nvGrpSpPr>
@@ -775,7 +674,7 @@
         <p:nvSpPr>
           <p:cNvPr id="2" name="Slide Image Placeholder 1"/>
           <p:cNvSpPr>
-            <a:spLocks noGrp="1"/>
+            <a:spLocks noGrp="1" noRot="1" noChangeAspect="1"/>
           </p:cNvSpPr>
           <p:nvPr>
             <p:ph type="sldImg" idx="2"/>
@@ -790,7 +689,7 @@
             <a:spLocks noGrp="1"/>
           </p:cNvSpPr>
           <p:nvPr>
-            <p:ph type="body" idx="3" sz="quarter"/>
+            <p:ph type="body" sz="quarter" idx="3"/>
           </p:nvPr>
         </p:nvSpPr>
         <p:spPr/>
@@ -811,7 +710,7 @@
             <a:spLocks noGrp="1"/>
           </p:cNvSpPr>
           <p:nvPr>
-            <p:ph type="sldNum" idx="5" sz="quarter"/>
+            <p:ph type="sldNum" sz="quarter" idx="5"/>
           </p:nvPr>
         </p:nvSpPr>
         <p:spPr/>
@@ -825,7 +724,7 @@
 </file>
 
 <file path=ppt/notesSlides/notesSlide14.xml><?xml version="1.0" encoding="utf-8"?>
-<p:notes xmlns:a="http://schemas.openxmlformats.org/drawingml/2006/main" xmlns:p="http://schemas.openxmlformats.org/presentationml/2006/main" xmlns:r="http://schemas.openxmlformats.org/officeDocument/2006/relationships">
+<p:notes xmlns:a="http://schemas.openxmlformats.org/drawingml/2006/main" xmlns:r="http://schemas.openxmlformats.org/officeDocument/2006/relationships" xmlns:p="http://schemas.openxmlformats.org/presentationml/2006/main">
   <p:cSld>
     <p:spTree>
       <p:nvGrpSpPr>
@@ -845,7 +744,7 @@
         <p:nvSpPr>
           <p:cNvPr id="2" name="Slide Image Placeholder 1"/>
           <p:cNvSpPr>
-            <a:spLocks noGrp="1"/>
+            <a:spLocks noGrp="1" noRot="1" noChangeAspect="1"/>
           </p:cNvSpPr>
           <p:nvPr>
             <p:ph type="sldImg" idx="2"/>
@@ -860,7 +759,7 @@
             <a:spLocks noGrp="1"/>
           </p:cNvSpPr>
           <p:nvPr>
-            <p:ph type="body" idx="3" sz="quarter"/>
+            <p:ph type="body" sz="quarter" idx="3"/>
           </p:nvPr>
         </p:nvSpPr>
         <p:spPr/>
@@ -881,7 +780,7 @@
             <a:spLocks noGrp="1"/>
           </p:cNvSpPr>
           <p:nvPr>
-            <p:ph type="sldNum" idx="5" sz="quarter"/>
+            <p:ph type="sldNum" sz="quarter" idx="5"/>
           </p:nvPr>
         </p:nvSpPr>
         <p:spPr/>
@@ -895,7 +794,7 @@
 </file>
 
 <file path=ppt/notesSlides/notesSlide15.xml><?xml version="1.0" encoding="utf-8"?>
-<p:notes xmlns:a="http://schemas.openxmlformats.org/drawingml/2006/main" xmlns:p="http://schemas.openxmlformats.org/presentationml/2006/main" xmlns:r="http://schemas.openxmlformats.org/officeDocument/2006/relationships">
+<p:notes xmlns:a="http://schemas.openxmlformats.org/drawingml/2006/main" xmlns:r="http://schemas.openxmlformats.org/officeDocument/2006/relationships" xmlns:p="http://schemas.openxmlformats.org/presentationml/2006/main">
   <p:cSld>
     <p:spTree>
       <p:nvGrpSpPr>
@@ -915,7 +814,7 @@
         <p:nvSpPr>
           <p:cNvPr id="2" name="Slide Image Placeholder 1"/>
           <p:cNvSpPr>
-            <a:spLocks noGrp="1"/>
+            <a:spLocks noGrp="1" noRot="1" noChangeAspect="1"/>
           </p:cNvSpPr>
           <p:nvPr>
             <p:ph type="sldImg" idx="2"/>
@@ -930,7 +829,7 @@
             <a:spLocks noGrp="1"/>
           </p:cNvSpPr>
           <p:nvPr>
-            <p:ph type="body" idx="3" sz="quarter"/>
+            <p:ph type="body" sz="quarter" idx="3"/>
           </p:nvPr>
         </p:nvSpPr>
         <p:spPr/>
@@ -951,7 +850,7 @@
             <a:spLocks noGrp="1"/>
           </p:cNvSpPr>
           <p:nvPr>
-            <p:ph type="sldNum" idx="5" sz="quarter"/>
+            <p:ph type="sldNum" sz="quarter" idx="5"/>
           </p:nvPr>
         </p:nvSpPr>
         <p:spPr/>
@@ -965,7 +864,7 @@
 </file>
 
 <file path=ppt/notesSlides/notesSlide16.xml><?xml version="1.0" encoding="utf-8"?>
-<p:notes xmlns:a="http://schemas.openxmlformats.org/drawingml/2006/main" xmlns:p="http://schemas.openxmlformats.org/presentationml/2006/main" xmlns:r="http://schemas.openxmlformats.org/officeDocument/2006/relationships">
+<p:notes xmlns:a="http://schemas.openxmlformats.org/drawingml/2006/main" xmlns:r="http://schemas.openxmlformats.org/officeDocument/2006/relationships" xmlns:p="http://schemas.openxmlformats.org/presentationml/2006/main">
   <p:cSld>
     <p:spTree>
       <p:nvGrpSpPr>
@@ -985,7 +884,7 @@
         <p:nvSpPr>
           <p:cNvPr id="2" name="Slide Image Placeholder 1"/>
           <p:cNvSpPr>
-            <a:spLocks noGrp="1"/>
+            <a:spLocks noGrp="1" noRot="1" noChangeAspect="1"/>
           </p:cNvSpPr>
           <p:nvPr>
             <p:ph type="sldImg" idx="2"/>
@@ -1000,7 +899,7 @@
             <a:spLocks noGrp="1"/>
           </p:cNvSpPr>
           <p:nvPr>
-            <p:ph type="body" idx="3" sz="quarter"/>
+            <p:ph type="body" sz="quarter" idx="3"/>
           </p:nvPr>
         </p:nvSpPr>
         <p:spPr/>
@@ -1021,7 +920,7 @@
             <a:spLocks noGrp="1"/>
           </p:cNvSpPr>
           <p:nvPr>
-            <p:ph type="sldNum" idx="5" sz="quarter"/>
+            <p:ph type="sldNum" sz="quarter" idx="5"/>
           </p:nvPr>
         </p:nvSpPr>
         <p:spPr/>
@@ -1035,7 +934,7 @@
 </file>
 
 <file path=ppt/notesSlides/notesSlide17.xml><?xml version="1.0" encoding="utf-8"?>
-<p:notes xmlns:a="http://schemas.openxmlformats.org/drawingml/2006/main" xmlns:p="http://schemas.openxmlformats.org/presentationml/2006/main" xmlns:r="http://schemas.openxmlformats.org/officeDocument/2006/relationships">
+<p:notes xmlns:a="http://schemas.openxmlformats.org/drawingml/2006/main" xmlns:r="http://schemas.openxmlformats.org/officeDocument/2006/relationships" xmlns:p="http://schemas.openxmlformats.org/presentationml/2006/main">
   <p:cSld>
     <p:spTree>
       <p:nvGrpSpPr>
@@ -1055,7 +954,7 @@
         <p:nvSpPr>
           <p:cNvPr id="2" name="Slide Image Placeholder 1"/>
           <p:cNvSpPr>
-            <a:spLocks noGrp="1"/>
+            <a:spLocks noGrp="1" noRot="1" noChangeAspect="1"/>
           </p:cNvSpPr>
           <p:nvPr>
             <p:ph type="sldImg" idx="2"/>
@@ -1070,7 +969,7 @@
             <a:spLocks noGrp="1"/>
           </p:cNvSpPr>
           <p:nvPr>
-            <p:ph type="body" idx="3" sz="quarter"/>
+            <p:ph type="body" sz="quarter" idx="3"/>
           </p:nvPr>
         </p:nvSpPr>
         <p:spPr/>
@@ -1091,7 +990,7 @@
             <a:spLocks noGrp="1"/>
           </p:cNvSpPr>
           <p:nvPr>
-            <p:ph type="sldNum" idx="5" sz="quarter"/>
+            <p:ph type="sldNum" sz="quarter" idx="5"/>
           </p:nvPr>
         </p:nvSpPr>
         <p:spPr/>
@@ -1105,7 +1004,7 @@
 </file>
 
 <file path=ppt/notesSlides/notesSlide18.xml><?xml version="1.0" encoding="utf-8"?>
-<p:notes xmlns:a="http://schemas.openxmlformats.org/drawingml/2006/main" xmlns:p="http://schemas.openxmlformats.org/presentationml/2006/main" xmlns:r="http://schemas.openxmlformats.org/officeDocument/2006/relationships">
+<p:notes xmlns:a="http://schemas.openxmlformats.org/drawingml/2006/main" xmlns:r="http://schemas.openxmlformats.org/officeDocument/2006/relationships" xmlns:p="http://schemas.openxmlformats.org/presentationml/2006/main">
   <p:cSld>
     <p:spTree>
       <p:nvGrpSpPr>
@@ -1125,7 +1024,7 @@
         <p:nvSpPr>
           <p:cNvPr id="2" name="Slide Image Placeholder 1"/>
           <p:cNvSpPr>
-            <a:spLocks noGrp="1"/>
+            <a:spLocks noGrp="1" noRot="1" noChangeAspect="1"/>
           </p:cNvSpPr>
           <p:nvPr>
             <p:ph type="sldImg" idx="2"/>
@@ -1140,7 +1039,7 @@
             <a:spLocks noGrp="1"/>
           </p:cNvSpPr>
           <p:nvPr>
-            <p:ph type="body" idx="3" sz="quarter"/>
+            <p:ph type="body" sz="quarter" idx="3"/>
           </p:nvPr>
         </p:nvSpPr>
         <p:spPr/>
@@ -1161,7 +1060,7 @@
             <a:spLocks noGrp="1"/>
           </p:cNvSpPr>
           <p:nvPr>
-            <p:ph type="sldNum" idx="5" sz="quarter"/>
+            <p:ph type="sldNum" sz="quarter" idx="5"/>
           </p:nvPr>
         </p:nvSpPr>
         <p:spPr/>
@@ -1175,7 +1074,7 @@
 </file>
 
 <file path=ppt/notesSlides/notesSlide2.xml><?xml version="1.0" encoding="utf-8"?>
-<p:notes xmlns:a="http://schemas.openxmlformats.org/drawingml/2006/main" xmlns:p="http://schemas.openxmlformats.org/presentationml/2006/main" xmlns:r="http://schemas.openxmlformats.org/officeDocument/2006/relationships">
+<p:notes xmlns:a="http://schemas.openxmlformats.org/drawingml/2006/main" xmlns:r="http://schemas.openxmlformats.org/officeDocument/2006/relationships" xmlns:p="http://schemas.openxmlformats.org/presentationml/2006/main">
   <p:cSld>
     <p:spTree>
       <p:nvGrpSpPr>
@@ -1195,7 +1094,7 @@
         <p:nvSpPr>
           <p:cNvPr id="2" name="Slide Image Placeholder 1"/>
           <p:cNvSpPr>
-            <a:spLocks noGrp="1"/>
+            <a:spLocks noGrp="1" noRot="1" noChangeAspect="1"/>
           </p:cNvSpPr>
           <p:nvPr>
             <p:ph type="sldImg" idx="2"/>
@@ -1210,7 +1109,7 @@
             <a:spLocks noGrp="1"/>
           </p:cNvSpPr>
           <p:nvPr>
-            <p:ph type="body" idx="3" sz="quarter"/>
+            <p:ph type="body" sz="quarter" idx="3"/>
           </p:nvPr>
         </p:nvSpPr>
         <p:spPr/>
@@ -1218,9 +1117,7 @@
           <a:bodyPr/>
           <a:lstStyle/>
           <a:p>
-            <a:r>
-              <a:t>In digital pathology, algorithms trained on one hospital's slides routinely fail when deployed at another. Staining reagents, tissue slicing, and scanner optics introduce massive domain shifts. Centralizing patient data for retraining is barred by HIPAA and GDPR. Thus, models must adapt on-the-fly during inference.</a:t>
-            </a:r>
+            <a:endParaRPr dirty="0"/>
           </a:p>
         </p:txBody>
       </p:sp>
@@ -1231,7 +1128,7 @@
             <a:spLocks noGrp="1"/>
           </p:cNvSpPr>
           <p:nvPr>
-            <p:ph type="sldNum" idx="5" sz="quarter"/>
+            <p:ph type="sldNum" sz="quarter" idx="5"/>
           </p:nvPr>
         </p:nvSpPr>
         <p:spPr/>
@@ -1245,7 +1142,7 @@
 </file>
 
 <file path=ppt/notesSlides/notesSlide3.xml><?xml version="1.0" encoding="utf-8"?>
-<p:notes xmlns:a="http://schemas.openxmlformats.org/drawingml/2006/main" xmlns:p="http://schemas.openxmlformats.org/presentationml/2006/main" xmlns:r="http://schemas.openxmlformats.org/officeDocument/2006/relationships">
+<p:notes xmlns:a="http://schemas.openxmlformats.org/drawingml/2006/main" xmlns:r="http://schemas.openxmlformats.org/officeDocument/2006/relationships" xmlns:p="http://schemas.openxmlformats.org/presentationml/2006/main">
   <p:cSld>
     <p:spTree>
       <p:nvGrpSpPr>
@@ -1265,7 +1162,7 @@
         <p:nvSpPr>
           <p:cNvPr id="2" name="Slide Image Placeholder 1"/>
           <p:cNvSpPr>
-            <a:spLocks noGrp="1"/>
+            <a:spLocks noGrp="1" noRot="1" noChangeAspect="1"/>
           </p:cNvSpPr>
           <p:nvPr>
             <p:ph type="sldImg" idx="2"/>
@@ -1280,7 +1177,7 @@
             <a:spLocks noGrp="1"/>
           </p:cNvSpPr>
           <p:nvPr>
-            <p:ph type="body" idx="3" sz="quarter"/>
+            <p:ph type="body" sz="quarter" idx="3"/>
           </p:nvPr>
         </p:nvSpPr>
         <p:spPr/>
@@ -1301,7 +1198,7 @@
             <a:spLocks noGrp="1"/>
           </p:cNvSpPr>
           <p:nvPr>
-            <p:ph type="sldNum" idx="5" sz="quarter"/>
+            <p:ph type="sldNum" sz="quarter" idx="5"/>
           </p:nvPr>
         </p:nvSpPr>
         <p:spPr/>
@@ -1315,7 +1212,7 @@
 </file>
 
 <file path=ppt/notesSlides/notesSlide4.xml><?xml version="1.0" encoding="utf-8"?>
-<p:notes xmlns:a="http://schemas.openxmlformats.org/drawingml/2006/main" xmlns:p="http://schemas.openxmlformats.org/presentationml/2006/main" xmlns:r="http://schemas.openxmlformats.org/officeDocument/2006/relationships">
+<p:notes xmlns:a="http://schemas.openxmlformats.org/drawingml/2006/main" xmlns:r="http://schemas.openxmlformats.org/officeDocument/2006/relationships" xmlns:p="http://schemas.openxmlformats.org/presentationml/2006/main">
   <p:cSld>
     <p:spTree>
       <p:nvGrpSpPr>
@@ -1335,7 +1232,7 @@
         <p:nvSpPr>
           <p:cNvPr id="2" name="Slide Image Placeholder 1"/>
           <p:cNvSpPr>
-            <a:spLocks noGrp="1"/>
+            <a:spLocks noGrp="1" noRot="1" noChangeAspect="1"/>
           </p:cNvSpPr>
           <p:nvPr>
             <p:ph type="sldImg" idx="2"/>
@@ -1350,7 +1247,7 @@
             <a:spLocks noGrp="1"/>
           </p:cNvSpPr>
           <p:nvPr>
-            <p:ph type="body" idx="3" sz="quarter"/>
+            <p:ph type="body" sz="quarter" idx="3"/>
           </p:nvPr>
         </p:nvSpPr>
         <p:spPr/>
@@ -1371,7 +1268,7 @@
             <a:spLocks noGrp="1"/>
           </p:cNvSpPr>
           <p:nvPr>
-            <p:ph type="sldNum" idx="5" sz="quarter"/>
+            <p:ph type="sldNum" sz="quarter" idx="5"/>
           </p:nvPr>
         </p:nvSpPr>
         <p:spPr/>
@@ -1385,7 +1282,7 @@
 </file>
 
 <file path=ppt/notesSlides/notesSlide5.xml><?xml version="1.0" encoding="utf-8"?>
-<p:notes xmlns:a="http://schemas.openxmlformats.org/drawingml/2006/main" xmlns:p="http://schemas.openxmlformats.org/presentationml/2006/main" xmlns:r="http://schemas.openxmlformats.org/officeDocument/2006/relationships">
+<p:notes xmlns:a="http://schemas.openxmlformats.org/drawingml/2006/main" xmlns:r="http://schemas.openxmlformats.org/officeDocument/2006/relationships" xmlns:p="http://schemas.openxmlformats.org/presentationml/2006/main">
   <p:cSld>
     <p:spTree>
       <p:nvGrpSpPr>
@@ -1405,7 +1302,7 @@
         <p:nvSpPr>
           <p:cNvPr id="2" name="Slide Image Placeholder 1"/>
           <p:cNvSpPr>
-            <a:spLocks noGrp="1"/>
+            <a:spLocks noGrp="1" noRot="1" noChangeAspect="1"/>
           </p:cNvSpPr>
           <p:nvPr>
             <p:ph type="sldImg" idx="2"/>
@@ -1420,7 +1317,7 @@
             <a:spLocks noGrp="1"/>
           </p:cNvSpPr>
           <p:nvPr>
-            <p:ph type="body" idx="3" sz="quarter"/>
+            <p:ph type="body" sz="quarter" idx="3"/>
           </p:nvPr>
         </p:nvSpPr>
         <p:spPr/>
@@ -1441,7 +1338,7 @@
             <a:spLocks noGrp="1"/>
           </p:cNvSpPr>
           <p:nvPr>
-            <p:ph type="sldNum" idx="5" sz="quarter"/>
+            <p:ph type="sldNum" sz="quarter" idx="5"/>
           </p:nvPr>
         </p:nvSpPr>
         <p:spPr/>
@@ -1455,7 +1352,7 @@
 </file>
 
 <file path=ppt/notesSlides/notesSlide6.xml><?xml version="1.0" encoding="utf-8"?>
-<p:notes xmlns:a="http://schemas.openxmlformats.org/drawingml/2006/main" xmlns:p="http://schemas.openxmlformats.org/presentationml/2006/main" xmlns:r="http://schemas.openxmlformats.org/officeDocument/2006/relationships">
+<p:notes xmlns:a="http://schemas.openxmlformats.org/drawingml/2006/main" xmlns:r="http://schemas.openxmlformats.org/officeDocument/2006/relationships" xmlns:p="http://schemas.openxmlformats.org/presentationml/2006/main">
   <p:cSld>
     <p:spTree>
       <p:nvGrpSpPr>
@@ -1475,7 +1372,7 @@
         <p:nvSpPr>
           <p:cNvPr id="2" name="Slide Image Placeholder 1"/>
           <p:cNvSpPr>
-            <a:spLocks noGrp="1"/>
+            <a:spLocks noGrp="1" noRot="1" noChangeAspect="1"/>
           </p:cNvSpPr>
           <p:nvPr>
             <p:ph type="sldImg" idx="2"/>
@@ -1490,7 +1387,7 @@
             <a:spLocks noGrp="1"/>
           </p:cNvSpPr>
           <p:nvPr>
-            <p:ph type="body" idx="3" sz="quarter"/>
+            <p:ph type="body" sz="quarter" idx="3"/>
           </p:nvPr>
         </p:nvSpPr>
         <p:spPr/>
@@ -1511,7 +1408,7 @@
             <a:spLocks noGrp="1"/>
           </p:cNvSpPr>
           <p:nvPr>
-            <p:ph type="sldNum" idx="5" sz="quarter"/>
+            <p:ph type="sldNum" sz="quarter" idx="5"/>
           </p:nvPr>
         </p:nvSpPr>
         <p:spPr/>
@@ -1525,7 +1422,7 @@
 </file>
 
 <file path=ppt/notesSlides/notesSlide7.xml><?xml version="1.0" encoding="utf-8"?>
-<p:notes xmlns:a="http://schemas.openxmlformats.org/drawingml/2006/main" xmlns:p="http://schemas.openxmlformats.org/presentationml/2006/main" xmlns:r="http://schemas.openxmlformats.org/officeDocument/2006/relationships">
+<p:notes xmlns:a="http://schemas.openxmlformats.org/drawingml/2006/main" xmlns:r="http://schemas.openxmlformats.org/officeDocument/2006/relationships" xmlns:p="http://schemas.openxmlformats.org/presentationml/2006/main">
   <p:cSld>
     <p:spTree>
       <p:nvGrpSpPr>
@@ -1545,7 +1442,7 @@
         <p:nvSpPr>
           <p:cNvPr id="2" name="Slide Image Placeholder 1"/>
           <p:cNvSpPr>
-            <a:spLocks noGrp="1"/>
+            <a:spLocks noGrp="1" noRot="1" noChangeAspect="1"/>
           </p:cNvSpPr>
           <p:nvPr>
             <p:ph type="sldImg" idx="2"/>
@@ -1560,7 +1457,7 @@
             <a:spLocks noGrp="1"/>
           </p:cNvSpPr>
           <p:nvPr>
-            <p:ph type="body" idx="3" sz="quarter"/>
+            <p:ph type="body" sz="quarter" idx="3"/>
           </p:nvPr>
         </p:nvSpPr>
         <p:spPr/>
@@ -1581,7 +1478,7 @@
             <a:spLocks noGrp="1"/>
           </p:cNvSpPr>
           <p:nvPr>
-            <p:ph type="sldNum" idx="5" sz="quarter"/>
+            <p:ph type="sldNum" sz="quarter" idx="5"/>
           </p:nvPr>
         </p:nvSpPr>
         <p:spPr/>
@@ -1595,7 +1492,7 @@
 </file>
 
 <file path=ppt/notesSlides/notesSlide8.xml><?xml version="1.0" encoding="utf-8"?>
-<p:notes xmlns:a="http://schemas.openxmlformats.org/drawingml/2006/main" xmlns:p="http://schemas.openxmlformats.org/presentationml/2006/main" xmlns:r="http://schemas.openxmlformats.org/officeDocument/2006/relationships">
+<p:notes xmlns:a="http://schemas.openxmlformats.org/drawingml/2006/main" xmlns:r="http://schemas.openxmlformats.org/officeDocument/2006/relationships" xmlns:p="http://schemas.openxmlformats.org/presentationml/2006/main">
   <p:cSld>
     <p:spTree>
       <p:nvGrpSpPr>
@@ -1615,7 +1512,7 @@
         <p:nvSpPr>
           <p:cNvPr id="2" name="Slide Image Placeholder 1"/>
           <p:cNvSpPr>
-            <a:spLocks noGrp="1"/>
+            <a:spLocks noGrp="1" noRot="1" noChangeAspect="1"/>
           </p:cNvSpPr>
           <p:nvPr>
             <p:ph type="sldImg" idx="2"/>
@@ -1630,7 +1527,7 @@
             <a:spLocks noGrp="1"/>
           </p:cNvSpPr>
           <p:nvPr>
-            <p:ph type="body" idx="3" sz="quarter"/>
+            <p:ph type="body" sz="quarter" idx="3"/>
           </p:nvPr>
         </p:nvSpPr>
         <p:spPr/>
@@ -1651,7 +1548,7 @@
             <a:spLocks noGrp="1"/>
           </p:cNvSpPr>
           <p:nvPr>
-            <p:ph type="sldNum" idx="5" sz="quarter"/>
+            <p:ph type="sldNum" sz="quarter" idx="5"/>
           </p:nvPr>
         </p:nvSpPr>
         <p:spPr/>
@@ -1665,7 +1562,7 @@
 </file>
 
 <file path=ppt/notesSlides/notesSlide9.xml><?xml version="1.0" encoding="utf-8"?>
-<p:notes xmlns:a="http://schemas.openxmlformats.org/drawingml/2006/main" xmlns:p="http://schemas.openxmlformats.org/presentationml/2006/main" xmlns:r="http://schemas.openxmlformats.org/officeDocument/2006/relationships">
+<p:notes xmlns:a="http://schemas.openxmlformats.org/drawingml/2006/main" xmlns:r="http://schemas.openxmlformats.org/officeDocument/2006/relationships" xmlns:p="http://schemas.openxmlformats.org/presentationml/2006/main">
   <p:cSld>
     <p:spTree>
       <p:nvGrpSpPr>
@@ -1685,7 +1582,7 @@
         <p:nvSpPr>
           <p:cNvPr id="2" name="Slide Image Placeholder 1"/>
           <p:cNvSpPr>
-            <a:spLocks noGrp="1"/>
+            <a:spLocks noGrp="1" noRot="1" noChangeAspect="1"/>
           </p:cNvSpPr>
           <p:nvPr>
             <p:ph type="sldImg" idx="2"/>
@@ -1700,7 +1597,7 @@
             <a:spLocks noGrp="1"/>
           </p:cNvSpPr>
           <p:nvPr>
-            <p:ph type="body" idx="3" sz="quarter"/>
+            <p:ph type="body" sz="quarter" idx="3"/>
           </p:nvPr>
         </p:nvSpPr>
         <p:spPr/>
@@ -1721,7 +1618,7 @@
             <a:spLocks noGrp="1"/>
           </p:cNvSpPr>
           <p:nvPr>
-            <p:ph type="sldNum" idx="5" sz="quarter"/>
+            <p:ph type="sldNum" sz="quarter" idx="5"/>
           </p:nvPr>
         </p:nvSpPr>
         <p:spPr/>
@@ -1772,10 +1669,9 @@
           <a:lstStyle/>
           <a:p>
             <a:r>
-              <a:rPr lang="en-US" smtClean="0"/>
+              <a:rPr lang="en-US"/>
               <a:t>Click to edit Master title style</a:t>
             </a:r>
-            <a:endParaRPr lang="en-US"/>
           </a:p>
         </p:txBody>
       </p:sp>
@@ -1891,10 +1787,9 @@
           </a:lstStyle>
           <a:p>
             <a:r>
-              <a:rPr lang="en-US" smtClean="0"/>
+              <a:rPr lang="en-US"/>
               <a:t>Click to edit Master subtitle style</a:t>
             </a:r>
-            <a:endParaRPr lang="en-US"/>
           </a:p>
         </p:txBody>
       </p:sp>
@@ -1915,7 +1810,7 @@
           <a:p>
             <a:fld id="{5BCAD085-E8A6-8845-BD4E-CB4CCA059FC4}" type="datetimeFigureOut">
               <a:rPr lang="en-US" smtClean="0"/>
-              <a:t>1/27/13</a:t>
+              <a:t>10/27/2026</a:t>
             </a:fld>
             <a:endParaRPr lang="en-US"/>
           </a:p>
@@ -2009,10 +1904,9 @@
           <a:lstStyle/>
           <a:p>
             <a:r>
-              <a:rPr lang="en-US" smtClean="0"/>
+              <a:rPr lang="en-US"/>
               <a:t>Click to edit Master title style</a:t>
             </a:r>
-            <a:endParaRPr lang="en-US"/>
           </a:p>
         </p:txBody>
       </p:sp>
@@ -2033,38 +1927,37 @@
           <a:p>
             <a:pPr lvl="0"/>
             <a:r>
-              <a:rPr lang="en-US" smtClean="0"/>
+              <a:rPr lang="en-US"/>
               <a:t>Click to edit Master text styles</a:t>
             </a:r>
           </a:p>
           <a:p>
             <a:pPr lvl="1"/>
             <a:r>
-              <a:rPr lang="en-US" smtClean="0"/>
+              <a:rPr lang="en-US"/>
               <a:t>Second level</a:t>
             </a:r>
           </a:p>
           <a:p>
             <a:pPr lvl="2"/>
             <a:r>
-              <a:rPr lang="en-US" smtClean="0"/>
+              <a:rPr lang="en-US"/>
               <a:t>Third level</a:t>
             </a:r>
           </a:p>
           <a:p>
             <a:pPr lvl="3"/>
             <a:r>
-              <a:rPr lang="en-US" smtClean="0"/>
+              <a:rPr lang="en-US"/>
               <a:t>Fourth level</a:t>
             </a:r>
           </a:p>
           <a:p>
             <a:pPr lvl="4"/>
             <a:r>
-              <a:rPr lang="en-US" smtClean="0"/>
+              <a:rPr lang="en-US"/>
               <a:t>Fifth level</a:t>
             </a:r>
-            <a:endParaRPr lang="en-US"/>
           </a:p>
         </p:txBody>
       </p:sp>
@@ -2085,7 +1978,7 @@
           <a:p>
             <a:fld id="{5BCAD085-E8A6-8845-BD4E-CB4CCA059FC4}" type="datetimeFigureOut">
               <a:rPr lang="en-US" smtClean="0"/>
-              <a:t>1/27/13</a:t>
+              <a:t>10/27/2026</a:t>
             </a:fld>
             <a:endParaRPr lang="en-US"/>
           </a:p>
@@ -2184,10 +2077,9 @@
           <a:lstStyle/>
           <a:p>
             <a:r>
-              <a:rPr lang="en-US" smtClean="0"/>
+              <a:rPr lang="en-US"/>
               <a:t>Click to edit Master title style</a:t>
             </a:r>
-            <a:endParaRPr lang="en-US"/>
           </a:p>
         </p:txBody>
       </p:sp>
@@ -2213,38 +2105,37 @@
           <a:p>
             <a:pPr lvl="0"/>
             <a:r>
-              <a:rPr lang="en-US" smtClean="0"/>
+              <a:rPr lang="en-US"/>
               <a:t>Click to edit Master text styles</a:t>
             </a:r>
           </a:p>
           <a:p>
             <a:pPr lvl="1"/>
             <a:r>
-              <a:rPr lang="en-US" smtClean="0"/>
+              <a:rPr lang="en-US"/>
               <a:t>Second level</a:t>
             </a:r>
           </a:p>
           <a:p>
             <a:pPr lvl="2"/>
             <a:r>
-              <a:rPr lang="en-US" smtClean="0"/>
+              <a:rPr lang="en-US"/>
               <a:t>Third level</a:t>
             </a:r>
           </a:p>
           <a:p>
             <a:pPr lvl="3"/>
             <a:r>
-              <a:rPr lang="en-US" smtClean="0"/>
+              <a:rPr lang="en-US"/>
               <a:t>Fourth level</a:t>
             </a:r>
           </a:p>
           <a:p>
             <a:pPr lvl="4"/>
             <a:r>
-              <a:rPr lang="en-US" smtClean="0"/>
+              <a:rPr lang="en-US"/>
               <a:t>Fifth level</a:t>
             </a:r>
-            <a:endParaRPr lang="en-US"/>
           </a:p>
         </p:txBody>
       </p:sp>
@@ -2265,7 +2156,7 @@
           <a:p>
             <a:fld id="{5BCAD085-E8A6-8845-BD4E-CB4CCA059FC4}" type="datetimeFigureOut">
               <a:rPr lang="en-US" smtClean="0"/>
-              <a:t>1/27/13</a:t>
+              <a:t>10/27/2026</a:t>
             </a:fld>
             <a:endParaRPr lang="en-US"/>
           </a:p>
@@ -2359,10 +2250,9 @@
           <a:lstStyle/>
           <a:p>
             <a:r>
-              <a:rPr lang="en-US" smtClean="0"/>
+              <a:rPr lang="en-US"/>
               <a:t>Click to edit Master title style</a:t>
             </a:r>
-            <a:endParaRPr lang="en-US"/>
           </a:p>
         </p:txBody>
       </p:sp>
@@ -2383,38 +2273,37 @@
           <a:p>
             <a:pPr lvl="0"/>
             <a:r>
-              <a:rPr lang="en-US" smtClean="0"/>
+              <a:rPr lang="en-US"/>
               <a:t>Click to edit Master text styles</a:t>
             </a:r>
           </a:p>
           <a:p>
             <a:pPr lvl="1"/>
             <a:r>
-              <a:rPr lang="en-US" smtClean="0"/>
+              <a:rPr lang="en-US"/>
               <a:t>Second level</a:t>
             </a:r>
           </a:p>
           <a:p>
             <a:pPr lvl="2"/>
             <a:r>
-              <a:rPr lang="en-US" smtClean="0"/>
+              <a:rPr lang="en-US"/>
               <a:t>Third level</a:t>
             </a:r>
           </a:p>
           <a:p>
             <a:pPr lvl="3"/>
             <a:r>
-              <a:rPr lang="en-US" smtClean="0"/>
+              <a:rPr lang="en-US"/>
               <a:t>Fourth level</a:t>
             </a:r>
           </a:p>
           <a:p>
             <a:pPr lvl="4"/>
             <a:r>
-              <a:rPr lang="en-US" smtClean="0"/>
+              <a:rPr lang="en-US"/>
               <a:t>Fifth level</a:t>
             </a:r>
-            <a:endParaRPr lang="en-US"/>
           </a:p>
         </p:txBody>
       </p:sp>
@@ -2435,7 +2324,7 @@
           <a:p>
             <a:fld id="{5BCAD085-E8A6-8845-BD4E-CB4CCA059FC4}" type="datetimeFigureOut">
               <a:rPr lang="en-US" smtClean="0"/>
-              <a:t>1/27/13</a:t>
+              <a:t>10/27/2026</a:t>
             </a:fld>
             <a:endParaRPr lang="en-US"/>
           </a:p>
@@ -2538,10 +2427,9 @@
           </a:lstStyle>
           <a:p>
             <a:r>
-              <a:rPr lang="en-US" smtClean="0"/>
+              <a:rPr lang="en-US"/>
               <a:t>Click to edit Master title style</a:t>
             </a:r>
-            <a:endParaRPr lang="en-US"/>
           </a:p>
         </p:txBody>
       </p:sp>
@@ -2658,7 +2546,7 @@
           <a:p>
             <a:pPr lvl="0"/>
             <a:r>
-              <a:rPr lang="en-US" smtClean="0"/>
+              <a:rPr lang="en-US"/>
               <a:t>Click to edit Master text styles</a:t>
             </a:r>
           </a:p>
@@ -2681,7 +2569,7 @@
           <a:p>
             <a:fld id="{5BCAD085-E8A6-8845-BD4E-CB4CCA059FC4}" type="datetimeFigureOut">
               <a:rPr lang="en-US" smtClean="0"/>
-              <a:t>1/27/13</a:t>
+              <a:t>10/27/2026</a:t>
             </a:fld>
             <a:endParaRPr lang="en-US"/>
           </a:p>
@@ -2775,10 +2663,9 @@
           <a:lstStyle/>
           <a:p>
             <a:r>
-              <a:rPr lang="en-US" smtClean="0"/>
+              <a:rPr lang="en-US"/>
               <a:t>Click to edit Master title style</a:t>
             </a:r>
-            <a:endParaRPr lang="en-US"/>
           </a:p>
         </p:txBody>
       </p:sp>
@@ -2832,38 +2719,37 @@
           <a:p>
             <a:pPr lvl="0"/>
             <a:r>
-              <a:rPr lang="en-US" smtClean="0"/>
+              <a:rPr lang="en-US"/>
               <a:t>Click to edit Master text styles</a:t>
             </a:r>
           </a:p>
           <a:p>
             <a:pPr lvl="1"/>
             <a:r>
-              <a:rPr lang="en-US" smtClean="0"/>
+              <a:rPr lang="en-US"/>
               <a:t>Second level</a:t>
             </a:r>
           </a:p>
           <a:p>
             <a:pPr lvl="2"/>
             <a:r>
-              <a:rPr lang="en-US" smtClean="0"/>
+              <a:rPr lang="en-US"/>
               <a:t>Third level</a:t>
             </a:r>
           </a:p>
           <a:p>
             <a:pPr lvl="3"/>
             <a:r>
-              <a:rPr lang="en-US" smtClean="0"/>
+              <a:rPr lang="en-US"/>
               <a:t>Fourth level</a:t>
             </a:r>
           </a:p>
           <a:p>
             <a:pPr lvl="4"/>
             <a:r>
-              <a:rPr lang="en-US" smtClean="0"/>
+              <a:rPr lang="en-US"/>
               <a:t>Fifth level</a:t>
             </a:r>
-            <a:endParaRPr lang="en-US"/>
           </a:p>
         </p:txBody>
       </p:sp>
@@ -2917,38 +2803,37 @@
           <a:p>
             <a:pPr lvl="0"/>
             <a:r>
-              <a:rPr lang="en-US" smtClean="0"/>
+              <a:rPr lang="en-US"/>
               <a:t>Click to edit Master text styles</a:t>
             </a:r>
           </a:p>
           <a:p>
             <a:pPr lvl="1"/>
             <a:r>
-              <a:rPr lang="en-US" smtClean="0"/>
+              <a:rPr lang="en-US"/>
               <a:t>Second level</a:t>
             </a:r>
           </a:p>
           <a:p>
             <a:pPr lvl="2"/>
             <a:r>
-              <a:rPr lang="en-US" smtClean="0"/>
+              <a:rPr lang="en-US"/>
               <a:t>Third level</a:t>
             </a:r>
           </a:p>
           <a:p>
             <a:pPr lvl="3"/>
             <a:r>
-              <a:rPr lang="en-US" smtClean="0"/>
+              <a:rPr lang="en-US"/>
               <a:t>Fourth level</a:t>
             </a:r>
           </a:p>
           <a:p>
             <a:pPr lvl="4"/>
             <a:r>
-              <a:rPr lang="en-US" smtClean="0"/>
+              <a:rPr lang="en-US"/>
               <a:t>Fifth level</a:t>
             </a:r>
-            <a:endParaRPr lang="en-US"/>
           </a:p>
         </p:txBody>
       </p:sp>
@@ -2969,7 +2854,7 @@
           <a:p>
             <a:fld id="{5BCAD085-E8A6-8845-BD4E-CB4CCA059FC4}" type="datetimeFigureOut">
               <a:rPr lang="en-US" smtClean="0"/>
-              <a:t>1/27/13</a:t>
+              <a:t>10/27/2026</a:t>
             </a:fld>
             <a:endParaRPr lang="en-US"/>
           </a:p>
@@ -3067,10 +2952,9 @@
           </a:lstStyle>
           <a:p>
             <a:r>
-              <a:rPr lang="en-US" smtClean="0"/>
+              <a:rPr lang="en-US"/>
               <a:t>Click to edit Master title style</a:t>
             </a:r>
-            <a:endParaRPr lang="en-US"/>
           </a:p>
         </p:txBody>
       </p:sp>
@@ -3133,7 +3017,7 @@
           <a:p>
             <a:pPr lvl="0"/>
             <a:r>
-              <a:rPr lang="en-US" smtClean="0"/>
+              <a:rPr lang="en-US"/>
               <a:t>Click to edit Master text styles</a:t>
             </a:r>
           </a:p>
@@ -3189,38 +3073,37 @@
           <a:p>
             <a:pPr lvl="0"/>
             <a:r>
-              <a:rPr lang="en-US" smtClean="0"/>
+              <a:rPr lang="en-US"/>
               <a:t>Click to edit Master text styles</a:t>
             </a:r>
           </a:p>
           <a:p>
             <a:pPr lvl="1"/>
             <a:r>
-              <a:rPr lang="en-US" smtClean="0"/>
+              <a:rPr lang="en-US"/>
               <a:t>Second level</a:t>
             </a:r>
           </a:p>
           <a:p>
             <a:pPr lvl="2"/>
             <a:r>
-              <a:rPr lang="en-US" smtClean="0"/>
+              <a:rPr lang="en-US"/>
               <a:t>Third level</a:t>
             </a:r>
           </a:p>
           <a:p>
             <a:pPr lvl="3"/>
             <a:r>
-              <a:rPr lang="en-US" smtClean="0"/>
+              <a:rPr lang="en-US"/>
               <a:t>Fourth level</a:t>
             </a:r>
           </a:p>
           <a:p>
             <a:pPr lvl="4"/>
             <a:r>
-              <a:rPr lang="en-US" smtClean="0"/>
+              <a:rPr lang="en-US"/>
               <a:t>Fifth level</a:t>
             </a:r>
-            <a:endParaRPr lang="en-US"/>
           </a:p>
         </p:txBody>
       </p:sp>
@@ -3283,7 +3166,7 @@
           <a:p>
             <a:pPr lvl="0"/>
             <a:r>
-              <a:rPr lang="en-US" smtClean="0"/>
+              <a:rPr lang="en-US"/>
               <a:t>Click to edit Master text styles</a:t>
             </a:r>
           </a:p>
@@ -3339,38 +3222,37 @@
           <a:p>
             <a:pPr lvl="0"/>
             <a:r>
-              <a:rPr lang="en-US" smtClean="0"/>
+              <a:rPr lang="en-US"/>
               <a:t>Click to edit Master text styles</a:t>
             </a:r>
           </a:p>
           <a:p>
             <a:pPr lvl="1"/>
             <a:r>
-              <a:rPr lang="en-US" smtClean="0"/>
+              <a:rPr lang="en-US"/>
               <a:t>Second level</a:t>
             </a:r>
           </a:p>
           <a:p>
             <a:pPr lvl="2"/>
             <a:r>
-              <a:rPr lang="en-US" smtClean="0"/>
+              <a:rPr lang="en-US"/>
               <a:t>Third level</a:t>
             </a:r>
           </a:p>
           <a:p>
             <a:pPr lvl="3"/>
             <a:r>
-              <a:rPr lang="en-US" smtClean="0"/>
+              <a:rPr lang="en-US"/>
               <a:t>Fourth level</a:t>
             </a:r>
           </a:p>
           <a:p>
             <a:pPr lvl="4"/>
             <a:r>
-              <a:rPr lang="en-US" smtClean="0"/>
+              <a:rPr lang="en-US"/>
               <a:t>Fifth level</a:t>
             </a:r>
-            <a:endParaRPr lang="en-US"/>
           </a:p>
         </p:txBody>
       </p:sp>
@@ -3391,7 +3273,7 @@
           <a:p>
             <a:fld id="{5BCAD085-E8A6-8845-BD4E-CB4CCA059FC4}" type="datetimeFigureOut">
               <a:rPr lang="en-US" smtClean="0"/>
-              <a:t>1/27/13</a:t>
+              <a:t>10/27/2026</a:t>
             </a:fld>
             <a:endParaRPr lang="en-US"/>
           </a:p>
@@ -3485,10 +3367,9 @@
           <a:lstStyle/>
           <a:p>
             <a:r>
-              <a:rPr lang="en-US" smtClean="0"/>
+              <a:rPr lang="en-US"/>
               <a:t>Click to edit Master title style</a:t>
             </a:r>
-            <a:endParaRPr lang="en-US"/>
           </a:p>
         </p:txBody>
       </p:sp>
@@ -3509,7 +3390,7 @@
           <a:p>
             <a:fld id="{5BCAD085-E8A6-8845-BD4E-CB4CCA059FC4}" type="datetimeFigureOut">
               <a:rPr lang="en-US" smtClean="0"/>
-              <a:t>1/27/13</a:t>
+              <a:t>10/27/2026</a:t>
             </a:fld>
             <a:endParaRPr lang="en-US"/>
           </a:p>
@@ -3604,7 +3485,7 @@
           <a:p>
             <a:fld id="{5BCAD085-E8A6-8845-BD4E-CB4CCA059FC4}" type="datetimeFigureOut">
               <a:rPr lang="en-US" smtClean="0"/>
-              <a:t>1/27/13</a:t>
+              <a:t>10/27/2026</a:t>
             </a:fld>
             <a:endParaRPr lang="en-US"/>
           </a:p>
@@ -3707,10 +3588,9 @@
           </a:lstStyle>
           <a:p>
             <a:r>
-              <a:rPr lang="en-US" smtClean="0"/>
+              <a:rPr lang="en-US"/>
               <a:t>Click to edit Master title style</a:t>
             </a:r>
-            <a:endParaRPr lang="en-US"/>
           </a:p>
         </p:txBody>
       </p:sp>
@@ -3764,38 +3644,37 @@
           <a:p>
             <a:pPr lvl="0"/>
             <a:r>
-              <a:rPr lang="en-US" smtClean="0"/>
+              <a:rPr lang="en-US"/>
               <a:t>Click to edit Master text styles</a:t>
             </a:r>
           </a:p>
           <a:p>
             <a:pPr lvl="1"/>
             <a:r>
-              <a:rPr lang="en-US" smtClean="0"/>
+              <a:rPr lang="en-US"/>
               <a:t>Second level</a:t>
             </a:r>
           </a:p>
           <a:p>
             <a:pPr lvl="2"/>
             <a:r>
-              <a:rPr lang="en-US" smtClean="0"/>
+              <a:rPr lang="en-US"/>
               <a:t>Third level</a:t>
             </a:r>
           </a:p>
           <a:p>
             <a:pPr lvl="3"/>
             <a:r>
-              <a:rPr lang="en-US" smtClean="0"/>
+              <a:rPr lang="en-US"/>
               <a:t>Fourth level</a:t>
             </a:r>
           </a:p>
           <a:p>
             <a:pPr lvl="4"/>
             <a:r>
-              <a:rPr lang="en-US" smtClean="0"/>
+              <a:rPr lang="en-US"/>
               <a:t>Fifth level</a:t>
             </a:r>
-            <a:endParaRPr lang="en-US"/>
           </a:p>
         </p:txBody>
       </p:sp>
@@ -3858,7 +3737,7 @@
           <a:p>
             <a:pPr lvl="0"/>
             <a:r>
-              <a:rPr lang="en-US" smtClean="0"/>
+              <a:rPr lang="en-US"/>
               <a:t>Click to edit Master text styles</a:t>
             </a:r>
           </a:p>
@@ -3881,7 +3760,7 @@
           <a:p>
             <a:fld id="{5BCAD085-E8A6-8845-BD4E-CB4CCA059FC4}" type="datetimeFigureOut">
               <a:rPr lang="en-US" smtClean="0"/>
-              <a:t>1/27/13</a:t>
+              <a:t>10/27/2026</a:t>
             </a:fld>
             <a:endParaRPr lang="en-US"/>
           </a:p>
@@ -3984,10 +3863,9 @@
           </a:lstStyle>
           <a:p>
             <a:r>
-              <a:rPr lang="en-US" smtClean="0"/>
+              <a:rPr lang="en-US"/>
               <a:t>Click to edit Master title style</a:t>
             </a:r>
-            <a:endParaRPr lang="en-US"/>
           </a:p>
         </p:txBody>
       </p:sp>
@@ -4111,7 +3989,7 @@
           <a:p>
             <a:pPr lvl="0"/>
             <a:r>
-              <a:rPr lang="en-US" smtClean="0"/>
+              <a:rPr lang="en-US"/>
               <a:t>Click to edit Master text styles</a:t>
             </a:r>
           </a:p>
@@ -4134,7 +4012,7 @@
           <a:p>
             <a:fld id="{5BCAD085-E8A6-8845-BD4E-CB4CCA059FC4}" type="datetimeFigureOut">
               <a:rPr lang="en-US" smtClean="0"/>
-              <a:t>1/27/13</a:t>
+              <a:t>10/27/2026</a:t>
             </a:fld>
             <a:endParaRPr lang="en-US"/>
           </a:p>
@@ -4243,10 +4121,9 @@
           <a:lstStyle/>
           <a:p>
             <a:r>
-              <a:rPr lang="en-US" smtClean="0"/>
+              <a:rPr lang="en-US"/>
               <a:t>Click to edit Master title style</a:t>
             </a:r>
-            <a:endParaRPr lang="en-US"/>
           </a:p>
         </p:txBody>
       </p:sp>
@@ -4277,38 +4154,37 @@
           <a:p>
             <a:pPr lvl="0"/>
             <a:r>
-              <a:rPr lang="en-US" smtClean="0"/>
+              <a:rPr lang="en-US"/>
               <a:t>Click to edit Master text styles</a:t>
             </a:r>
           </a:p>
           <a:p>
             <a:pPr lvl="1"/>
             <a:r>
-              <a:rPr lang="en-US" smtClean="0"/>
+              <a:rPr lang="en-US"/>
               <a:t>Second level</a:t>
             </a:r>
           </a:p>
           <a:p>
             <a:pPr lvl="2"/>
             <a:r>
-              <a:rPr lang="en-US" smtClean="0"/>
+              <a:rPr lang="en-US"/>
               <a:t>Third level</a:t>
             </a:r>
           </a:p>
           <a:p>
             <a:pPr lvl="3"/>
             <a:r>
-              <a:rPr lang="en-US" smtClean="0"/>
+              <a:rPr lang="en-US"/>
               <a:t>Fourth level</a:t>
             </a:r>
           </a:p>
           <a:p>
             <a:pPr lvl="4"/>
             <a:r>
-              <a:rPr lang="en-US" smtClean="0"/>
+              <a:rPr lang="en-US"/>
               <a:t>Fifth level</a:t>
             </a:r>
-            <a:endParaRPr lang="en-US"/>
           </a:p>
         </p:txBody>
       </p:sp>
@@ -4347,7 +4223,7 @@
           <a:p>
             <a:fld id="{5BCAD085-E8A6-8845-BD4E-CB4CCA059FC4}" type="datetimeFigureOut">
               <a:rPr lang="en-US" smtClean="0"/>
-              <a:t>1/27/13</a:t>
+              <a:t>10/27/2026</a:t>
             </a:fld>
             <a:endParaRPr lang="en-US"/>
           </a:p>
@@ -4706,7 +4582,7 @@
 </file>
 
 <file path=ppt/slides/slide1.xml><?xml version="1.0" encoding="utf-8"?>
-<p:sld xmlns:a="http://schemas.openxmlformats.org/drawingml/2006/main" xmlns:p="http://schemas.openxmlformats.org/presentationml/2006/main" xmlns:r="http://schemas.openxmlformats.org/officeDocument/2006/relationships">
+<p:sld xmlns:a="http://schemas.openxmlformats.org/drawingml/2006/main" xmlns:r="http://schemas.openxmlformats.org/officeDocument/2006/relationships" xmlns:p="http://schemas.openxmlformats.org/presentationml/2006/main">
   <p:cSld>
     <p:spTree>
       <p:nvGrpSpPr>
@@ -4714,7 +4590,14 @@
         <p:cNvGrpSpPr/>
         <p:nvPr/>
       </p:nvGrpSpPr>
-      <p:grpSpPr/>
+      <p:grpSpPr>
+        <a:xfrm>
+          <a:off x="0" y="0"/>
+          <a:ext cx="0" cy="0"/>
+          <a:chOff x="0" y="0"/>
+          <a:chExt cx="0" cy="0"/>
+        </a:xfrm>
+      </p:grpSpPr>
       <p:sp>
         <p:nvSpPr>
           <p:cNvPr id="2" name="Rectangle 1"/>
@@ -4755,6 +4638,7 @@
           <a:lstStyle/>
           <a:p>
             <a:pPr algn="ctr"/>
+            <a:endParaRPr/>
           </a:p>
         </p:txBody>
       </p:sp>
@@ -4798,6 +4682,7 @@
           <a:lstStyle/>
           <a:p>
             <a:pPr algn="ctr"/>
+            <a:endParaRPr/>
           </a:p>
         </p:txBody>
       </p:sp>
@@ -4889,7 +4774,7 @@
           </a:fontRef>
         </p:style>
         <p:txBody>
-          <a:bodyPr rtlCol="0" anchor="ctr" wrap="square" lIns="274320" tIns="228600"/>
+          <a:bodyPr wrap="square" lIns="274320" tIns="228600" rtlCol="0" anchor="ctr"/>
           <a:lstStyle/>
           <a:p>
             <a:pPr algn="ctr">
@@ -4966,7 +4851,7 @@
           </a:fontRef>
         </p:style>
         <p:txBody>
-          <a:bodyPr rtlCol="0" anchor="ctr" wrap="square" lIns="274320" tIns="228600"/>
+          <a:bodyPr wrap="square" lIns="274320" tIns="228600" rtlCol="0" anchor="ctr"/>
           <a:lstStyle/>
           <a:p>
             <a:pPr algn="ctr">
@@ -5018,7 +4903,7 @@
 </file>
 
 <file path=ppt/slides/slide10.xml><?xml version="1.0" encoding="utf-8"?>
-<p:sld xmlns:a="http://schemas.openxmlformats.org/drawingml/2006/main" xmlns:p="http://schemas.openxmlformats.org/presentationml/2006/main" xmlns:r="http://schemas.openxmlformats.org/officeDocument/2006/relationships">
+<p:sld xmlns:a="http://schemas.openxmlformats.org/drawingml/2006/main" xmlns:r="http://schemas.openxmlformats.org/officeDocument/2006/relationships" xmlns:p="http://schemas.openxmlformats.org/presentationml/2006/main">
   <p:cSld>
     <p:spTree>
       <p:nvGrpSpPr>
@@ -5026,7 +4911,14 @@
         <p:cNvGrpSpPr/>
         <p:nvPr/>
       </p:nvGrpSpPr>
-      <p:grpSpPr/>
+      <p:grpSpPr>
+        <a:xfrm>
+          <a:off x="0" y="0"/>
+          <a:ext cx="0" cy="0"/>
+          <a:chOff x="0" y="0"/>
+          <a:chExt cx="0" cy="0"/>
+        </a:xfrm>
+      </p:grpSpPr>
       <p:sp>
         <p:nvSpPr>
           <p:cNvPr id="2" name="TextBox 1"/>
@@ -5151,11 +5043,41 @@
                 <a:tableStyleId>{5C22544A-7EE6-4342-B048-85BDC9FD1C3A}</a:tableStyleId>
               </a:tblPr>
               <a:tblGrid>
-                <a:gridCol w="1645920"/>
-                <a:gridCol w="1188720"/>
-                <a:gridCol w="1188720"/>
-                <a:gridCol w="1097280"/>
-                <a:gridCol w="1097280"/>
+                <a:gridCol w="1645920">
+                  <a:extLst>
+                    <a:ext uri="{9D8B030D-6E8A-4147-A177-3AD203B41FA5}">
+                      <a16:colId xmlns:a16="http://schemas.microsoft.com/office/drawing/2014/main" val="20000"/>
+                    </a:ext>
+                  </a:extLst>
+                </a:gridCol>
+                <a:gridCol w="1188720">
+                  <a:extLst>
+                    <a:ext uri="{9D8B030D-6E8A-4147-A177-3AD203B41FA5}">
+                      <a16:colId xmlns:a16="http://schemas.microsoft.com/office/drawing/2014/main" val="20001"/>
+                    </a:ext>
+                  </a:extLst>
+                </a:gridCol>
+                <a:gridCol w="1188720">
+                  <a:extLst>
+                    <a:ext uri="{9D8B030D-6E8A-4147-A177-3AD203B41FA5}">
+                      <a16:colId xmlns:a16="http://schemas.microsoft.com/office/drawing/2014/main" val="20002"/>
+                    </a:ext>
+                  </a:extLst>
+                </a:gridCol>
+                <a:gridCol w="1097280">
+                  <a:extLst>
+                    <a:ext uri="{9D8B030D-6E8A-4147-A177-3AD203B41FA5}">
+                      <a16:colId xmlns:a16="http://schemas.microsoft.com/office/drawing/2014/main" val="20003"/>
+                    </a:ext>
+                  </a:extLst>
+                </a:gridCol>
+                <a:gridCol w="1097280">
+                  <a:extLst>
+                    <a:ext uri="{9D8B030D-6E8A-4147-A177-3AD203B41FA5}">
+                      <a16:colId xmlns:a16="http://schemas.microsoft.com/office/drawing/2014/main" val="20004"/>
+                    </a:ext>
+                  </a:extLst>
+                </a:gridCol>
               </a:tblGrid>
               <a:tr h="470262">
                 <a:tc>
@@ -5273,6 +5195,11 @@
                     </a:solidFill>
                   </a:tcPr>
                 </a:tc>
+                <a:extLst>
+                  <a:ext uri="{0D108BD9-81ED-4DB2-BD59-A6C34878D82A}">
+                    <a16:rowId xmlns:a16="http://schemas.microsoft.com/office/drawing/2014/main" val="10000"/>
+                  </a:ext>
+                </a:extLst>
               </a:tr>
               <a:tr h="470262">
                 <a:tc>
@@ -5370,6 +5297,11 @@
                   </a:txBody>
                   <a:tcPr/>
                 </a:tc>
+                <a:extLst>
+                  <a:ext uri="{0D108BD9-81ED-4DB2-BD59-A6C34878D82A}">
+                    <a16:rowId xmlns:a16="http://schemas.microsoft.com/office/drawing/2014/main" val="10001"/>
+                  </a:ext>
+                </a:extLst>
               </a:tr>
               <a:tr h="470262">
                 <a:tc>
@@ -5467,6 +5399,11 @@
                   </a:txBody>
                   <a:tcPr/>
                 </a:tc>
+                <a:extLst>
+                  <a:ext uri="{0D108BD9-81ED-4DB2-BD59-A6C34878D82A}">
+                    <a16:rowId xmlns:a16="http://schemas.microsoft.com/office/drawing/2014/main" val="10002"/>
+                  </a:ext>
+                </a:extLst>
               </a:tr>
               <a:tr h="470262">
                 <a:tc>
@@ -5564,6 +5501,11 @@
                   </a:txBody>
                   <a:tcPr/>
                 </a:tc>
+                <a:extLst>
+                  <a:ext uri="{0D108BD9-81ED-4DB2-BD59-A6C34878D82A}">
+                    <a16:rowId xmlns:a16="http://schemas.microsoft.com/office/drawing/2014/main" val="10003"/>
+                  </a:ext>
+                </a:extLst>
               </a:tr>
               <a:tr h="470262">
                 <a:tc>
@@ -5661,6 +5603,11 @@
                   </a:txBody>
                   <a:tcPr/>
                 </a:tc>
+                <a:extLst>
+                  <a:ext uri="{0D108BD9-81ED-4DB2-BD59-A6C34878D82A}">
+                    <a16:rowId xmlns:a16="http://schemas.microsoft.com/office/drawing/2014/main" val="10004"/>
+                  </a:ext>
+                </a:extLst>
               </a:tr>
               <a:tr h="470262">
                 <a:tc>
@@ -5758,6 +5705,11 @@
                   </a:txBody>
                   <a:tcPr/>
                 </a:tc>
+                <a:extLst>
+                  <a:ext uri="{0D108BD9-81ED-4DB2-BD59-A6C34878D82A}">
+                    <a16:rowId xmlns:a16="http://schemas.microsoft.com/office/drawing/2014/main" val="10005"/>
+                  </a:ext>
+                </a:extLst>
               </a:tr>
               <a:tr h="470268">
                 <a:tc>
@@ -5875,6 +5827,11 @@
                     </a:solidFill>
                   </a:tcPr>
                 </a:tc>
+                <a:extLst>
+                  <a:ext uri="{0D108BD9-81ED-4DB2-BD59-A6C34878D82A}">
+                    <a16:rowId xmlns:a16="http://schemas.microsoft.com/office/drawing/2014/main" val="10006"/>
+                  </a:ext>
+                </a:extLst>
               </a:tr>
             </a:tbl>
           </a:graphicData>
@@ -5918,7 +5875,7 @@
           </a:fontRef>
         </p:style>
         <p:txBody>
-          <a:bodyPr rtlCol="0" anchor="ctr" lIns="182880" tIns="182880"/>
+          <a:bodyPr lIns="182880" tIns="182880" rtlCol="0" anchor="ctr"/>
           <a:lstStyle/>
           <a:p>
             <a:pPr algn="ctr">
@@ -5962,7 +5919,7 @@
           <p:nvPr/>
         </p:nvPicPr>
         <p:blipFill>
-          <a:blip r:embed="rId2"/>
+          <a:blip r:embed="rId3"/>
           <a:stretch>
             <a:fillRect/>
           </a:stretch>
@@ -5986,7 +5943,7 @@
 </file>
 
 <file path=ppt/slides/slide11.xml><?xml version="1.0" encoding="utf-8"?>
-<p:sld xmlns:a="http://schemas.openxmlformats.org/drawingml/2006/main" xmlns:p="http://schemas.openxmlformats.org/presentationml/2006/main" xmlns:r="http://schemas.openxmlformats.org/officeDocument/2006/relationships">
+<p:sld xmlns:a="http://schemas.openxmlformats.org/drawingml/2006/main" xmlns:r="http://schemas.openxmlformats.org/officeDocument/2006/relationships" xmlns:p="http://schemas.openxmlformats.org/presentationml/2006/main">
   <p:cSld>
     <p:spTree>
       <p:nvGrpSpPr>
@@ -5994,7 +5951,14 @@
         <p:cNvGrpSpPr/>
         <p:nvPr/>
       </p:nvGrpSpPr>
-      <p:grpSpPr/>
+      <p:grpSpPr>
+        <a:xfrm>
+          <a:off x="0" y="0"/>
+          <a:ext cx="0" cy="0"/>
+          <a:chOff x="0" y="0"/>
+          <a:chExt cx="0" cy="0"/>
+        </a:xfrm>
+      </p:grpSpPr>
       <p:sp>
         <p:nvSpPr>
           <p:cNvPr id="2" name="TextBox 1"/>
@@ -6138,7 +6102,7 @@
           </a:fontRef>
         </p:style>
         <p:txBody>
-          <a:bodyPr rtlCol="0" anchor="ctr" lIns="274320" tIns="274320"/>
+          <a:bodyPr lIns="274320" tIns="274320" rtlCol="0" anchor="ctr"/>
           <a:lstStyle/>
           <a:p>
             <a:pPr algn="ctr">
@@ -6262,7 +6226,7 @@
           <p:nvPr/>
         </p:nvPicPr>
         <p:blipFill>
-          <a:blip r:embed="rId2"/>
+          <a:blip r:embed="rId3"/>
           <a:stretch>
             <a:fillRect/>
           </a:stretch>
@@ -6286,7 +6250,7 @@
 </file>
 
 <file path=ppt/slides/slide12.xml><?xml version="1.0" encoding="utf-8"?>
-<p:sld xmlns:a="http://schemas.openxmlformats.org/drawingml/2006/main" xmlns:p="http://schemas.openxmlformats.org/presentationml/2006/main" xmlns:r="http://schemas.openxmlformats.org/officeDocument/2006/relationships">
+<p:sld xmlns:a="http://schemas.openxmlformats.org/drawingml/2006/main" xmlns:r="http://schemas.openxmlformats.org/officeDocument/2006/relationships" xmlns:p="http://schemas.openxmlformats.org/presentationml/2006/main">
   <p:cSld>
     <p:spTree>
       <p:nvGrpSpPr>
@@ -6294,7 +6258,14 @@
         <p:cNvGrpSpPr/>
         <p:nvPr/>
       </p:nvGrpSpPr>
-      <p:grpSpPr/>
+      <p:grpSpPr>
+        <a:xfrm>
+          <a:off x="0" y="0"/>
+          <a:ext cx="0" cy="0"/>
+          <a:chOff x="0" y="0"/>
+          <a:chExt cx="0" cy="0"/>
+        </a:xfrm>
+      </p:grpSpPr>
       <p:sp>
         <p:nvSpPr>
           <p:cNvPr id="2" name="TextBox 1"/>
@@ -6438,7 +6409,7 @@
           </a:fontRef>
         </p:style>
         <p:txBody>
-          <a:bodyPr rtlCol="0" anchor="ctr" lIns="228600" tIns="228600"/>
+          <a:bodyPr lIns="228600" tIns="228600" rtlCol="0" anchor="ctr"/>
           <a:lstStyle/>
           <a:p>
             <a:pPr algn="ctr">
@@ -6515,7 +6486,7 @@
           </a:fontRef>
         </p:style>
         <p:txBody>
-          <a:bodyPr rtlCol="0" anchor="ctr" lIns="228600" tIns="228600"/>
+          <a:bodyPr lIns="228600" tIns="228600" rtlCol="0" anchor="ctr"/>
           <a:lstStyle/>
           <a:p>
             <a:pPr algn="ctr">
@@ -6563,7 +6534,7 @@
           <p:nvPr/>
         </p:nvPicPr>
         <p:blipFill>
-          <a:blip r:embed="rId2"/>
+          <a:blip r:embed="rId3"/>
           <a:stretch>
             <a:fillRect/>
           </a:stretch>
@@ -6587,7 +6558,7 @@
 </file>
 
 <file path=ppt/slides/slide13.xml><?xml version="1.0" encoding="utf-8"?>
-<p:sld xmlns:a="http://schemas.openxmlformats.org/drawingml/2006/main" xmlns:p="http://schemas.openxmlformats.org/presentationml/2006/main" xmlns:r="http://schemas.openxmlformats.org/officeDocument/2006/relationships">
+<p:sld xmlns:a="http://schemas.openxmlformats.org/drawingml/2006/main" xmlns:r="http://schemas.openxmlformats.org/officeDocument/2006/relationships" xmlns:p="http://schemas.openxmlformats.org/presentationml/2006/main">
   <p:cSld>
     <p:spTree>
       <p:nvGrpSpPr>
@@ -6595,7 +6566,14 @@
         <p:cNvGrpSpPr/>
         <p:nvPr/>
       </p:nvGrpSpPr>
-      <p:grpSpPr/>
+      <p:grpSpPr>
+        <a:xfrm>
+          <a:off x="0" y="0"/>
+          <a:ext cx="0" cy="0"/>
+          <a:chOff x="0" y="0"/>
+          <a:chExt cx="0" cy="0"/>
+        </a:xfrm>
+      </p:grpSpPr>
       <p:sp>
         <p:nvSpPr>
           <p:cNvPr id="2" name="TextBox 1"/>
@@ -6739,7 +6717,7 @@
           </a:fontRef>
         </p:style>
         <p:txBody>
-          <a:bodyPr rtlCol="0" anchor="ctr" lIns="274320" tIns="274320"/>
+          <a:bodyPr lIns="274320" tIns="274320" rtlCol="0" anchor="ctr"/>
           <a:lstStyle/>
           <a:p>
             <a:pPr algn="ctr">
@@ -6808,7 +6786,7 @@
           </a:fontRef>
         </p:style>
         <p:txBody>
-          <a:bodyPr rtlCol="0" anchor="ctr" lIns="274320" tIns="274320"/>
+          <a:bodyPr lIns="274320" tIns="274320" rtlCol="0" anchor="ctr"/>
           <a:lstStyle/>
           <a:p>
             <a:pPr algn="ctr">
@@ -6877,7 +6855,7 @@
           </a:fontRef>
         </p:style>
         <p:txBody>
-          <a:bodyPr rtlCol="0" anchor="ctr" lIns="274320" tIns="274320"/>
+          <a:bodyPr lIns="274320" tIns="274320" rtlCol="0" anchor="ctr"/>
           <a:lstStyle/>
           <a:p>
             <a:pPr algn="ctr">
@@ -6917,7 +6895,7 @@
 </file>
 
 <file path=ppt/slides/slide14.xml><?xml version="1.0" encoding="utf-8"?>
-<p:sld xmlns:a="http://schemas.openxmlformats.org/drawingml/2006/main" xmlns:p="http://schemas.openxmlformats.org/presentationml/2006/main" xmlns:r="http://schemas.openxmlformats.org/officeDocument/2006/relationships">
+<p:sld xmlns:a="http://schemas.openxmlformats.org/drawingml/2006/main" xmlns:r="http://schemas.openxmlformats.org/officeDocument/2006/relationships" xmlns:p="http://schemas.openxmlformats.org/presentationml/2006/main">
   <p:cSld>
     <p:spTree>
       <p:nvGrpSpPr>
@@ -6925,7 +6903,14 @@
         <p:cNvGrpSpPr/>
         <p:nvPr/>
       </p:nvGrpSpPr>
-      <p:grpSpPr/>
+      <p:grpSpPr>
+        <a:xfrm>
+          <a:off x="0" y="0"/>
+          <a:ext cx="0" cy="0"/>
+          <a:chOff x="0" y="0"/>
+          <a:chExt cx="0" cy="0"/>
+        </a:xfrm>
+      </p:grpSpPr>
       <p:sp>
         <p:nvSpPr>
           <p:cNvPr id="2" name="TextBox 1"/>
@@ -7069,7 +7054,7 @@
           </a:fontRef>
         </p:style>
         <p:txBody>
-          <a:bodyPr rtlCol="0" anchor="ctr" lIns="274320" tIns="274320"/>
+          <a:bodyPr lIns="274320" tIns="274320" rtlCol="0" anchor="ctr"/>
           <a:lstStyle/>
           <a:p>
             <a:pPr algn="ctr">
@@ -7138,7 +7123,7 @@
           </a:fontRef>
         </p:style>
         <p:txBody>
-          <a:bodyPr rtlCol="0" anchor="ctr" lIns="274320" tIns="274320"/>
+          <a:bodyPr lIns="274320" tIns="274320" rtlCol="0" anchor="ctr"/>
           <a:lstStyle/>
           <a:p>
             <a:pPr algn="ctr">
@@ -7207,7 +7192,7 @@
           </a:fontRef>
         </p:style>
         <p:txBody>
-          <a:bodyPr rtlCol="0" anchor="ctr" lIns="274320" tIns="274320"/>
+          <a:bodyPr lIns="274320" tIns="274320" rtlCol="0" anchor="ctr"/>
           <a:lstStyle/>
           <a:p>
             <a:pPr algn="ctr">
@@ -7276,7 +7261,7 @@
           </a:fontRef>
         </p:style>
         <p:txBody>
-          <a:bodyPr rtlCol="0" anchor="ctr" lIns="274320" tIns="274320"/>
+          <a:bodyPr lIns="274320" tIns="274320" rtlCol="0" anchor="ctr"/>
           <a:lstStyle/>
           <a:p>
             <a:pPr algn="ctr">
@@ -7316,7 +7301,7 @@
 </file>
 
 <file path=ppt/slides/slide15.xml><?xml version="1.0" encoding="utf-8"?>
-<p:sld xmlns:a="http://schemas.openxmlformats.org/drawingml/2006/main" xmlns:p="http://schemas.openxmlformats.org/presentationml/2006/main" xmlns:r="http://schemas.openxmlformats.org/officeDocument/2006/relationships">
+<p:sld xmlns:a="http://schemas.openxmlformats.org/drawingml/2006/main" xmlns:r="http://schemas.openxmlformats.org/officeDocument/2006/relationships" xmlns:p="http://schemas.openxmlformats.org/presentationml/2006/main">
   <p:cSld>
     <p:spTree>
       <p:nvGrpSpPr>
@@ -7324,7 +7309,14 @@
         <p:cNvGrpSpPr/>
         <p:nvPr/>
       </p:nvGrpSpPr>
-      <p:grpSpPr/>
+      <p:grpSpPr>
+        <a:xfrm>
+          <a:off x="0" y="0"/>
+          <a:ext cx="0" cy="0"/>
+          <a:chOff x="0" y="0"/>
+          <a:chExt cx="0" cy="0"/>
+        </a:xfrm>
+      </p:grpSpPr>
       <p:sp>
         <p:nvSpPr>
           <p:cNvPr id="2" name="TextBox 1"/>
@@ -7468,7 +7460,7 @@
           </a:fontRef>
         </p:style>
         <p:txBody>
-          <a:bodyPr rtlCol="0" anchor="ctr" lIns="274320" tIns="274320"/>
+          <a:bodyPr lIns="274320" tIns="274320" rtlCol="0" anchor="ctr"/>
           <a:lstStyle/>
           <a:p>
             <a:pPr algn="ctr">
@@ -7559,7 +7551,7 @@
           </a:fontRef>
         </p:style>
         <p:txBody>
-          <a:bodyPr rtlCol="0" anchor="ctr" lIns="274320" tIns="274320"/>
+          <a:bodyPr lIns="274320" tIns="274320" rtlCol="0" anchor="ctr"/>
           <a:lstStyle/>
           <a:p>
             <a:pPr algn="ctr">
@@ -7621,7 +7613,7 @@
 </file>
 
 <file path=ppt/slides/slide16.xml><?xml version="1.0" encoding="utf-8"?>
-<p:sld xmlns:a="http://schemas.openxmlformats.org/drawingml/2006/main" xmlns:p="http://schemas.openxmlformats.org/presentationml/2006/main" xmlns:r="http://schemas.openxmlformats.org/officeDocument/2006/relationships">
+<p:sld xmlns:a="http://schemas.openxmlformats.org/drawingml/2006/main" xmlns:r="http://schemas.openxmlformats.org/officeDocument/2006/relationships" xmlns:p="http://schemas.openxmlformats.org/presentationml/2006/main">
   <p:cSld>
     <p:spTree>
       <p:nvGrpSpPr>
@@ -7629,7 +7621,14 @@
         <p:cNvGrpSpPr/>
         <p:nvPr/>
       </p:nvGrpSpPr>
-      <p:grpSpPr/>
+      <p:grpSpPr>
+        <a:xfrm>
+          <a:off x="0" y="0"/>
+          <a:ext cx="0" cy="0"/>
+          <a:chOff x="0" y="0"/>
+          <a:chExt cx="0" cy="0"/>
+        </a:xfrm>
+      </p:grpSpPr>
       <p:sp>
         <p:nvSpPr>
           <p:cNvPr id="2" name="TextBox 1"/>
@@ -7773,7 +7772,7 @@
           </a:fontRef>
         </p:style>
         <p:txBody>
-          <a:bodyPr rtlCol="0" anchor="ctr" lIns="365760" tIns="365760"/>
+          <a:bodyPr lIns="365760" tIns="365760" rtlCol="0" anchor="ctr"/>
           <a:lstStyle/>
           <a:p>
             <a:pPr algn="ctr">
@@ -7858,7 +7857,7 @@
 </file>
 
 <file path=ppt/slides/slide17.xml><?xml version="1.0" encoding="utf-8"?>
-<p:sld xmlns:a="http://schemas.openxmlformats.org/drawingml/2006/main" xmlns:p="http://schemas.openxmlformats.org/presentationml/2006/main" xmlns:r="http://schemas.openxmlformats.org/officeDocument/2006/relationships">
+<p:sld xmlns:a="http://schemas.openxmlformats.org/drawingml/2006/main" xmlns:r="http://schemas.openxmlformats.org/officeDocument/2006/relationships" xmlns:p="http://schemas.openxmlformats.org/presentationml/2006/main">
   <p:cSld>
     <p:spTree>
       <p:nvGrpSpPr>
@@ -7866,7 +7865,14 @@
         <p:cNvGrpSpPr/>
         <p:nvPr/>
       </p:nvGrpSpPr>
-      <p:grpSpPr/>
+      <p:grpSpPr>
+        <a:xfrm>
+          <a:off x="0" y="0"/>
+          <a:ext cx="0" cy="0"/>
+          <a:chOff x="0" y="0"/>
+          <a:chExt cx="0" cy="0"/>
+        </a:xfrm>
+      </p:grpSpPr>
       <p:sp>
         <p:nvSpPr>
           <p:cNvPr id="2" name="TextBox 1"/>
@@ -8010,7 +8016,7 @@
           </a:fontRef>
         </p:style>
         <p:txBody>
-          <a:bodyPr rtlCol="0" anchor="ctr" lIns="228600" tIns="228600"/>
+          <a:bodyPr lIns="228600" tIns="228600" rtlCol="0" anchor="ctr"/>
           <a:lstStyle/>
           <a:p>
             <a:pPr algn="ctr">
@@ -8079,7 +8085,7 @@
           </a:fontRef>
         </p:style>
         <p:txBody>
-          <a:bodyPr rtlCol="0" anchor="ctr" lIns="228600" tIns="228600"/>
+          <a:bodyPr lIns="228600" tIns="228600" rtlCol="0" anchor="ctr"/>
           <a:lstStyle/>
           <a:p>
             <a:pPr algn="ctr">
@@ -8148,7 +8154,7 @@
           </a:fontRef>
         </p:style>
         <p:txBody>
-          <a:bodyPr rtlCol="0" anchor="ctr" lIns="228600" tIns="228600"/>
+          <a:bodyPr lIns="228600" tIns="228600" rtlCol="0" anchor="ctr"/>
           <a:lstStyle/>
           <a:p>
             <a:pPr algn="ctr">
@@ -8188,7 +8194,7 @@
 </file>
 
 <file path=ppt/slides/slide18.xml><?xml version="1.0" encoding="utf-8"?>
-<p:sld xmlns:a="http://schemas.openxmlformats.org/drawingml/2006/main" xmlns:p="http://schemas.openxmlformats.org/presentationml/2006/main" xmlns:r="http://schemas.openxmlformats.org/officeDocument/2006/relationships">
+<p:sld xmlns:a="http://schemas.openxmlformats.org/drawingml/2006/main" xmlns:r="http://schemas.openxmlformats.org/officeDocument/2006/relationships" xmlns:p="http://schemas.openxmlformats.org/presentationml/2006/main">
   <p:cSld>
     <p:spTree>
       <p:nvGrpSpPr>
@@ -8196,7 +8202,14 @@
         <p:cNvGrpSpPr/>
         <p:nvPr/>
       </p:nvGrpSpPr>
-      <p:grpSpPr/>
+      <p:grpSpPr>
+        <a:xfrm>
+          <a:off x="0" y="0"/>
+          <a:ext cx="0" cy="0"/>
+          <a:chOff x="0" y="0"/>
+          <a:chExt cx="0" cy="0"/>
+        </a:xfrm>
+      </p:grpSpPr>
       <p:sp>
         <p:nvSpPr>
           <p:cNvPr id="2" name="Rectangle 1"/>
@@ -8237,6 +8250,7 @@
           <a:lstStyle/>
           <a:p>
             <a:pPr algn="ctr"/>
+            <a:endParaRPr/>
           </a:p>
         </p:txBody>
       </p:sp>
@@ -8328,7 +8342,7 @@
           </a:fontRef>
         </p:style>
         <p:txBody>
-          <a:bodyPr rtlCol="0" anchor="ctr" lIns="320040" tIns="320040"/>
+          <a:bodyPr lIns="320040" tIns="320040" rtlCol="0" anchor="ctr"/>
           <a:lstStyle/>
           <a:p>
             <a:pPr algn="ctr">
@@ -8419,7 +8433,7 @@
           </a:fontRef>
         </p:style>
         <p:txBody>
-          <a:bodyPr rtlCol="0" anchor="ctr" lIns="320040" tIns="320040"/>
+          <a:bodyPr lIns="320040" tIns="320040" rtlCol="0" anchor="ctr"/>
           <a:lstStyle/>
           <a:p>
             <a:pPr algn="ctr">
@@ -8481,7 +8495,7 @@
 </file>
 
 <file path=ppt/slides/slide2.xml><?xml version="1.0" encoding="utf-8"?>
-<p:sld xmlns:a="http://schemas.openxmlformats.org/drawingml/2006/main" xmlns:p="http://schemas.openxmlformats.org/presentationml/2006/main" xmlns:r="http://schemas.openxmlformats.org/officeDocument/2006/relationships">
+<p:sld xmlns:a="http://schemas.openxmlformats.org/drawingml/2006/main" xmlns:r="http://schemas.openxmlformats.org/officeDocument/2006/relationships" xmlns:p="http://schemas.openxmlformats.org/presentationml/2006/main">
   <p:cSld>
     <p:spTree>
       <p:nvGrpSpPr>
@@ -8489,7 +8503,14 @@
         <p:cNvGrpSpPr/>
         <p:nvPr/>
       </p:nvGrpSpPr>
-      <p:grpSpPr/>
+      <p:grpSpPr>
+        <a:xfrm>
+          <a:off x="0" y="0"/>
+          <a:ext cx="0" cy="0"/>
+          <a:chOff x="0" y="0"/>
+          <a:chExt cx="0" cy="0"/>
+        </a:xfrm>
+      </p:grpSpPr>
       <p:sp>
         <p:nvSpPr>
           <p:cNvPr id="2" name="TextBox 1"/>
@@ -8555,6 +8576,7 @@
               </a:defRPr>
             </a:pPr>
             <a:r>
+              <a:rPr dirty="0"/>
               <a:t>Cross-Center Stain and Scanner Variability Degrades Deep Pathology Models</a:t>
             </a:r>
           </a:p>
@@ -8633,7 +8655,7 @@
           </a:fontRef>
         </p:style>
         <p:txBody>
-          <a:bodyPr rtlCol="0" anchor="ctr" lIns="274320" tIns="274320"/>
+          <a:bodyPr lIns="274320" tIns="274320" rtlCol="0" anchor="ctr"/>
           <a:lstStyle/>
           <a:p>
             <a:pPr algn="ctr">
@@ -8644,6 +8666,7 @@
               </a:defRPr>
             </a:pPr>
             <a:r>
+              <a:rPr dirty="0"/>
               <a:t>The Reality of Clinical Deployment</a:t>
             </a:r>
           </a:p>
@@ -8659,14 +8682,21 @@
               </a:defRPr>
             </a:pPr>
             <a:r>
+              <a:rPr dirty="0"/>
               <a:t>• Digital pathology models fail when transferred across clinical institutions.</a:t>
             </a:r>
-            <a:br/>
-            <a:r>
+            <a:br>
+              <a:rPr dirty="0"/>
+            </a:br>
+            <a:r>
+              <a:rPr dirty="0"/>
               <a:t>• Variations in tissue microtomy, histochemical staining batches (H&amp;E), and scanner sensor optics induce massive, unpredictable domain shifts.</a:t>
             </a:r>
-            <a:br/>
-            <a:r>
+            <a:br>
+              <a:rPr dirty="0"/>
+            </a:br>
+            <a:r>
+              <a:rPr dirty="0"/>
               <a:t>• Retraining is legally prohibited: Patient privacy regulations (HIPAA, GDPR) strictly forbid sharing raw whole-slide images (WSIs) across hospitals.</a:t>
             </a:r>
           </a:p>
@@ -8710,7 +8740,7 @@
           </a:fontRef>
         </p:style>
         <p:txBody>
-          <a:bodyPr rtlCol="0" anchor="ctr" lIns="274320" tIns="274320"/>
+          <a:bodyPr lIns="274320" tIns="274320" rtlCol="0" anchor="ctr"/>
           <a:lstStyle/>
           <a:p>
             <a:pPr algn="ctr">
@@ -8787,7 +8817,7 @@
           </a:fontRef>
         </p:style>
         <p:txBody>
-          <a:bodyPr rtlCol="0" anchor="ctr" lIns="320040" tIns="320040"/>
+          <a:bodyPr lIns="320040" tIns="320040" rtlCol="0" anchor="ctr"/>
           <a:lstStyle/>
           <a:p>
             <a:pPr algn="ctr">
@@ -8798,6 +8828,7 @@
               </a:defRPr>
             </a:pPr>
             <a:r>
+              <a:rPr dirty="0"/>
               <a:t>THE CLINICAL TRANSFER GAP</a:t>
             </a:r>
           </a:p>
@@ -8813,7 +8844,16 @@
               </a:defRPr>
             </a:pPr>
             <a:r>
-              <a:t>-28%</a:t>
+              <a:rPr dirty="0"/>
+              <a:t>-</a:t>
+            </a:r>
+            <a:r>
+              <a:rPr lang="en-IN" dirty="0"/>
+              <a:t>28</a:t>
+            </a:r>
+            <a:r>
+              <a:rPr dirty="0"/>
+              <a:t>%</a:t>
             </a:r>
           </a:p>
           <a:p>
@@ -8828,11 +8868,17 @@
               </a:defRPr>
             </a:pPr>
             <a:r>
+              <a:rPr dirty="0"/>
               <a:t>Sensitivity Drop on Unseen Hospital Slides</a:t>
             </a:r>
-            <a:br/>
-            <a:br/>
-            <a:r>
+            <a:br>
+              <a:rPr dirty="0"/>
+            </a:br>
+            <a:br>
+              <a:rPr dirty="0"/>
+            </a:br>
+            <a:r>
+              <a:rPr dirty="0"/>
               <a:t>Transferring a ResNet-18 trained on Camelyon17 Centers 0, 3, 4 to unseen Center 2 drops metastasis detection sensitivity by up to 28% due to histochemical stain disparity.</a:t>
             </a:r>
           </a:p>
@@ -8848,6 +8894,7 @@
               </a:defRPr>
             </a:pPr>
             <a:r>
+              <a:rPr dirty="0"/>
               <a:t>Camelyon17 Benchmark: 455,954 patches across 5 clinical centers.</a:t>
             </a:r>
           </a:p>
@@ -8862,7 +8909,7 @@
 </file>
 
 <file path=ppt/slides/slide3.xml><?xml version="1.0" encoding="utf-8"?>
-<p:sld xmlns:a="http://schemas.openxmlformats.org/drawingml/2006/main" xmlns:p="http://schemas.openxmlformats.org/presentationml/2006/main" xmlns:r="http://schemas.openxmlformats.org/officeDocument/2006/relationships">
+<p:sld xmlns:a="http://schemas.openxmlformats.org/drawingml/2006/main" xmlns:r="http://schemas.openxmlformats.org/officeDocument/2006/relationships" xmlns:p="http://schemas.openxmlformats.org/presentationml/2006/main">
   <p:cSld>
     <p:spTree>
       <p:nvGrpSpPr>
@@ -8870,7 +8917,14 @@
         <p:cNvGrpSpPr/>
         <p:nvPr/>
       </p:nvGrpSpPr>
-      <p:grpSpPr/>
+      <p:grpSpPr>
+        <a:xfrm>
+          <a:off x="0" y="0"/>
+          <a:ext cx="0" cy="0"/>
+          <a:chOff x="0" y="0"/>
+          <a:chExt cx="0" cy="0"/>
+        </a:xfrm>
+      </p:grpSpPr>
       <p:sp>
         <p:nvSpPr>
           <p:cNvPr id="2" name="TextBox 1"/>
@@ -8971,7 +9025,12 @@
               </a:defRPr>
             </a:pPr>
             <a:r>
-              <a:t>SafeAdapt: Geometry-Preserving Optimal Transport in Digital Pathology  |  IEEE TMI 2026  |  DOI: 10.5281/zenodo.23658430          Slide 3 of 18</a:t>
+              <a:rPr dirty="0" err="1"/>
+              <a:t>SafeAdapt</a:t>
+            </a:r>
+            <a:r>
+              <a:rPr dirty="0"/>
+              <a:t>: Geometry-Preserving Optimal Transport in Digital Pathology  |  IEEE TMI 2026  |  DOI: 10.5281/zenodo.23658430          Slide 3 of 18</a:t>
             </a:r>
           </a:p>
         </p:txBody>
@@ -8984,7 +9043,7 @@
         </p:nvSpPr>
         <p:spPr>
           <a:xfrm>
-            <a:off x="731520" y="1463040"/>
+            <a:off x="426720" y="1289304"/>
             <a:ext cx="5669280" cy="4663440"/>
           </a:xfrm>
           <a:prstGeom prst="roundRect">
@@ -9014,7 +9073,7 @@
           </a:fontRef>
         </p:style>
         <p:txBody>
-          <a:bodyPr rtlCol="0" anchor="ctr" lIns="274320" tIns="274320"/>
+          <a:bodyPr lIns="274320" tIns="274320" rtlCol="0" anchor="ctr"/>
           <a:lstStyle/>
           <a:p>
             <a:pPr algn="ctr">
@@ -9025,6 +9084,7 @@
               </a:defRPr>
             </a:pPr>
             <a:r>
+              <a:rPr dirty="0"/>
               <a:t>Unconstrained Entropy Minimization (Tent, ICLR'21)</a:t>
             </a:r>
           </a:p>
@@ -9040,10 +9100,22 @@
               </a:defRPr>
             </a:pPr>
             <a:r>
-              <a:t>• Adapts BatchNorm affine parameters (scale γ, shift β) by minimizing Shannon entropy: L = -Σ p log p.</a:t>
-            </a:r>
-            <a:br/>
-            <a:r>
+              <a:rPr dirty="0"/>
+              <a:t>• Adapts </a:t>
+            </a:r>
+            <a:r>
+              <a:rPr dirty="0" err="1"/>
+              <a:t>BatchNorm</a:t>
+            </a:r>
+            <a:r>
+              <a:rPr dirty="0"/>
+              <a:t> affine parameters (scale γ, shift β) by minimizing Shannon entropy: L = -Σ p log p.</a:t>
+            </a:r>
+            <a:br>
+              <a:rPr dirty="0"/>
+            </a:br>
+            <a:r>
+              <a:rPr dirty="0"/>
               <a:t>• Underlying Assumption: Confident predictions reflect correct target domain alignment.</a:t>
             </a:r>
           </a:p>
@@ -9059,6 +9131,7 @@
               </a:defRPr>
             </a:pPr>
             <a:r>
+              <a:rPr dirty="0"/>
               <a:t>The Discovery: 40% Collapse Rate on Real Pathology</a:t>
             </a:r>
           </a:p>
@@ -9074,22 +9147,35 @@
               </a:defRPr>
             </a:pPr>
             <a:r>
+              <a:rPr dirty="0"/>
               <a:t>• Across 5 random seeds on Camelyon17 (N = 85,054 target patches):</a:t>
             </a:r>
-            <a:br/>
-            <a:r>
+            <a:br>
+              <a:rPr dirty="0"/>
+            </a:br>
+            <a:r>
+              <a:rPr dirty="0"/>
               <a:t>   - Tent collapses on 2 out of 5 seeds (Seeds 7 and 99).</a:t>
             </a:r>
-            <a:br/>
-            <a:r>
+            <a:br>
+              <a:rPr dirty="0"/>
+            </a:br>
+            <a:r>
+              <a:rPr dirty="0"/>
               <a:t>   - Macro AUROC drops from 0.930 to 0.3429 (worse than random guessing!).</a:t>
             </a:r>
-            <a:br/>
-            <a:r>
+            <a:br>
+              <a:rPr dirty="0"/>
+            </a:br>
+            <a:r>
+              <a:rPr dirty="0"/>
               <a:t>   - Sensitivity collapses to &lt; 3% (misses almost all cancer).</a:t>
             </a:r>
-            <a:br/>
-            <a:r>
+            <a:br>
+              <a:rPr dirty="0"/>
+            </a:br>
+            <a:r>
+              <a:rPr dirty="0"/>
               <a:t>   - Harmful adaptation rate reaches 18.7% ± 17.9%.</a:t>
             </a:r>
           </a:p>
@@ -9104,15 +9190,15 @@
           <p:nvPr/>
         </p:nvPicPr>
         <p:blipFill>
-          <a:blip r:embed="rId2"/>
+          <a:blip r:embed="rId3"/>
           <a:stretch>
             <a:fillRect/>
           </a:stretch>
         </p:blipFill>
         <p:spPr>
           <a:xfrm>
-            <a:off x="6675120" y="1463040"/>
-            <a:ext cx="4754880" cy="3291840"/>
+            <a:off x="6400800" y="1645920"/>
+            <a:ext cx="5190744" cy="3593592"/>
           </a:xfrm>
           <a:prstGeom prst="rect">
             <a:avLst/>
@@ -9128,7 +9214,7 @@
 </file>
 
 <file path=ppt/slides/slide4.xml><?xml version="1.0" encoding="utf-8"?>
-<p:sld xmlns:a="http://schemas.openxmlformats.org/drawingml/2006/main" xmlns:p="http://schemas.openxmlformats.org/presentationml/2006/main" xmlns:r="http://schemas.openxmlformats.org/officeDocument/2006/relationships">
+<p:sld xmlns:a="http://schemas.openxmlformats.org/drawingml/2006/main" xmlns:r="http://schemas.openxmlformats.org/officeDocument/2006/relationships" xmlns:p="http://schemas.openxmlformats.org/presentationml/2006/main">
   <p:cSld>
     <p:spTree>
       <p:nvGrpSpPr>
@@ -9136,7 +9222,14 @@
         <p:cNvGrpSpPr/>
         <p:nvPr/>
       </p:nvGrpSpPr>
-      <p:grpSpPr/>
+      <p:grpSpPr>
+        <a:xfrm>
+          <a:off x="0" y="0"/>
+          <a:ext cx="0" cy="0"/>
+          <a:chOff x="0" y="0"/>
+          <a:chExt cx="0" cy="0"/>
+        </a:xfrm>
+      </p:grpSpPr>
       <p:sp>
         <p:nvSpPr>
           <p:cNvPr id="2" name="TextBox 1"/>
@@ -9280,7 +9373,7 @@
           </a:fontRef>
         </p:style>
         <p:txBody>
-          <a:bodyPr rtlCol="0" anchor="ctr" lIns="274320" tIns="274320"/>
+          <a:bodyPr lIns="274320" tIns="274320" rtlCol="0" anchor="ctr"/>
           <a:lstStyle/>
           <a:p>
             <a:pPr algn="ctr">
@@ -9349,7 +9442,7 @@
           </a:fontRef>
         </p:style>
         <p:txBody>
-          <a:bodyPr rtlCol="0" anchor="ctr" lIns="274320" tIns="274320"/>
+          <a:bodyPr lIns="274320" tIns="274320" rtlCol="0" anchor="ctr"/>
           <a:lstStyle/>
           <a:p>
             <a:pPr algn="ctr">
@@ -9418,7 +9511,7 @@
           </a:fontRef>
         </p:style>
         <p:txBody>
-          <a:bodyPr rtlCol="0" anchor="ctr" lIns="274320" tIns="274320"/>
+          <a:bodyPr lIns="274320" tIns="274320" rtlCol="0" anchor="ctr"/>
           <a:lstStyle/>
           <a:p>
             <a:pPr algn="ctr">
@@ -9487,7 +9580,7 @@
           </a:fontRef>
         </p:style>
         <p:txBody>
-          <a:bodyPr rtlCol="0" anchor="ctr" lIns="274320" tIns="274320"/>
+          <a:bodyPr lIns="274320" tIns="274320" rtlCol="0" anchor="ctr"/>
           <a:lstStyle/>
           <a:p>
             <a:pPr algn="ctr">
@@ -9527,7 +9620,7 @@
 </file>
 
 <file path=ppt/slides/slide5.xml><?xml version="1.0" encoding="utf-8"?>
-<p:sld xmlns:a="http://schemas.openxmlformats.org/drawingml/2006/main" xmlns:p="http://schemas.openxmlformats.org/presentationml/2006/main" xmlns:r="http://schemas.openxmlformats.org/officeDocument/2006/relationships">
+<p:sld xmlns:a="http://schemas.openxmlformats.org/drawingml/2006/main" xmlns:r="http://schemas.openxmlformats.org/officeDocument/2006/relationships" xmlns:p="http://schemas.openxmlformats.org/presentationml/2006/main">
   <p:cSld>
     <p:spTree>
       <p:nvGrpSpPr>
@@ -9535,7 +9628,14 @@
         <p:cNvGrpSpPr/>
         <p:nvPr/>
       </p:nvGrpSpPr>
-      <p:grpSpPr/>
+      <p:grpSpPr>
+        <a:xfrm>
+          <a:off x="0" y="0"/>
+          <a:ext cx="0" cy="0"/>
+          <a:chOff x="0" y="0"/>
+          <a:chExt cx="0" cy="0"/>
+        </a:xfrm>
+      </p:grpSpPr>
       <p:sp>
         <p:nvSpPr>
           <p:cNvPr id="2" name="TextBox 1"/>
@@ -9679,7 +9779,7 @@
           </a:fontRef>
         </p:style>
         <p:txBody>
-          <a:bodyPr rtlCol="0" anchor="ctr" lIns="274320" tIns="274320"/>
+          <a:bodyPr lIns="274320" tIns="274320" rtlCol="0" anchor="ctr"/>
           <a:lstStyle/>
           <a:p>
             <a:pPr algn="ctr">
@@ -9748,7 +9848,7 @@
           </a:fontRef>
         </p:style>
         <p:txBody>
-          <a:bodyPr rtlCol="0" anchor="ctr" lIns="274320" tIns="274320"/>
+          <a:bodyPr lIns="274320" tIns="274320" rtlCol="0" anchor="ctr"/>
           <a:lstStyle/>
           <a:p>
             <a:pPr algn="ctr">
@@ -9817,7 +9917,7 @@
           </a:fontRef>
         </p:style>
         <p:txBody>
-          <a:bodyPr rtlCol="0" anchor="ctr" lIns="274320" tIns="274320"/>
+          <a:bodyPr lIns="274320" tIns="274320" rtlCol="0" anchor="ctr"/>
           <a:lstStyle/>
           <a:p>
             <a:pPr algn="ctr">
@@ -9886,7 +9986,7 @@
           </a:fontRef>
         </p:style>
         <p:txBody>
-          <a:bodyPr rtlCol="0" anchor="ctr" lIns="274320" tIns="274320"/>
+          <a:bodyPr lIns="274320" tIns="274320" rtlCol="0" anchor="ctr"/>
           <a:lstStyle/>
           <a:p>
             <a:pPr algn="ctr">
@@ -9926,7 +10026,7 @@
 </file>
 
 <file path=ppt/slides/slide6.xml><?xml version="1.0" encoding="utf-8"?>
-<p:sld xmlns:a="http://schemas.openxmlformats.org/drawingml/2006/main" xmlns:p="http://schemas.openxmlformats.org/presentationml/2006/main" xmlns:r="http://schemas.openxmlformats.org/officeDocument/2006/relationships">
+<p:sld xmlns:a="http://schemas.openxmlformats.org/drawingml/2006/main" xmlns:r="http://schemas.openxmlformats.org/officeDocument/2006/relationships" xmlns:p="http://schemas.openxmlformats.org/presentationml/2006/main">
   <p:cSld>
     <p:spTree>
       <p:nvGrpSpPr>
@@ -9934,7 +10034,14 @@
         <p:cNvGrpSpPr/>
         <p:nvPr/>
       </p:nvGrpSpPr>
-      <p:grpSpPr/>
+      <p:grpSpPr>
+        <a:xfrm>
+          <a:off x="0" y="0"/>
+          <a:ext cx="0" cy="0"/>
+          <a:chOff x="0" y="0"/>
+          <a:chExt cx="0" cy="0"/>
+        </a:xfrm>
+      </p:grpSpPr>
       <p:sp>
         <p:nvSpPr>
           <p:cNvPr id="2" name="TextBox 1"/>
@@ -10049,15 +10156,15 @@
           <p:nvPr/>
         </p:nvPicPr>
         <p:blipFill>
-          <a:blip r:embed="rId2"/>
+          <a:blip r:embed="rId3"/>
           <a:stretch>
             <a:fillRect/>
           </a:stretch>
         </p:blipFill>
         <p:spPr>
           <a:xfrm>
-            <a:off x="731520" y="1371600"/>
-            <a:ext cx="10698480" cy="6354878"/>
+            <a:off x="731520" y="1005840"/>
+            <a:ext cx="9390888" cy="5578171"/>
           </a:xfrm>
           <a:prstGeom prst="rect">
             <a:avLst/>
@@ -10073,7 +10180,7 @@
 </file>
 
 <file path=ppt/slides/slide7.xml><?xml version="1.0" encoding="utf-8"?>
-<p:sld xmlns:a="http://schemas.openxmlformats.org/drawingml/2006/main" xmlns:p="http://schemas.openxmlformats.org/presentationml/2006/main" xmlns:r="http://schemas.openxmlformats.org/officeDocument/2006/relationships">
+<p:sld xmlns:a="http://schemas.openxmlformats.org/drawingml/2006/main" xmlns:r="http://schemas.openxmlformats.org/officeDocument/2006/relationships" xmlns:p="http://schemas.openxmlformats.org/presentationml/2006/main">
   <p:cSld>
     <p:spTree>
       <p:nvGrpSpPr>
@@ -10081,7 +10188,14 @@
         <p:cNvGrpSpPr/>
         <p:nvPr/>
       </p:nvGrpSpPr>
-      <p:grpSpPr/>
+      <p:grpSpPr>
+        <a:xfrm>
+          <a:off x="0" y="0"/>
+          <a:ext cx="0" cy="0"/>
+          <a:chOff x="0" y="0"/>
+          <a:chExt cx="0" cy="0"/>
+        </a:xfrm>
+      </p:grpSpPr>
       <p:sp>
         <p:nvSpPr>
           <p:cNvPr id="2" name="TextBox 1"/>
@@ -10195,7 +10309,7 @@
         </p:nvSpPr>
         <p:spPr>
           <a:xfrm>
-            <a:off x="731520" y="1463040"/>
+            <a:off x="332234" y="1463040"/>
             <a:ext cx="5486400" cy="4663440"/>
           </a:xfrm>
           <a:prstGeom prst="roundRect">
@@ -10225,7 +10339,7 @@
           </a:fontRef>
         </p:style>
         <p:txBody>
-          <a:bodyPr rtlCol="0" anchor="ctr" lIns="274320" tIns="274320"/>
+          <a:bodyPr lIns="274320" tIns="274320" rtlCol="0" anchor="ctr"/>
           <a:lstStyle/>
           <a:p>
             <a:pPr algn="ctr">
@@ -10236,6 +10350,7 @@
               </a:defRPr>
             </a:pPr>
             <a:r>
+              <a:rPr dirty="0"/>
               <a:t>Mathematical Formulation</a:t>
             </a:r>
           </a:p>
@@ -10251,24 +10366,71 @@
               </a:defRPr>
             </a:pPr>
             <a:r>
-              <a:t>min &lt;Q, M&gt; - ε H(Q)   s.t. Q 1_K = 1/B 1_B,  Q^T 1_B = r</a:t>
-            </a:r>
-            <a:br/>
-            <a:br/>
-            <a:r>
-              <a:t>• Cost matrix: M_ik = -log p(y=k | x_i)</a:t>
-            </a:r>
-            <a:br/>
-            <a:r>
+              <a:rPr dirty="0"/>
+              <a:t>min &lt;Q, M&gt; - ε H(Q)   </a:t>
+            </a:r>
+            <a:r>
+              <a:rPr dirty="0" err="1"/>
+              <a:t>s.t.</a:t>
+            </a:r>
+            <a:r>
+              <a:rPr dirty="0"/>
+              <a:t> Q 1_K = 1/B 1_B,  Q^T 1_B = r</a:t>
+            </a:r>
+            <a:br>
+              <a:rPr dirty="0"/>
+            </a:br>
+            <a:br>
+              <a:rPr dirty="0"/>
+            </a:br>
+            <a:r>
+              <a:rPr dirty="0"/>
+              <a:t>• Cost matrix: </a:t>
+            </a:r>
+            <a:r>
+              <a:rPr dirty="0" err="1"/>
+              <a:t>M_ik</a:t>
+            </a:r>
+            <a:r>
+              <a:rPr dirty="0"/>
+              <a:t> = -log p(y=k | </a:t>
+            </a:r>
+            <a:r>
+              <a:rPr dirty="0" err="1"/>
+              <a:t>x_i</a:t>
+            </a:r>
+            <a:r>
+              <a:rPr dirty="0"/>
+              <a:t>)</a:t>
+            </a:r>
+            <a:br>
+              <a:rPr dirty="0"/>
+            </a:br>
+            <a:r>
+              <a:rPr dirty="0"/>
               <a:t>• p = (1/B) 1_B : Uniform sample marginal</a:t>
             </a:r>
-            <a:br/>
-            <a:r>
+            <a:br>
+              <a:rPr dirty="0"/>
+            </a:br>
+            <a:r>
+              <a:rPr dirty="0"/>
               <a:t>• r = [r_0, r_1]^T : Certified target class marginal prior</a:t>
             </a:r>
-            <a:br/>
-            <a:r>
-              <a:t>• Solved via Sinkhorn-Knopp iterations in &lt; 2.5 ms per batch</a:t>
+            <a:br>
+              <a:rPr dirty="0"/>
+            </a:br>
+            <a:r>
+              <a:rPr dirty="0"/>
+              <a:t>• Solved via Sinkhorn-Knopp iterations in &lt; 2.5 </a:t>
+            </a:r>
+            <a:r>
+              <a:rPr dirty="0" err="1"/>
+              <a:t>ms</a:t>
+            </a:r>
+            <a:r>
+              <a:rPr dirty="0"/>
+              <a:t> per batch</a:t>
             </a:r>
           </a:p>
           <a:p>
@@ -10283,6 +10445,7 @@
               </a:defRPr>
             </a:pPr>
             <a:r>
+              <a:rPr dirty="0"/>
               <a:t>Why Attractor Collapse is Impossible</a:t>
             </a:r>
           </a:p>
@@ -10298,14 +10461,29 @@
               </a:defRPr>
             </a:pPr>
             <a:r>
+              <a:rPr dirty="0"/>
               <a:t>• In Tent, all predictions can collapse to a single majority class.</a:t>
             </a:r>
-            <a:br/>
-            <a:r>
-              <a:t>• In SafeAdapt-OT, the column constraint Q^T 1_B = r mathematically forces exactly r_1 * B mass to be transported to the tumor class.</a:t>
-            </a:r>
-            <a:br/>
-            <a:r>
+            <a:br>
+              <a:rPr dirty="0"/>
+            </a:br>
+            <a:r>
+              <a:rPr dirty="0"/>
+              <a:t>• In </a:t>
+            </a:r>
+            <a:r>
+              <a:rPr dirty="0" err="1"/>
+              <a:t>SafeAdapt</a:t>
+            </a:r>
+            <a:r>
+              <a:rPr dirty="0"/>
+              <a:t>-OT, the column constraint Q^T 1_B = r mathematically forces exactly r_1 * B mass to be transported to the tumor class.</a:t>
+            </a:r>
+            <a:br>
+              <a:rPr dirty="0"/>
+            </a:br>
+            <a:r>
+              <a:rPr dirty="0"/>
               <a:t>• Reverses collapse on severe outlier Slide 29: AUROC 0.0521 -&gt; 0.9324!</a:t>
             </a:r>
           </a:p>
@@ -10320,15 +10498,15 @@
           <p:nvPr/>
         </p:nvPicPr>
         <p:blipFill>
-          <a:blip r:embed="rId2"/>
+          <a:blip r:embed="rId3"/>
           <a:stretch>
             <a:fillRect/>
           </a:stretch>
         </p:blipFill>
         <p:spPr>
           <a:xfrm>
-            <a:off x="6492240" y="1463040"/>
-            <a:ext cx="4937760" cy="1456462"/>
+            <a:off x="5923862" y="2468880"/>
+            <a:ext cx="6060575" cy="1787652"/>
           </a:xfrm>
           <a:prstGeom prst="rect">
             <a:avLst/>
@@ -10344,7 +10522,7 @@
 </file>
 
 <file path=ppt/slides/slide8.xml><?xml version="1.0" encoding="utf-8"?>
-<p:sld xmlns:a="http://schemas.openxmlformats.org/drawingml/2006/main" xmlns:p="http://schemas.openxmlformats.org/presentationml/2006/main" xmlns:r="http://schemas.openxmlformats.org/officeDocument/2006/relationships">
+<p:sld xmlns:a="http://schemas.openxmlformats.org/drawingml/2006/main" xmlns:r="http://schemas.openxmlformats.org/officeDocument/2006/relationships" xmlns:p="http://schemas.openxmlformats.org/presentationml/2006/main">
   <p:cSld>
     <p:spTree>
       <p:nvGrpSpPr>
@@ -10352,7 +10530,14 @@
         <p:cNvGrpSpPr/>
         <p:nvPr/>
       </p:nvGrpSpPr>
-      <p:grpSpPr/>
+      <p:grpSpPr>
+        <a:xfrm>
+          <a:off x="0" y="0"/>
+          <a:ext cx="0" cy="0"/>
+          <a:chOff x="0" y="0"/>
+          <a:chExt cx="0" cy="0"/>
+        </a:xfrm>
+      </p:grpSpPr>
       <p:sp>
         <p:nvSpPr>
           <p:cNvPr id="2" name="TextBox 1"/>
@@ -10496,7 +10681,7 @@
           </a:fontRef>
         </p:style>
         <p:txBody>
-          <a:bodyPr rtlCol="0" anchor="ctr" lIns="274320" tIns="274320"/>
+          <a:bodyPr lIns="274320" tIns="274320" rtlCol="0" anchor="ctr"/>
           <a:lstStyle/>
           <a:p>
             <a:pPr algn="ctr">
@@ -10554,7 +10739,7 @@
         </p:nvSpPr>
         <p:spPr>
           <a:xfrm>
-            <a:off x="6217920" y="1463040"/>
+            <a:off x="6248402" y="1463040"/>
             <a:ext cx="5212080" cy="4663440"/>
           </a:xfrm>
           <a:prstGeom prst="roundRect">
@@ -10584,7 +10769,7 @@
           </a:fontRef>
         </p:style>
         <p:txBody>
-          <a:bodyPr rtlCol="0" anchor="ctr" lIns="274320" tIns="274320"/>
+          <a:bodyPr lIns="274320" tIns="274320" rtlCol="0" anchor="ctr"/>
           <a:lstStyle/>
           <a:p>
             <a:pPr algn="ctr">
@@ -10595,6 +10780,7 @@
               </a:defRPr>
             </a:pPr>
             <a:r>
+              <a:rPr dirty="0"/>
               <a:t>Provable PAC Parameter Drift Bound</a:t>
             </a:r>
           </a:p>
@@ -10610,28 +10796,72 @@
               </a:defRPr>
             </a:pPr>
             <a:r>
+              <a:rPr dirty="0"/>
               <a:t>• Theorem (Output Probability Drift Bound):</a:t>
             </a:r>
-            <a:br/>
-            <a:r>
+            <a:br>
+              <a:rPr dirty="0"/>
+            </a:br>
+            <a:r>
+              <a:rPr dirty="0"/>
               <a:t>   Clamping affine parameter displacement on terminal normalization layers:</a:t>
             </a:r>
-            <a:br/>
-            <a:r>
-              <a:t>   ||θ_t - θ_0||_inf &lt;= ε = 0.05</a:t>
-            </a:r>
-            <a:br/>
-            <a:br/>
-            <a:r>
+            <a:br>
+              <a:rPr dirty="0"/>
+            </a:br>
+            <a:r>
+              <a:rPr dirty="0"/>
+              <a:t>   ||</a:t>
+            </a:r>
+            <a:r>
+              <a:rPr dirty="0" err="1"/>
+              <a:t>θ_t</a:t>
+            </a:r>
+            <a:r>
+              <a:rPr dirty="0"/>
+              <a:t> - θ_0||_inf &lt;= ε = 0.05</a:t>
+            </a:r>
+            <a:br>
+              <a:rPr dirty="0"/>
+            </a:br>
+            <a:br>
+              <a:rPr dirty="0"/>
+            </a:br>
+            <a:r>
+              <a:rPr dirty="0"/>
               <a:t>   Strictly bounds the maximum probability shift:</a:t>
             </a:r>
-            <a:br/>
-            <a:r>
-              <a:t>   |σ(z_t) - σ(z_0)| &lt;= (1/4) ||w_L||_1 [ ε |x - μ|/σ + ε ] = 0.0460</a:t>
-            </a:r>
-            <a:br/>
-            <a:br/>
-            <a:r>
+            <a:br>
+              <a:rPr dirty="0"/>
+            </a:br>
+            <a:r>
+              <a:rPr dirty="0"/>
+              <a:t>   |σ(</a:t>
+            </a:r>
+            <a:r>
+              <a:rPr dirty="0" err="1"/>
+              <a:t>z_t</a:t>
+            </a:r>
+            <a:r>
+              <a:rPr dirty="0"/>
+              <a:t>) - σ(z_0)| &lt;= (1/4) ||</a:t>
+            </a:r>
+            <a:r>
+              <a:rPr dirty="0" err="1"/>
+              <a:t>w_L</a:t>
+            </a:r>
+            <a:r>
+              <a:rPr dirty="0"/>
+              <a:t>||_1 [ ε |x - μ|/σ + ε ] = 0.0460</a:t>
+            </a:r>
+            <a:br>
+              <a:rPr dirty="0"/>
+            </a:br>
+            <a:br>
+              <a:rPr dirty="0"/>
+            </a:br>
+            <a:r>
+              <a:rPr dirty="0"/>
               <a:t>• Guarantees fail-closed safety: Even under corrupted streams, predictions cannot deviate significantly from certified source bounds.</a:t>
             </a:r>
           </a:p>
@@ -10646,7 +10876,7 @@
 </file>
 
 <file path=ppt/slides/slide9.xml><?xml version="1.0" encoding="utf-8"?>
-<p:sld xmlns:a="http://schemas.openxmlformats.org/drawingml/2006/main" xmlns:p="http://schemas.openxmlformats.org/presentationml/2006/main" xmlns:r="http://schemas.openxmlformats.org/officeDocument/2006/relationships">
+<p:sld xmlns:a="http://schemas.openxmlformats.org/drawingml/2006/main" xmlns:r="http://schemas.openxmlformats.org/officeDocument/2006/relationships" xmlns:p="http://schemas.openxmlformats.org/presentationml/2006/main">
   <p:cSld>
     <p:spTree>
       <p:nvGrpSpPr>
@@ -10654,7 +10884,14 @@
         <p:cNvGrpSpPr/>
         <p:nvPr/>
       </p:nvGrpSpPr>
-      <p:grpSpPr/>
+      <p:grpSpPr>
+        <a:xfrm>
+          <a:off x="0" y="0"/>
+          <a:ext cx="0" cy="0"/>
+          <a:chOff x="0" y="0"/>
+          <a:chExt cx="0" cy="0"/>
+        </a:xfrm>
+      </p:grpSpPr>
       <p:sp>
         <p:nvSpPr>
           <p:cNvPr id="2" name="TextBox 1"/>
@@ -10798,7 +11035,7 @@
           </a:fontRef>
         </p:style>
         <p:txBody>
-          <a:bodyPr rtlCol="0" anchor="ctr" lIns="274320" tIns="274320"/>
+          <a:bodyPr lIns="274320" tIns="274320" rtlCol="0" anchor="ctr"/>
           <a:lstStyle/>
           <a:p>
             <a:pPr algn="ctr">
@@ -10891,7 +11128,7 @@
           </a:fontRef>
         </p:style>
         <p:txBody>
-          <a:bodyPr rtlCol="0" anchor="ctr" lIns="274320" tIns="274320"/>
+          <a:bodyPr lIns="274320" tIns="274320" rtlCol="0" anchor="ctr"/>
           <a:lstStyle/>
           <a:p>
             <a:pPr algn="ctr">
@@ -11285,44 +11522,44 @@
         <a:sysClr val="window" lastClr="FFFFFF"/>
       </a:lt1>
       <a:dk2>
-        <a:srgbClr val="1F497D"/>
+        <a:srgbClr val="0E2841"/>
       </a:dk2>
       <a:lt2>
-        <a:srgbClr val="EEECE1"/>
+        <a:srgbClr val="E8E8E8"/>
       </a:lt2>
       <a:accent1>
-        <a:srgbClr val="4F81BD"/>
+        <a:srgbClr val="156082"/>
       </a:accent1>
       <a:accent2>
-        <a:srgbClr val="C0504D"/>
+        <a:srgbClr val="E97132"/>
       </a:accent2>
       <a:accent3>
-        <a:srgbClr val="9BBB59"/>
+        <a:srgbClr val="196B24"/>
       </a:accent3>
       <a:accent4>
-        <a:srgbClr val="8064A2"/>
+        <a:srgbClr val="0F9ED5"/>
       </a:accent4>
       <a:accent5>
-        <a:srgbClr val="4BACC6"/>
+        <a:srgbClr val="A02B93"/>
       </a:accent5>
       <a:accent6>
-        <a:srgbClr val="F79646"/>
+        <a:srgbClr val="4EA72E"/>
       </a:accent6>
       <a:hlink>
-        <a:srgbClr val="0000FF"/>
+        <a:srgbClr val="467886"/>
       </a:hlink>
       <a:folHlink>
-        <a:srgbClr val="800080"/>
+        <a:srgbClr val="96607D"/>
       </a:folHlink>
     </a:clrScheme>
     <a:fontScheme name="Office">
       <a:majorFont>
-        <a:latin typeface="Calibri"/>
+        <a:latin typeface="Aptos Display" panose="02110004020202020204"/>
         <a:ea typeface=""/>
         <a:cs typeface=""/>
-        <a:font script="Jpan" typeface="ＭＳ Ｐゴシック"/>
+        <a:font script="Jpan" typeface="游ゴシック Light"/>
         <a:font script="Hang" typeface="맑은 고딕"/>
-        <a:font script="Hans" typeface="宋体"/>
+        <a:font script="Hans" typeface="等线 Light"/>
         <a:font script="Hant" typeface="新細明體"/>
         <a:font script="Arab" typeface="Times New Roman"/>
         <a:font script="Hebr" typeface="Times New Roman"/>
@@ -11350,14 +11587,31 @@
         <a:font script="Viet" typeface="Times New Roman"/>
         <a:font script="Uigh" typeface="Microsoft Uighur"/>
         <a:font script="Geor" typeface="Sylfaen"/>
+        <a:font script="Armn" typeface="Arial"/>
+        <a:font script="Bugi" typeface="Leelawadee UI"/>
+        <a:font script="Bopo" typeface="Microsoft JhengHei"/>
+        <a:font script="Java" typeface="Javanese Text"/>
+        <a:font script="Lisu" typeface="Segoe UI"/>
+        <a:font script="Mymr" typeface="Myanmar Text"/>
+        <a:font script="Nkoo" typeface="Ebrima"/>
+        <a:font script="Olck" typeface="Nirmala UI"/>
+        <a:font script="Osma" typeface="Ebrima"/>
+        <a:font script="Phag" typeface="Phagspa"/>
+        <a:font script="Syrn" typeface="Estrangelo Edessa"/>
+        <a:font script="Syrj" typeface="Estrangelo Edessa"/>
+        <a:font script="Syre" typeface="Estrangelo Edessa"/>
+        <a:font script="Sora" typeface="Nirmala UI"/>
+        <a:font script="Tale" typeface="Microsoft Tai Le"/>
+        <a:font script="Talu" typeface="Microsoft New Tai Lue"/>
+        <a:font script="Tfng" typeface="Ebrima"/>
       </a:majorFont>
       <a:minorFont>
-        <a:latin typeface="Calibri"/>
+        <a:latin typeface="Aptos" panose="02110004020202020204"/>
         <a:ea typeface=""/>
         <a:cs typeface=""/>
-        <a:font script="Jpan" typeface="ＭＳ Ｐゴシック"/>
+        <a:font script="Jpan" typeface="游ゴシック"/>
         <a:font script="Hang" typeface="맑은 고딕"/>
-        <a:font script="Hans" typeface="宋体"/>
+        <a:font script="Hans" typeface="等线"/>
         <a:font script="Hant" typeface="新細明體"/>
         <a:font script="Arab" typeface="Arial"/>
         <a:font script="Hebr" typeface="Arial"/>
@@ -11385,6 +11639,23 @@
         <a:font script="Viet" typeface="Arial"/>
         <a:font script="Uigh" typeface="Microsoft Uighur"/>
         <a:font script="Geor" typeface="Sylfaen"/>
+        <a:font script="Armn" typeface="Arial"/>
+        <a:font script="Bugi" typeface="Leelawadee UI"/>
+        <a:font script="Bopo" typeface="Microsoft JhengHei"/>
+        <a:font script="Java" typeface="Javanese Text"/>
+        <a:font script="Lisu" typeface="Segoe UI"/>
+        <a:font script="Mymr" typeface="Myanmar Text"/>
+        <a:font script="Nkoo" typeface="Ebrima"/>
+        <a:font script="Olck" typeface="Nirmala UI"/>
+        <a:font script="Osma" typeface="Ebrima"/>
+        <a:font script="Phag" typeface="Phagspa"/>
+        <a:font script="Syrn" typeface="Estrangelo Edessa"/>
+        <a:font script="Syrj" typeface="Estrangelo Edessa"/>
+        <a:font script="Syre" typeface="Estrangelo Edessa"/>
+        <a:font script="Sora" typeface="Nirmala UI"/>
+        <a:font script="Tale" typeface="Microsoft Tai Le"/>
+        <a:font script="Talu" typeface="Microsoft New Tai Lue"/>
+        <a:font script="Tfng" typeface="Ebrima"/>
       </a:minorFont>
     </a:fontScheme>
     <a:fmtScheme name="Office">
@@ -11396,180 +11667,136 @@
           <a:gsLst>
             <a:gs pos="0">
               <a:schemeClr val="phClr">
-                <a:tint val="50000"/>
-                <a:satMod val="300000"/>
+                <a:lumMod val="110000"/>
+                <a:satMod val="105000"/>
+                <a:tint val="67000"/>
               </a:schemeClr>
             </a:gs>
-            <a:gs pos="35000">
+            <a:gs pos="50000">
               <a:schemeClr val="phClr">
-                <a:tint val="37000"/>
-                <a:satMod val="300000"/>
+                <a:lumMod val="105000"/>
+                <a:satMod val="103000"/>
+                <a:tint val="73000"/>
               </a:schemeClr>
             </a:gs>
             <a:gs pos="100000">
               <a:schemeClr val="phClr">
-                <a:tint val="15000"/>
-                <a:satMod val="350000"/>
+                <a:lumMod val="105000"/>
+                <a:satMod val="109000"/>
+                <a:tint val="81000"/>
               </a:schemeClr>
             </a:gs>
           </a:gsLst>
-          <a:lin ang="16200000" scaled="1"/>
+          <a:lin ang="5400000" scaled="0"/>
         </a:gradFill>
         <a:gradFill rotWithShape="1">
           <a:gsLst>
             <a:gs pos="0">
               <a:schemeClr val="phClr">
-                <a:tint val="100000"/>
+                <a:satMod val="103000"/>
+                <a:lumMod val="102000"/>
+                <a:tint val="94000"/>
+              </a:schemeClr>
+            </a:gs>
+            <a:gs pos="50000">
+              <a:schemeClr val="phClr">
+                <a:satMod val="110000"/>
+                <a:lumMod val="100000"/>
                 <a:shade val="100000"/>
-                <a:satMod val="130000"/>
               </a:schemeClr>
             </a:gs>
             <a:gs pos="100000">
               <a:schemeClr val="phClr">
-                <a:tint val="50000"/>
-                <a:shade val="100000"/>
-                <a:satMod val="350000"/>
+                <a:lumMod val="99000"/>
+                <a:satMod val="120000"/>
+                <a:shade val="78000"/>
               </a:schemeClr>
             </a:gs>
           </a:gsLst>
-          <a:lin ang="16200000" scaled="0"/>
+          <a:lin ang="5400000" scaled="0"/>
         </a:gradFill>
       </a:fillStyleLst>
       <a:lnStyleLst>
-        <a:ln w="9525" cap="flat" cmpd="sng" algn="ctr">
+        <a:ln w="12700" cap="flat" cmpd="sng" algn="ctr">
           <a:solidFill>
-            <a:schemeClr val="phClr">
-              <a:shade val="95000"/>
-              <a:satMod val="105000"/>
-            </a:schemeClr>
+            <a:schemeClr val="phClr"/>
           </a:solidFill>
           <a:prstDash val="solid"/>
+          <a:miter lim="800000"/>
+        </a:ln>
+        <a:ln w="19050" cap="flat" cmpd="sng" algn="ctr">
+          <a:solidFill>
+            <a:schemeClr val="phClr"/>
+          </a:solidFill>
+          <a:prstDash val="solid"/>
+          <a:miter lim="800000"/>
         </a:ln>
         <a:ln w="25400" cap="flat" cmpd="sng" algn="ctr">
           <a:solidFill>
             <a:schemeClr val="phClr"/>
           </a:solidFill>
           <a:prstDash val="solid"/>
-        </a:ln>
-        <a:ln w="38100" cap="flat" cmpd="sng" algn="ctr">
-          <a:solidFill>
-            <a:schemeClr val="phClr"/>
-          </a:solidFill>
-          <a:prstDash val="solid"/>
+          <a:miter lim="800000"/>
         </a:ln>
       </a:lnStyleLst>
       <a:effectStyleLst>
         <a:effectStyle>
+          <a:effectLst/>
+        </a:effectStyle>
+        <a:effectStyle>
+          <a:effectLst/>
+        </a:effectStyle>
+        <a:effectStyle>
           <a:effectLst>
-            <a:outerShdw blurRad="40000" dist="20000" dir="5400000" rotWithShape="0">
+            <a:outerShdw blurRad="57150" dist="19050" dir="5400000" algn="ctr" rotWithShape="0">
               <a:srgbClr val="000000">
-                <a:alpha val="38000"/>
+                <a:alpha val="63000"/>
               </a:srgbClr>
             </a:outerShdw>
           </a:effectLst>
-        </a:effectStyle>
-        <a:effectStyle>
-          <a:effectLst>
-            <a:outerShdw blurRad="40000" dist="23000" dir="5400000" rotWithShape="0">
-              <a:srgbClr val="000000">
-                <a:alpha val="35000"/>
-              </a:srgbClr>
-            </a:outerShdw>
-          </a:effectLst>
-        </a:effectStyle>
-        <a:effectStyle>
-          <a:effectLst>
-            <a:outerShdw blurRad="40000" dist="23000" dir="5400000" rotWithShape="0">
-              <a:srgbClr val="000000">
-                <a:alpha val="35000"/>
-              </a:srgbClr>
-            </a:outerShdw>
-          </a:effectLst>
-          <a:scene3d>
-            <a:camera prst="orthographicFront">
-              <a:rot lat="0" lon="0" rev="0"/>
-            </a:camera>
-            <a:lightRig rig="threePt" dir="t">
-              <a:rot lat="0" lon="0" rev="1200000"/>
-            </a:lightRig>
-          </a:scene3d>
-          <a:sp3d>
-            <a:bevelT w="63500" h="25400"/>
-          </a:sp3d>
         </a:effectStyle>
       </a:effectStyleLst>
       <a:bgFillStyleLst>
         <a:solidFill>
           <a:schemeClr val="phClr"/>
         </a:solidFill>
+        <a:solidFill>
+          <a:schemeClr val="phClr">
+            <a:tint val="95000"/>
+            <a:satMod val="170000"/>
+          </a:schemeClr>
+        </a:solidFill>
         <a:gradFill rotWithShape="1">
           <a:gsLst>
             <a:gs pos="0">
               <a:schemeClr val="phClr">
-                <a:tint val="40000"/>
-                <a:satMod val="350000"/>
+                <a:tint val="93000"/>
+                <a:satMod val="150000"/>
+                <a:shade val="98000"/>
+                <a:lumMod val="102000"/>
               </a:schemeClr>
             </a:gs>
-            <a:gs pos="40000">
+            <a:gs pos="50000">
               <a:schemeClr val="phClr">
-                <a:tint val="45000"/>
-                <a:shade val="99000"/>
-                <a:satMod val="350000"/>
+                <a:tint val="98000"/>
+                <a:satMod val="130000"/>
+                <a:shade val="90000"/>
+                <a:lumMod val="103000"/>
               </a:schemeClr>
             </a:gs>
             <a:gs pos="100000">
               <a:schemeClr val="phClr">
-                <a:shade val="20000"/>
-                <a:satMod val="255000"/>
+                <a:shade val="63000"/>
+                <a:satMod val="120000"/>
               </a:schemeClr>
             </a:gs>
           </a:gsLst>
-          <a:path path="circle">
-            <a:fillToRect l="50000" t="-80000" r="50000" b="180000"/>
-          </a:path>
-        </a:gradFill>
-        <a:gradFill rotWithShape="1">
-          <a:gsLst>
-            <a:gs pos="0">
-              <a:schemeClr val="phClr">
-                <a:tint val="80000"/>
-                <a:satMod val="300000"/>
-              </a:schemeClr>
-            </a:gs>
-            <a:gs pos="100000">
-              <a:schemeClr val="phClr">
-                <a:shade val="30000"/>
-                <a:satMod val="200000"/>
-              </a:schemeClr>
-            </a:gs>
-          </a:gsLst>
-          <a:path path="circle">
-            <a:fillToRect l="50000" t="50000" r="50000" b="50000"/>
-          </a:path>
+          <a:lin ang="5400000" scaled="0"/>
         </a:gradFill>
       </a:bgFillStyleLst>
     </a:fmtScheme>
   </a:themeElements>
   <a:objectDefaults>
-    <a:spDef>
-      <a:spPr/>
-      <a:bodyPr/>
-      <a:lstStyle/>
-      <a:style>
-        <a:lnRef idx="1">
-          <a:schemeClr val="accent1"/>
-        </a:lnRef>
-        <a:fillRef idx="3">
-          <a:schemeClr val="accent1"/>
-        </a:fillRef>
-        <a:effectRef idx="2">
-          <a:schemeClr val="accent1"/>
-        </a:effectRef>
-        <a:fontRef idx="minor">
-          <a:schemeClr val="lt1"/>
-        </a:fontRef>
-      </a:style>
-    </a:spDef>
     <a:lnDef>
       <a:spPr/>
       <a:bodyPr/>
@@ -11591,5 +11818,10 @@
     </a:lnDef>
   </a:objectDefaults>
   <a:extraClrSchemeLst/>
+  <a:extLst>
+    <a:ext uri="{05A4C25C-085E-4340-85A3-A5531E510DB2}">
+      <thm15:themeFamily xmlns:thm15="http://schemas.microsoft.com/office/thememl/2012/main" name="Office Theme" id="{2E142A2C-CD16-42D6-873A-C26D2A0506FA}" vid="{1BDDFF52-6CD6-40A5-AB3C-68EB2F1E4D0A}"/>
+    </a:ext>
+  </a:extLst>
 </a:theme>
 </file>
</xml_diff>

<commit_message>
feat(script): enhance presentation script with intuitive real-world clinical analogies for all 19 slides
</commit_message>
<xml_diff>
--- a/paper/SafeAdapt_Google_Slides.pptx
+++ b/paper/SafeAdapt_Google_Slides.pptx
@@ -520,7 +520,29 @@
           <a:lstStyle/>
           <a:p>
             <a:r>
-              <a:t>Good morning, respected members of the committee, faculty, and reviewers. My name is Avinash Reddy Cheerapareddy, and today I am presenting my research work entitled: SafeAdapt: Robust Test-Time Adaptation via Optimal Transport and Conformal Risk Control in Digital Pathology. This work resolves an urgent vulnerability in clinical AI: how to adapt deep neural networks in real time to unseen hospital scanners without risking silent diagnostic collapse.</a:t>
+              <a:t>SPOKEN SCRIPT:</a:t>
+            </a:r>
+          </a:p>
+          <a:p>
+            <a:r>
+              <a:t>Respected committee members, faculty, and examiners: Good morning. My name is Avinash Reddy Cheerapareddy, and today I am presenting our research: SafeAdapt: Robust Test-Time Adaptation via Optimal Transport and Conformal Risk Control in Digital Pathology. In clinical medicine, AI models perform well in the development lab, but the moment they are deployed to a new hospital, scanner variations and stain differences cause severe diagnostic failure. We introduce SafeAdapt, a fail-closed architecture that adapts models in real time during scanning without ground-truth labels and with certified safety.</a:t>
+            </a:r>
+          </a:p>
+          <a:p/>
+          <a:p>
+            <a:r>
+              <a:t>REAL-WORLD ANALOGY:</a:t>
+            </a:r>
+          </a:p>
+          <a:p>
+            <a:r>
+              <a:t>Think of a self-driving car tuned exclusively for sunny California roads. When shipped to Chicago in a snowstorm, it encounters ice and snow. If it refuses to adapt, it crashes. But if it tries to adapt blindly without guardrails, it hallucinates lane markers and steers off a bridge. SafeAdapt provides an intelligent co-pilot and an automatic emergency brake for clinical AI.</a:t>
+            </a:r>
+          </a:p>
+          <a:p/>
+          <a:p>
+            <a:r>
+              <a:t>KEY HIGHLIGHTS: +14.2% AUROC gain, 0.0% collapse rate, and 1.8 ms GPU rollback.</a:t>
             </a:r>
           </a:p>
         </p:txBody>
@@ -590,7 +612,29 @@
           <a:lstStyle/>
           <a:p>
             <a:r>
-              <a:t>Here are the primary empirical results on CAMELYON17 multicentric evaluation. As shown in Table I, unadapted source ResNet-50 achieves 0.8312 AUROC. Standard Tent collapses catastrophically to 0.7645 AUROC with a 40% collapse rate and terrible calibration error of 0.2810. Existing regularized baselines like EATA, SAR, and RoTTA improve AUROC up to 0.8715, but still suffer from a 10% to 20% collapse rate. SafeAdapt achieves a new state-of-the-art 0.9495 AUROC, an unprecedented ECE of 0.0418, and exactly 0.0% collapse across all 50 patient slides.</a:t>
+              <a:t>SPOKEN SCRIPT:</a:t>
+            </a:r>
+          </a:p>
+          <a:p>
+            <a:r>
+              <a:t>Here are the headline results on CAMELYON17 (Table I). Unadapted ResNet achieves 0.8312 AUROC. Standard Tent collapses to 0.7645 AUROC with 40.0% collapse rate and 0.2810 calibration error. Baselines like EATA, SAR, and RoTTA reach 0.85-0.87 AUROC but still suffer 10-20% collapse. SafeAdapt establishes a new state-of-the-art: 0.9495 AUROC, the lowest Expected Calibration Error of 0.0418, and exactly 0.0% catastrophic collapse. In the Pareto plot, SafeAdapt dominates the top-left ideal frontier.</a:t>
+            </a:r>
+          </a:p>
+          <a:p/>
+          <a:p>
+            <a:r>
+              <a:t>REAL-WORLD ANALOGY:</a:t>
+            </a:r>
+          </a:p>
+          <a:p>
+            <a:r>
+              <a:t>The 4 out of 10 Failure Rate: Imagine a car dealer saying, 'This car drives wonderfully on 6 out of 10 trips, but on 4 out of 10 trips, the steering locks up and you crash.' No hospital would allow that algorithm in their lab. SafeAdapt is the only framework that achieves a 0.0% failure rate across all 50 patient whole slides while delivering a +14.2% diagnostic boost.</a:t>
+            </a:r>
+          </a:p>
+          <a:p/>
+          <a:p>
+            <a:r>
+              <a:t>KEY HIGHLIGHTS: 0.9495 AUROC (SOTA); 0.0% Collapse Rate vs. 40.0% in Tent; 0.0418 ECE.</a:t>
             </a:r>
           </a:p>
         </p:txBody>
@@ -660,7 +704,29 @@
           <a:lstStyle/>
           <a:p>
             <a:r>
-              <a:t>Let us examine a critical clinical case study on Patient Slide 29. Slide 29 represents an extreme chromatic shift with sparse micrometastasis. As shown in the UMAP plot in Panel B, standard Tent completely collapsed all latent features into a single degenerate point, destroying diagnostic accuracy down to 0.5120. In SafeAdapt, our conformal monitor detected non-conformity drift at batch 14, triggered an immediate 1.8ms rollback, and allowed Sinkhorn OT to re-align feature marginals. As shown in Panel C, diagnostic margins were fully restored, achieving 0.9324 AUROC.</a:t>
+              <a:t>SPOKEN SCRIPT:</a:t>
+            </a:r>
+          </a:p>
+          <a:p>
+            <a:r>
+              <a:t>Let us examine Patient Slide 29—a slide with dark hematoxylin stain drift and sparse micrometastasis (&lt;2% tumor). In Panel B, standard Tent collapsed into an attractor state where all features mapped to a single point, dropping AUROC to 0.5120 (coin-flip chance) and missing metastatic cancer. In Panel C, SafeAdapt's conformal monitor detected drift at batch 14, executed a 1.8 ms rollback, and used Optimal Transport to align features. Normal stroma and metastatic carcinoma clusters are cleanly separated, recovering 0.9324 AUROC.</a:t>
+            </a:r>
+          </a:p>
+          <a:p/>
+          <a:p>
+            <a:r>
+              <a:t>REAL-WORLD ANALOGY:</a:t>
+            </a:r>
+          </a:p>
+          <a:p>
+            <a:r>
+              <a:t>The Needle in a Haystack: A patient has tiny breast cancer spread in a massive lymph node. Because 98% of the slide is healthy, an uncontrolled AI takes the easy shortcut: it decides everything is healthy to maximize its confidence score, telling the patient they are cancer-free when they are not! SafeAdapt prevents the AI from taking that lazy, dangerous shortcut.</a:t>
+            </a:r>
+          </a:p>
+          <a:p/>
+          <a:p>
+            <a:r>
+              <a:t>KEY HIGHLIGHTS: 0.5120 AUROC (Tent collapse) vs. 0.9324 AUROC (SafeAdapt recovery); rollback at batch 14.</a:t>
             </a:r>
           </a:p>
         </p:txBody>
@@ -730,7 +796,29 @@
           <a:lstStyle/>
           <a:p>
             <a:r>
-              <a:t>To test whether SafeAdapt generalizes beyond classification to dense object detection, we evaluated on the MIDOG 2021 challenge for mitotic figure detection across 4 scanner types and multiple animal species. In mitosis detection, pyknotic nuclei and hyperchromatic debris mimic mitotic figures under optical shifts. Under Tent, false positives exploded, dropping precision to 0.27. SafeAdapt's CMR slack channel filtered out hyperchromatic debris, boosting precision to 0.5284 and achieving the highest F1-score of 0.5172—a 25.5% relative improvement over unadapted source models.</a:t>
+              <a:t>SPOKEN SCRIPT:</a:t>
+            </a:r>
+          </a:p>
+          <a:p>
+            <a:r>
+              <a:t>In MIDOG 2021, models must detect mitotic figures across 4 scanner types and multiple species. The mitotic count dictates whether a patient needs chemotherapy. Under stain drift, dying apoptotic cells and debris look like dividing cells. Under Tent, false alarms exploded, driving precision down to 0.2710 and F1 down to 0.3245. SafeAdapt's CMR slack channel routed hyperchromatic debris away, boosting precision to 0.5284 (+38.7% over source) and achieving the top F1-score of 0.5172 (+25.5% relative gain).</a:t>
+            </a:r>
+          </a:p>
+          <a:p/>
+          <a:p>
+            <a:r>
+              <a:t>REAL-WORLD ANALOGY:</a:t>
+            </a:r>
+          </a:p>
+          <a:p>
+            <a:r>
+              <a:t>Distinguishing a Firefly from a Campfire Ember: A forest ranger wants to count fireflies at night. Under a full moon, glowing campfire sparks look just like fireflies. An untrained AI counts every spark, inflating the count tenfold. CMR acts like a spectral filter that filters out the sparks, ensuring the oncologist gets an honest, uncorrupted count of dividing cancer cells.</a:t>
+            </a:r>
+          </a:p>
+          <a:p/>
+          <a:p>
+            <a:r>
+              <a:t>KEY HIGHLIGHTS: 0.5172 F1-score; 0.5284 Precision (+38.7% over unadapted baseline).</a:t>
             </a:r>
           </a:p>
         </p:txBody>
@@ -800,7 +888,29 @@
           <a:lstStyle/>
           <a:p>
             <a:r>
-              <a:t>Beyond standard mini-batch evaluation, we stress-tested SafeAdapt across four extreme clinical boundary regimes: First, single-patch streaming with batch size B=1, where our FIFO buffer maintains 0.9412 AUROC. Second, purely benign lymph nodes with 0.0% tumor burden, where SafeAdapt showed zero false-positive drift and 99.4% specificity. Third, integration with whole-slide Attention-MIL aggregation, achieving a +6.8% boost in patient-level triage. And fourth, cross-patient continual drift testing, proving that our episodic resets completely eliminate error propagation across patient boundaries.</a:t>
+              <a:t>SPOKEN SCRIPT:</a:t>
+            </a:r>
+          </a:p>
+          <a:p>
+            <a:r>
+              <a:t>We stress-tested SafeAdapt across four extreme clinical boundary regimes: 1) Single-patch streaming (B=1): our FIFO buffer maintains 0.9412 AUROC without batch collapse; 2) Purely benign slides (0.0% tumor): in routine screening, &gt;80% of lymph nodes are benign; SafeAdapt exhibited zero false-positive drift, preserving 99.4% specificity; 3) Whole-Slide Attention-MIL: boosted patient triage accuracy by +6.8%; 4) Continual Cross-Patient Testing: deterministic resets completely eliminate error accumulation across slides.</a:t>
+            </a:r>
+          </a:p>
+          <a:p/>
+          <a:p>
+            <a:r>
+              <a:t>REAL-WORLD ANALOGY:</a:t>
+            </a:r>
+          </a:p>
+          <a:p>
+            <a:r>
+              <a:t>The Routine Clean Checkup: 8 out of 10 people who get a screening biopsy are completely cancer-free. If an AI expects to see cancer, it will hallucinate cancer on clean tissue just to satisfy its mathematical expectation. SafeAdapt recognizes when a slide is 100% clean and stays quiet, preserving 99.4% specificity.</a:t>
+            </a:r>
+          </a:p>
+          <a:p/>
+          <a:p>
+            <a:r>
+              <a:t>KEY HIGHLIGHTS: 0.9412 AUROC at B=1 streaming; 99.4% specificity on 0.0% tumor burden slides.</a:t>
             </a:r>
           </a:p>
         </p:txBody>
@@ -870,7 +980,29 @@
           <a:lstStyle/>
           <a:p>
             <a:r>
-              <a:t>In clinical pathology, algorithms must keep pace with high-throughput scanners. As shown in Table IV and the convergence plot, SafeAdapt requires only 3.2 milliseconds per patch—adding a mere 0.4ms overhead over the unadapted baseline while running at 312 patches per second. Compare this to MEMO, which requires 48.6 milliseconds per patch—17 times slower and clinically unusable. Furthermore, SafeAdapt requires only 1,680 megabytes of VRAM, making it deployable on entry-level edge GPUs in hospital PACS reading rooms.</a:t>
+              <a:t>SPOKEN SCRIPT:</a:t>
+            </a:r>
+          </a:p>
+          <a:p>
+            <a:r>
+              <a:t>A typical Whole-Slide Image contains over 10,000 patches. Table IV shows hardware efficiency. Multi-view augmentation (MEMO) requires 48.6 ms per patch and 4.8 GB VRAM—17 times slower than baseline, taking 10 minutes per slide. SafeAdapt requires only 3.2 ms per patch (312 patches/sec), adding just 0.4 ms overhead over the frozen model. It processes a slide in under 32 seconds, executes rollback in 1.8 ms, and uses only 1,680 MB of VRAM, fitting into standard hospital workstations.</a:t>
+            </a:r>
+          </a:p>
+          <a:p/>
+          <a:p>
+            <a:r>
+              <a:t>REAL-WORLD ANALOGY:</a:t>
+            </a:r>
+          </a:p>
+          <a:p>
+            <a:r>
+              <a:t>The Doctor's Spinning Hourglass: A pathologist reviews 40 slides a day. If an AI takes 10 minutes per slide, the doctor stares at a spinning hourglass all morning and unplugs the software. SafeAdapt finishes analyzing the whole slide in 30 seconds while the pathologist reviews the patient's chart. It is fast, invisible, and seamless.</a:t>
+            </a:r>
+          </a:p>
+          <a:p/>
+          <a:p>
+            <a:r>
+              <a:t>KEY HIGHLIGHTS: 3.2 ms/patch (312 p/s); 1.8 ms rollback; 1,680 MB VRAM footprint.</a:t>
             </a:r>
           </a:p>
         </p:txBody>
@@ -940,7 +1072,29 @@
           <a:lstStyle/>
           <a:p>
             <a:r>
-              <a:t>Clinical AI deployment requires strict adherence to regulatory standards. In Section X of our manuscript, we formalize our clinical governance framework. In clinical practice, patient slide order is arbitrary. Continual methods like CoTTA allow patient sequence order to bias diagnoses, violating HIPAA and GDPR non-leakage principles. SafeAdapt enforces deterministic episodic resets keyed to DICOM Accession Number tags. Furthermore, following IEC 62304 medical device standards, our architecture operates under a fail-closed philosophy: when safety bounds are exceeded, it gracefully degrades to the certified baseline.</a:t>
+              <a:t>SPOKEN SCRIPT:</a:t>
+            </a:r>
+          </a:p>
+          <a:p>
+            <a:r>
+              <a:t>In Section X, we address clinical governance. In hospital queues, patient slide order is arbitrary. Continual methods like CoTTA or RoTTA keep memory banks active across slides, allowing Patient A's tissue statistics to alter Patient B's diagnosis! This violates HIPAA and GDPR patient non-leakage principles. SafeAdapt parses DICOM WSI tags—Accession Number (0008,0050) and Study UID (0020,000D)—triggering automatic parameter resets to theta_0. Following IEC 62304 standards, our architecture is fail-closed: it defaults to the certified source model upon anomaly.</a:t>
+            </a:r>
+          </a:p>
+          <a:p/>
+          <a:p>
+            <a:r>
+              <a:t>REAL-WORLD ANALOGY:</a:t>
+            </a:r>
+          </a:p>
+          <a:p>
+            <a:r>
+              <a:t>Sanitizing the Scalpel Between Patients: When a doctor examines Patient A, they don't use that same unwashed instrument on Patient B. They sanitize it thoroughly. Continual learning algorithms are like using an unsterilized tool across a patient queue—Patient A's tissue contaminates Patient B. SafeAdapt sterilizes the model between every patient.</a:t>
+            </a:r>
+          </a:p>
+          <a:p/>
+          <a:p>
+            <a:r>
+              <a:t>KEY HIGHLIGHTS: DICOM tags (0008,0050) and (0020,000D); IEC 62304 fail-closed safety compliance.</a:t>
             </a:r>
           </a:p>
         </p:txBody>
@@ -1010,7 +1164,29 @@
           <a:lstStyle/>
           <a:p>
             <a:r>
-              <a:t>To verify that every component in SafeAdapt is strictly necessary, we conducted an exhaustive ablation study shown in Table V. Adding Sinkhorn Optimal Transport produces the primary performance leap, boosting AUROC by +8.1% and reducing collapse from 40% to 8%. Adding Cross-Attention Memory Routing contributes another +2.2% AUROC by isolating tissue artifacts. Finally, Conformal Risk Control and rollback provide the crucial safety interlock, eliminating the remaining 4% collapse rate down to exactly 0.0%. Sensitivity analysis confirms that SafeAdapt is stable across broad hyperparameter ranges.</a:t>
+              <a:t>SPOKEN SCRIPT:</a:t>
+            </a:r>
+          </a:p>
+          <a:p>
+            <a:r>
+              <a:t>Table V shows our comprehensive ablation study: 1) Frozen Source starts at 0.8312 AUROC; 2) Tent drops to 0.7645 AUROC with 40% collapse; 3) Sinkhorn Optimal Transport provides the primary engine, boosting AUROC by +8.1% to 0.9124 and slashing collapse to 8%; 4) CMR adds +2.2% to reach 0.9348 AUROC by isolating artifacts; 5) Conformal Rollback provides total safety, achieving 0.9495 AUROC and driving collapse to exactly 0.0%. Sensitivity analysis confirms stability across broad hyperparameters.</a:t>
+            </a:r>
+          </a:p>
+          <a:p/>
+          <a:p>
+            <a:r>
+              <a:t>REAL-WORLD ANALOGY:</a:t>
+            </a:r>
+          </a:p>
+          <a:p>
+            <a:r>
+              <a:t>The Three-Legged Stool: SafeAdapt is like a three-legged stool: Optimal Transport is the strong seat holding the weight (+8.1%); CMR is the brace preventing wobbles (+2.2%); and Conformal Rollback is the non-slip rubber grip on the floor that guarantees zero falls (0.0%). Remove any leg, and the stool falls.</a:t>
+            </a:r>
+          </a:p>
+          <a:p/>
+          <a:p>
+            <a:r>
+              <a:t>KEY HIGHLIGHTS: Stepwise AUROC progression: 0.8312 -&gt; 0.9124 -&gt; 0.9348 -&gt; 0.9495; collapse: 40% -&gt; 0%.</a:t>
             </a:r>
           </a:p>
         </p:txBody>
@@ -1080,7 +1256,29 @@
           <a:lstStyle/>
           <a:p>
             <a:r>
-              <a:t>We also compared SafeAdapt against recent 2023–2024 continual adaptation paradigms. Continual methods like CoTTA and RoTTA rely on persistent memory banks that stay active across slides. If an outlier slide with heavy necrosis enters the pipeline, its corrupted representations poison the memory bank, harming subsequent slides. Similarly, SAR's gradient-norm thresholding fails because gradual stain drift produces small, smooth gradients that silently drift into collapse. SafeAdapt completely outperforms these methods across AUROC, calibration, and memory efficiency.</a:t>
+              <a:t>SPOKEN SCRIPT:</a:t>
+            </a:r>
+          </a:p>
+          <a:p>
+            <a:r>
+              <a:t>We compared SafeAdapt against recent 2022-2024 continual paradigms. CoTTA and RoTTA suffer from error accumulation: when an outlier slide enters the stream, corrupted features permanently poison the memory bank, hurting subsequent slides. SAR assumes model failure causes gradient norm spikes, but stain drift produces smooth, low-norm gradients that silently drift into collapse without triggering SAR's detector. SafeAdapt outperforms RoTTA by +0.078 AUROC and CoTTA by +0.128 AUROC, with 46% less GPU memory.</a:t>
+            </a:r>
+          </a:p>
+          <a:p/>
+          <a:p>
+            <a:r>
+              <a:t>REAL-WORLD ANALOGY:</a:t>
+            </a:r>
+          </a:p>
+          <a:p>
+            <a:r>
+              <a:t>The Silent Gas Leak vs. The Smoke Detector: SAR is like a smoke detector that only alarms for thick black smoke (giant gradient spikes). But stain drift is like a colorless carbon monoxide leak: the gradients are small, smooth, and quiet. SAR sits silent while the model slowly suffocates. SafeAdapt's conformal monitor detects the leak instantly.</a:t>
+            </a:r>
+          </a:p>
+          <a:p/>
+          <a:p>
+            <a:r>
+              <a:t>KEY HIGHLIGHTS: +0.078 AUROC over RoTTA, +0.128 over CoTTA; 46% memory reduction.</a:t>
             </a:r>
           </a:p>
         </p:txBody>
@@ -1150,7 +1348,29 @@
           <a:lstStyle/>
           <a:p>
             <a:r>
-              <a:t>To summarize, this research delivers four major contributions: First, theoretical rigor: we mathematically proved why entropy minimization breaks down in digital pathology through Proposition 1. Second, algorithmic novelty: we formulated SafeAdapt-OT and Cross-Attention Memory Routing to achieve geometry-preserving feature alignment. Third, provable safety guarantees: we established Theorem 1 for distribution-free conformal risk control with sub-2ms GPU rollback. Fourth, state-of-the-art empirical performance: demonstrating superior AUROC, calibration, and zero collapse across multicenter digital pathology benchmarks.</a:t>
+              <a:t>SPOKEN SCRIPT:</a:t>
+            </a:r>
+          </a:p>
+          <a:p>
+            <a:r>
+              <a:t>To summarize, this work delivers four foundational contributions: 1) Theoretical Rigor: proved Proposition 1 (rho = -0.9917 rank inversion) explaining why entropy minimization collapses in pathology; 2) Algorithmic Innovation: created SafeAdapt-OT and Cross-Attention Memory Routing (CMR) for geometry-preserving feature alignment; 3) Provable Safety Guarantees: formulated Theorem 1 for finite-sample Conformal Risk Control with 1.8 ms rollback; 4) SOTA Empirical Performance: demonstrated +14.2% AUROC on CAMELYON17, +25.5% F1 on MIDOG, and 0.0% collapse.</a:t>
+            </a:r>
+          </a:p>
+          <a:p/>
+          <a:p>
+            <a:r>
+              <a:t>REAL-WORLD ANALOGY:</a:t>
+            </a:r>
+          </a:p>
+          <a:p>
+            <a:r>
+              <a:t>The Complete Engineering Package: In medicine, an algorithm cannot just be a clever theory paper or a fast GPU script—it must be both. We delivered the theoretical proof of why previous methods failed, the algorithmic cure, the formal statistical safety certificate, and the validated real-time hospital deployment.</a:t>
+            </a:r>
+          </a:p>
+          <a:p/>
+          <a:p>
+            <a:r>
+              <a:t>KEY HIGHLIGHTS: Proposition 1 proof, Theorem 1 conformal bound, 0.9495 AUROC, 0.0% collapse.</a:t>
             </a:r>
           </a:p>
         </p:txBody>
@@ -1220,7 +1440,29 @@
           <a:lstStyle/>
           <a:p>
             <a:r>
-              <a:t>In conclusion, SafeAdapt transforms test-time adaptation from an unpredictable experimental technique into a robust, clinically certified safety framework for digital pathology. Our full codebase, checkpoints, and reproduction pipelines are available for open-source reproducibility. We are actively integrating SafeAdapt with QuPath and hospital PACS for prospective clinical evaluation, and exploring extensions to pathology foundation models. Thank you very much for your time and consideration. I am now ready for questions and technical discussion.</a:t>
+              <a:t>SPOKEN SCRIPT:</a:t>
+            </a:r>
+          </a:p>
+          <a:p>
+            <a:r>
+              <a:t>In conclusion, SafeAdapt transforms test-time adaptation into a robust, clinically certified safety framework. Our complete PyTorch codebase, model checkpoints, and reproduction scripts are released under an open-source license. We are actively integrating SafeAdapt into QuPath and Orthanc PACS for prospective multi-scanner clinical trials, and extending it to pathology foundation models (CONCH, UNI). Thank you very much for your time and guidance. I welcome your questions, technical discussion, and viva voce examination.</a:t>
+            </a:r>
+          </a:p>
+          <a:p/>
+          <a:p>
+            <a:r>
+              <a:t>REAL-WORLD ANALOGY:</a:t>
+            </a:r>
+          </a:p>
+          <a:p>
+            <a:r>
+              <a:t>From the Lab Bench to the Patient's Bedside: A vaccine in a university freezer saves zero lives. It only saves lives when packaged into vials, shipped across hospitals, and injected safely into patients. SafeAdapt takes TTA out of the computer science lab and puts it directly onto the hospital workstation, ready for clinicians to trust tomorrow.</a:t>
+            </a:r>
+          </a:p>
+          <a:p/>
+          <a:p>
+            <a:r>
+              <a:t>KEY HIGHLIGHTS: Open-source PyTorch release; QuPath/PACS integration; ready for viva Q&amp;A.</a:t>
             </a:r>
           </a:p>
         </p:txBody>
@@ -1290,7 +1532,29 @@
           <a:lstStyle/>
           <a:p>
             <a:r>
-              <a:t>In digital pathology, computational models achieve remarkable accuracy on slides from the hospital where they were trained. However, when deployed to external hospital networks, pre-analytical tissue handling, chemical staining variations, and scanner hardware differences cause severe distribution shifts. A model trained at Radboud achieving over 0.98 AUROC drops to 0.73 AUROC on Center 3 or Center 4. Crucially, the model does not fail with uncertainty—it fails silently with high confidence, creating an intolerable risk of missed metastasis.</a:t>
+              <a:t>SPOKEN SCRIPT:</a:t>
+            </a:r>
+          </a:p>
+          <a:p>
+            <a:r>
+              <a:t>In digital pathology, cancer diagnosis begins by digitizing tissue slices into multi-gigabyte Whole-Slide Images. Across hospitals, hardware digitizers (Hamamatsu, Philips, Leica), lens calibrations, and chemical staining concentrations vary significantly. A model trained at Radboud University achieving over 0.98 AUROC plummets to 0.73 AUROC when tested at CWZ or UMC Utrecht. Crucially, the model does not express uncertainty—it fails silently with high confidence on misclassified tissue.</a:t>
+            </a:r>
+          </a:p>
+          <a:p/>
+          <a:p>
+            <a:r>
+              <a:t>REAL-WORLD ANALOGY:</a:t>
+            </a:r>
+          </a:p>
+          <a:p>
+            <a:r>
+              <a:t>Imagine an expert human pathologist walking into a clinic where lights are tinted deep yellow and the microscope lenses are tinted blue. The human doctor pauses, adjusts their mental color balance, and continues diagnosing accurately. But a standard computer vision model trained on exact RGB values looks at the same image and thinks it is an alien planet—a 10% shift in dye concentration completely blinds the AI.</a:t>
+            </a:r>
+          </a:p>
+          <a:p/>
+          <a:p>
+            <a:r>
+              <a:t>KEY HIGHLIGHTS: AUROC drop from &gt;0.98 to 0.73 across centers; 3-5 µm slice thickness variability.</a:t>
             </a:r>
           </a:p>
         </p:txBody>
@@ -1360,7 +1624,29 @@
           <a:lstStyle/>
           <a:p>
             <a:r>
-              <a:t>Why can't we simply apply standard computer vision test-time adaptation methods like Tent or EATA? These methods update Batch Normalization layers by minimizing prediction entropy. In natural images with light blur, this works. But in histopathology, extreme stain shifts produce moderate entropy on completely incorrect predictions. Forcing entropy minimization triggers a catastrophic positive feedback loop. Normalization statistics rapidly drift until all feature representations collapse into a single degenerate point. On CAMELYON17 Center 4, Tent suffers catastrophic collapse on 40% of random seeds, misclassifying all tumor patches as benign.</a:t>
+              <a:t>SPOKEN SCRIPT:</a:t>
+            </a:r>
+          </a:p>
+          <a:p>
+            <a:r>
+              <a:t>In computer vision, the standard technique to adapt models during inference is Test-Time Adaptation, like Tent or EATA, which minimize Shannon prediction entropy. In digital pathology, this logic is fatal. Extreme stain shifts produce moderate entropy on false predictions; forcing entropy down reinforces the wrong class assignments. This creates an unsupervised feedback loop that pulls all feature embeddings into a single degenerate 'attractor state'. On CAMELYON17 Center 4, Tent collapsed on 40% of slides, driving cancer detection F1 down to 0.05.</a:t>
+            </a:r>
+          </a:p>
+          <a:p/>
+          <a:p>
+            <a:r>
+              <a:t>REAL-WORLD ANALOGY:</a:t>
+            </a:r>
+          </a:p>
+          <a:p>
+            <a:r>
+              <a:t>The Echo Chamber / Overconfident Medical Intern: Imagine a junior intern who misidentifies normal tissue as cancer. If the attending physician says, 'Whatever you do, be 100% decisive!', the intern assumes their mistake was correct and becomes aggressively overconfident. In the next room, they repeat the error with even higher confidence. Within two hours, the intern diagnoses every single patient on the floor with cancer. That is what entropy minimization does.</a:t>
+            </a:r>
+          </a:p>
+          <a:p/>
+          <a:p>
+            <a:r>
+              <a:t>KEY HIGHLIGHTS: 40.0% collapse rate on CAMELYON17; complete loss of diagnostic margins on Slide 29.</a:t>
             </a:r>
           </a:p>
         </p:txBody>
@@ -1430,7 +1716,29 @@
           <a:lstStyle/>
           <a:p>
             <a:r>
-              <a:t>In Section III of our manuscript, we formalize the exact mathematical root cause behind TTA collapse in Proposition 1. Through a second-order Taylor expansion, we show that predictive variance depends on the logit gradient, which scales as p times (1 minus p). When an overconfident network predicts probability near 1, this gradient vanishes. Our empirical tests confirm a devastating Spearman rank correlation of rho = -0.9917 between predictive entropy and epistemic uncertainty. This proves why entropy thresholds in methods like EATA and SAR fail: the network becomes maximally confident precisely when it is maximally damaged.</a:t>
+              <a:t>SPOKEN SCRIPT:</a:t>
+            </a:r>
+          </a:p>
+          <a:p>
+            <a:r>
+              <a:t>In Proposition 1, we prove the theoretical root cause: the Variance-Confidence Paradox. Through a second-order Taylor expansion, predictive variance depends directly on the logit gradient, which scales as p * (1 - p). As confidence approaches 1, this gradient vanishes quadratically! We measured the empirical rank correlation between epistemic weight variance (via MC-Dropout) and entropy: Spearman rho is -0.9917. The model outputs 99.8% confidence precisely when its epistemic uncertainty is at its maximum! That is why scalar confidence filters fail.</a:t>
+            </a:r>
+          </a:p>
+          <a:p/>
+          <a:p>
+            <a:r>
+              <a:t>REAL-WORLD ANALOGY:</a:t>
+            </a:r>
+          </a:p>
+          <a:p>
+            <a:r>
+              <a:t>The Dunning-Kruger Effect on an Exam: A student sits for a medical board exam without studying. Instead of leaving blanks, they mark option 'B' on all 200 questions with 100% confidence. Their predictive entropy is zero—they are totally decisive. But their actual knowledge is zero. If a system only checks how confident the student is, it gives them top marks for decisiveness while they fail the exam.</a:t>
+            </a:r>
+          </a:p>
+          <a:p/>
+          <a:p>
+            <a:r>
+              <a:t>KEY HIGHLIGHTS: Spearman rho = -0.9917; vanishing gradient formula grad p = p(1-p) grad z.</a:t>
             </a:r>
           </a:p>
         </p:txBody>
@@ -1500,7 +1808,29 @@
           <a:lstStyle/>
           <a:p>
             <a:r>
-              <a:t>To solve this challenge, we developed SafeAdapt, a deterministic, fail-closed test-time adaptation architecture. As shown in this architectural pipeline, SafeAdapt processes streaming whole-slide patches through four interlocking safeguards: First, a dual-stream architecture pairs a frozen source anchor with an adaptive student. Second, Sinkhorn Optimal Transport aligns feature marginals to source class prototypes. Third, Cross-Attention Memory Routing isolates staining debris into a slack channel. Fourth, a finite-sample conformal risk controller monitors adaptation quality, executing a sub-2ms rollback to the anchor if risk bounds are breached.</a:t>
+              <a:t>SPOKEN SCRIPT:</a:t>
+            </a:r>
+          </a:p>
+          <a:p>
+            <a:r>
+              <a:t>Here is our proposed solution: SafeAdapt. SafeAdapt replaces uncontrolled entropy minimization with four interlocking safeguards: 1) A Dual-Stream feature extractor pairing a frozen source anchor with an adaptive student; 2) Sinkhorn Optimal Transport to align feature marginals without label feedback; 3) Cross-Attention Memory Routing (CMR) to isolate staining artifacts into a slack channel; and 4) Finite-Sample Conformal Risk Control that triggers an instantaneous 1.8 ms GPU rollback if parameter drift breaches safety limits.</a:t>
+            </a:r>
+          </a:p>
+          <a:p/>
+          <a:p>
+            <a:r>
+              <a:t>REAL-WORLD ANALOGY:</a:t>
+            </a:r>
+          </a:p>
+          <a:p>
+            <a:r>
+              <a:t>Commercial Airliner Dual-Pilot Cockpit: You have a senior Captain (the frozen anchor) who knows the flight envelope. You have a First Officer (the adaptive student) who flies the plane and adjusts for wind shear. A flight computer (CMR) ignores weather radar noise. And an envelope protection system steps in: if the co-pilot banks the plane beyond 30 degrees, the flight computer instantly takes control and levels the wings.</a:t>
+            </a:r>
+          </a:p>
+          <a:p/>
+          <a:p>
+            <a:r>
+              <a:t>KEY HIGHLIGHTS: 4-stage pipeline; Dual-Stream separation of Frozen Anchor vs. Adaptive Student.</a:t>
             </a:r>
           </a:p>
         </p:txBody>
@@ -1570,7 +1900,29 @@
           <a:lstStyle/>
           <a:p>
             <a:r>
-              <a:t>Our first core mechanism replaces hazardous entropy minimization with entropy-regularized Sinkhorn Optimal Transport. We compute the pairwise Wasserstein distance between incoming patch embeddings and a frozen prototype dictionary. By enforcing uniform column marginal constraints, the optimal transport plan guarantees balanced prototype representation. Even if a patient slide has 99% benign tissue, the network cannot collapse into a single degenerate class. Using the Sinkhorn-Knopp algorithm, this requires fewer than 5 matrix-vector multiplications, executing in under 0.4 milliseconds.</a:t>
+              <a:t>SPOKEN SCRIPT:</a:t>
+            </a:r>
+          </a:p>
+          <a:p>
+            <a:r>
+              <a:t>Mechanism 1 replaces entropy minimization with Sinkhorn Optimal Transport. We compute the Wasserstein distance between incoming patch embeddings and a prototype dictionary of tissue classes. By enforcing uniform column marginal constraints, the optimal transport plan must allocate features across classes in balanced proportions. Even if a slide has 99% normal tissue, the uniform marginal constraint makes it mathematically impossible for the network to collapse into a single class attractor. It converges in under 5 matrix-vector multiplications in less than 0.4 ms on GPU.</a:t>
+            </a:r>
+          </a:p>
+          <a:p/>
+          <a:p>
+            <a:r>
+              <a:t>REAL-WORLD ANALOGY:</a:t>
+            </a:r>
+          </a:p>
+          <a:p>
+            <a:r>
+              <a:t>Fair Logistics Dispatcher: If a regional dispatcher has 100 trucks and 5 warehouses, an uncontrolled system might route all 100 trucks to one warehouse because it's slightly closer, causing massive gridlock. Sinkhorn Optimal Transport enforces strict capacity constraints: Warehouse 1 takes 20 trucks, Warehouse 2 takes 20, guaranteeing efficient matching while preventing systemic overload.</a:t>
+            </a:r>
+          </a:p>
+          <a:p/>
+          <a:p>
+            <a:r>
+              <a:t>KEY HIGHLIGHTS: &lt;0.4 ms GPU execution; +8.1% AUROC gain from OT alignment alone.</a:t>
             </a:r>
           </a:p>
         </p:txBody>
@@ -1640,7 +1992,29 @@
           <a:lstStyle/>
           <a:p>
             <a:r>
-              <a:t>Our second mechanism is Cross-Attention Memory-Augmented Routing, or CMR. Real clinical slides are messy: they contain surgical ink, air bubbles, folded tissue edges, and necrotic debris. If a model tries to adapt on these artifacts, its parameters drift rapidly. CMR introduces an episodic key-value memory bank and an explicit slack prototype channel. Features that do not match authentic tissue are routed into the slack channel, absorbing non-neoplastic noise and preventing distortive gradients from polluting diagnostic prototypes.</a:t>
+              <a:t>SPOKEN SCRIPT:</a:t>
+            </a:r>
+          </a:p>
+          <a:p>
+            <a:r>
+              <a:t>Mechanism 2 is Cross-Attention Memory-Augmented Routing (CMR). Clinical slides contain pen marks (surgical ink), tissue folds, air bubbles under the coverslip, and cautery burns. A standard model confuses dark ink with aggressive tumor pigment, corrupting its updates. CMR maintains an episodic memory bank of validated source features. When streaming patches have near-zero cosine similarity with real tissue, CMR routes them into an explicit slack prototype channel, preventing distorted gradients from polluting diagnostic prototypes.</a:t>
+            </a:r>
+          </a:p>
+          <a:p/>
+          <a:p>
+            <a:r>
+              <a:t>REAL-WORLD ANALOGY:</a:t>
+            </a:r>
+          </a:p>
+          <a:p>
+            <a:r>
+              <a:t>Security Bouncer with a VIP Coatroom: At an exclusive medical conference, only badge-holding oncologists are allowed to vote. If someone walks in off the street in a costume (surgical ink or an air bubble), the bouncer courteously steers them into the coatroom lounge (the slack channel). They can stay there safely, but they cannot vote on clinical decisions.</a:t>
+            </a:r>
+          </a:p>
+          <a:p/>
+          <a:p>
+            <a:r>
+              <a:t>KEY HIGHLIGHTS: -38.4% false-positive patch activations; +2.2% AUROC boost.</a:t>
             </a:r>
           </a:p>
         </p:txBody>
@@ -1710,7 +2084,29 @@
           <a:lstStyle/>
           <a:p>
             <a:r>
-              <a:t>Our third mechanism provides finite-sample statistical safety through Conformal Risk Control, formalized in Theorem 1. We track non-conformity scores across streaming batches to bound the probability of clinical error below a user-selected significance level alpha, typically 0.05. This guarantee is distribution-free and requires no parametric assumptions. If cumulative risk breaches this threshold, an emergency interlock triggers an instantaneous 1.8 millisecond GPU parameter rollback to the certified anchor state theta_0. This fail-closed architecture guarantees zero catastrophic collapse.</a:t>
+              <a:t>SPOKEN SCRIPT:</a:t>
+            </a:r>
+          </a:p>
+          <a:p>
+            <a:r>
+              <a:t>Mechanism 3 provides statistical safety via Finite-Sample Conformal Risk Control (Theorem 1). We compute non-conformity scores on streaming batches to bound clinical risk: P(R(theta_t) &lt;= alpha) &gt;= 1 - delta. This holds strictly without parametric assumptions on target scanners. We track the moving variance of conformal p-values. If empirical risk breaches alpha = 0.05, the adaptation controller trips a safety interlock, restoring anchor parameters theta_0 in 1.8 milliseconds from GPU memory without stalling the WSI queue.</a:t>
+            </a:r>
+          </a:p>
+          <a:p/>
+          <a:p>
+            <a:r>
+              <a:t>REAL-WORLD ANALOGY:</a:t>
+            </a:r>
+          </a:p>
+          <a:p>
+            <a:r>
+              <a:t>High-Speed Factory Circuit Breaker: In a bottling plant, if an infrared sensor detects bottle caps deviating by 0.5 mm, an ultra-fast arm diverts the defective bottle in 2 ms while the main conveyor belt keeps running at full speed. Our conformal rollback detects parameter drift before diagnostic harm occurs and resets weights in 1.8 milliseconds.</a:t>
+            </a:r>
+          </a:p>
+          <a:p/>
+          <a:p>
+            <a:r>
+              <a:t>KEY HIGHLIGHTS: Theorem 1 distribution-free bound; 1.8 ms sub-frame rollback.</a:t>
             </a:r>
           </a:p>
         </p:txBody>
@@ -1780,7 +2176,29 @@
           <a:lstStyle/>
           <a:p>
             <a:r>
-              <a:t>To rigorously evaluate SafeAdapt, we benchmarked across two challenging international multicenter datasets: CAMELYON17, comprising 50 whole-slide images across 5 university medical centers, and the MIDOG 2021 challenge for cross-scanner and cross-species mitosis detection. We compared SafeAdapt against 8 competing paradigms, including classical vision TTA like Tent, EATA, and SAR, continual methods like CoTTA and RoTTA, and augmentation methods like MEMO, across 5 random seeds to rigorously capture collapse behaviors.</a:t>
+              <a:t>SPOKEN SCRIPT:</a:t>
+            </a:r>
+          </a:p>
+          <a:p>
+            <a:r>
+              <a:t>To rigorously evaluate SafeAdapt, we benchmarked across two premier multicenter datasets: CAMELYON17 (50 whole slides across 5 university medical centers in the Netherlands: Radboud, Utrecht, Rijnstate, CWZ, Groningen) and MIDOG 2021 (cross-scanner mitosis detection across 4 digitizers and multi-species tissue). We compared against 8 baselines spanning classical TTA (Tent, EATA, SAR), continual TTA (CoTTA, RoTTA), and augmentation (MEMO), across 5 random seeds to capture non-deterministic collapse.</a:t>
+            </a:r>
+          </a:p>
+          <a:p/>
+          <a:p>
+            <a:r>
+              <a:t>REAL-WORLD ANALOGY:</a:t>
+            </a:r>
+          </a:p>
+          <a:p>
+            <a:r>
+              <a:t>Multi-Center Drug Clinical Trials: If a pharmaceutical company tests a drug only on 20 healthy volunteers in their own lab, the FDA rejects it. A real clinical trial must test across 5 independent hospitals with diverse patient populations. CAMELYON17 represents a true multi-center trial across 5 hospital systems to ensure our AI works across any hospital scanner.</a:t>
+            </a:r>
+          </a:p>
+          <a:p/>
+          <a:p>
+            <a:r>
+              <a:t>KEY HIGHLIGHTS: 5 independent university medical centers; 8 competing adaptation baselines.</a:t>
             </a:r>
           </a:p>
         </p:txBody>

</xml_diff>